<commit_message>
Run E1b and E3, add abstention handling, department formatting conventions
- E1b (RAG with the full note) and E3 (RAG + Chain-of-Verification) generated and evaluated;
  E3 checkpointed with --revise-only; keep/replace/remove revision instructions; result
  files re-read before writing to avoid overwriting a concurrently finished run
- preprocessing.is_abstention: explicit "Not stated in the note" lines excluded from the claim
  set (41 of 42 were labeled Contradicted by the judge)
- ablations/analyze generalized to all conditions; five-generator pipeline figure
- thesis: per-chapter table/figure numbering, "Chapter N Title" headings, Bibliography,
  American spelling, results/discussion/conclusion/abstract for five conditions,
  table widths clamped to the text width, no stray blank pages
- slides and description updated for five conditions

Co-Authored-By: Claude Fable 5.1 <noreply@anthropic.com>
</commit_message>
<xml_diff>
--- a/deliverables/Progress_Slides_Fall2026.pptx
+++ b/deliverables/Progress_Slides_Fall2026.pptx
@@ -3313,7 +3313,7 @@
         <p:spPr>
           <a:xfrm>
             <a:off x="365760" y="1097280"/>
-            <a:ext cx="5577840" cy="2702287"/>
+            <a:ext cx="5577840" cy="3315383"/>
           </a:xfrm>
           <a:prstGeom prst="rect">
             <a:avLst/>
@@ -3420,7 +3420,7 @@
             </a:pPr>
             <a:r>
               <a:rPr sz="1600"/>
-              <a:t>• Complete draft generated from the result files: 95 pages in CSUN format (1-inch margins, 12-pt Times New Roman, double-spaced, roman-numbered preliminary pages, arabic body)</a:t>
+              <a:t>• Complete draft generated from the result files: 107 pages in CSUN format (1-inch margins, 12-pt Times New Roman, double-spaced, roman-numbered preliminary pages, arabic body)</a:t>
             </a:r>
           </a:p>
           <a:p>
@@ -3442,7 +3442,7 @@
             </a:pPr>
             <a:r>
               <a:rPr sz="1600"/>
-              <a:t>• New content since May: header-filter correction, judge validation against expert annotations, five aggregation variants, threshold/top-k/cleaned-evidence ablations, coverage proxy, negation analysis, error taxonomy, ethics and governance section</a:t>
+              <a:t>• New content since May: two new conditions (E1b, E3), header-filter correction, judge validation against expert annotations, five aggregation variants, threshold/top-k/cleaned-evidence ablations, coverage proxy, negation analysis, error taxonomy, ethics and governance section</a:t>
             </a:r>
           </a:p>
           <a:p>
@@ -3615,7 +3615,7 @@
                     <a:p>
                       <a:r>
                         <a:rPr sz="1000" b="0"/>
-                        <a:t>Run E1b and E3 (API access), re-run recomputation and rebuild; optional MIMIC re-run with a local open-weight generator</a:t>
+                        <a:t>Sampling-variance runs (several generations per note) if API budget allows; optional MIMIC re-run with a local open-weight generator</a:t>
                       </a:r>
                     </a:p>
                   </a:txBody>
@@ -3910,17 +3910,6 @@
             </a:pPr>
             <a:r>
               <a:rPr sz="1600"/>
-              <a:t>• API access for E1b and E3: about 550 GPT-4o-mini calls (under one dollar); needs an OPENAI_API_KEY on the build machine</a:t>
-            </a:r>
-          </a:p>
-          <a:p>
-            <a:pPr>
-              <a:spcAft>
-                <a:spcPts val="800"/>
-              </a:spcAft>
-            </a:pPr>
-            <a:r>
-              <a:rPr sz="1600"/>
               <a:t>• MIMIC generation: requires a zero-data-retention agreement or a local open-weight model; kept optional</a:t>
             </a:r>
           </a:p>
@@ -4068,7 +4057,7 @@
             </a:pPr>
             <a:r>
               <a:rPr sz="1600"/>
-              <a:t>• Three approaches compared on 50 MTSamples notes: E0 zero-context LLM, E1 RAG (excerpts only), E2 centroid extractive</a:t>
+              <a:t>• Five conditions compared on 50 MTSamples notes: E0 zero-context LLM, E1 RAG (excerpts only), E1b RAG (note + excerpts), E3 RAG + Chain-of-Verification, E2 centroid extractive</a:t>
             </a:r>
           </a:p>
           <a:p>
@@ -4148,7 +4137,7 @@
         <p:spPr>
           <a:xfrm>
             <a:off x="365760" y="1097280"/>
-            <a:ext cx="11430000" cy="6015789"/>
+            <a:ext cx="11430000" cy="7100455"/>
           </a:xfrm>
           <a:prstGeom prst="rect">
             <a:avLst/>
@@ -4260,7 +4249,7 @@
             </a:pPr>
             <a:r>
               <a:rPr sz="1600"/>
-              <a:t>• MTSamples (public): 4,999 transcriptions, 624 eligible consult and discharge notes, 50 sampled (seed 42); 1,211 claims labelled</a:t>
+              <a:t>• MTSamples (public): 4,999 transcriptions, 624 eligible consult and discharge notes, 50 sampled (seed 42); 2,016 claims labeled</a:t>
             </a:r>
           </a:p>
           <a:p>
@@ -4671,7 +4660,7 @@
           <a:p>
             <a:r>
               <a:rPr sz="2800" b="1"/>
-              <a:t>Main results (n = 50 documents, header lines excluded)</a:t>
+              <a:t>Main results (n = 50 documents; header lines and abstentions excluded)</a:t>
             </a:r>
           </a:p>
         </p:txBody>
@@ -4686,7 +4675,7 @@
         </p:nvGraphicFramePr>
         <p:xfrm>
           <a:off x="365760" y="1097280"/>
-          <a:ext cx="11429997" cy="2194560"/>
+          <a:ext cx="11429998" cy="2560320"/>
         </p:xfrm>
         <a:graphic>
           <a:graphicData uri="http://schemas.openxmlformats.org/drawingml/2006/table">
@@ -4695,12 +4684,12 @@
                 <a:tableStyleId>{5C22544A-7EE6-4342-B048-85BDC9FD1C3A}</a:tableStyleId>
               </a:tblPr>
               <a:tblGrid>
-                <a:gridCol w="2456033"/>
-                <a:gridCol w="1511404"/>
-                <a:gridCol w="1322479"/>
-                <a:gridCol w="1511404"/>
-                <a:gridCol w="2739421"/>
-                <a:gridCol w="1889256"/>
+                <a:gridCol w="2799183"/>
+                <a:gridCol w="1726163"/>
+                <a:gridCol w="1726163"/>
+                <a:gridCol w="1726163"/>
+                <a:gridCol w="1726163"/>
+                <a:gridCol w="1726163"/>
               </a:tblGrid>
               <a:tr h="365760">
                 <a:tc>
@@ -4736,7 +4725,33 @@
                     <a:p>
                       <a:r>
                         <a:rPr sz="1100" b="1"/>
-                        <a:t>E1 RAG</a:t>
+                        <a:t>E1 RAG excerpts</a:t>
+                      </a:r>
+                    </a:p>
+                  </a:txBody>
+                  <a:tcPr/>
+                </a:tc>
+                <a:tc>
+                  <a:txBody>
+                    <a:bodyPr/>
+                    <a:lstStyle/>
+                    <a:p>
+                      <a:r>
+                        <a:rPr sz="1100" b="1"/>
+                        <a:t>E1b RAG + note</a:t>
+                      </a:r>
+                    </a:p>
+                  </a:txBody>
+                  <a:tcPr/>
+                </a:tc>
+                <a:tc>
+                  <a:txBody>
+                    <a:bodyPr/>
+                    <a:lstStyle/>
+                    <a:p>
+                      <a:r>
+                        <a:rPr sz="1100" b="1"/>
+                        <a:t>E3 RAG + CoVe</a:t>
                       </a:r>
                     </a:p>
                   </a:txBody>
@@ -4755,32 +4770,6 @@
                   </a:txBody>
                   <a:tcPr/>
                 </a:tc>
-                <a:tc>
-                  <a:txBody>
-                    <a:bodyPr/>
-                    <a:lstStyle/>
-                    <a:p>
-                      <a:r>
-                        <a:rPr sz="1100" b="1"/>
-                        <a:t>E1 vs E0</a:t>
-                      </a:r>
-                    </a:p>
-                  </a:txBody>
-                  <a:tcPr/>
-                </a:tc>
-                <a:tc>
-                  <a:txBody>
-                    <a:bodyPr/>
-                    <a:lstStyle/>
-                    <a:p>
-                      <a:r>
-                        <a:rPr sz="1100" b="1"/>
-                        <a:t>E2 vs E0</a:t>
-                      </a:r>
-                    </a:p>
-                  </a:txBody>
-                  <a:tcPr/>
-                </a:tc>
               </a:tr>
               <a:tr h="365760">
                 <a:tc>
@@ -4829,33 +4818,33 @@
                     <a:p>
                       <a:r>
                         <a:rPr sz="1000" b="0"/>
+                        <a:t>0.759</a:t>
+                      </a:r>
+                    </a:p>
+                  </a:txBody>
+                  <a:tcPr/>
+                </a:tc>
+                <a:tc>
+                  <a:txBody>
+                    <a:bodyPr/>
+                    <a:lstStyle/>
+                    <a:p>
+                      <a:r>
+                        <a:rPr sz="1000" b="0"/>
+                        <a:t>0.688</a:t>
+                      </a:r>
+                    </a:p>
+                  </a:txBody>
+                  <a:tcPr/>
+                </a:tc>
+                <a:tc>
+                  <a:txBody>
+                    <a:bodyPr/>
+                    <a:lstStyle/>
+                    <a:p>
+                      <a:r>
+                        <a:rPr sz="1000" b="0"/>
                         <a:t>0.122</a:t>
-                      </a:r>
-                    </a:p>
-                  </a:txBody>
-                  <a:tcPr/>
-                </a:tc>
-                <a:tc>
-                  <a:txBody>
-                    <a:bodyPr/>
-                    <a:lstStyle/>
-                    <a:p>
-                      <a:r>
-                        <a:rPr sz="1000" b="0"/>
-                        <a:t>-0.004, p = 0.977</a:t>
-                      </a:r>
-                    </a:p>
-                  </a:txBody>
-                  <a:tcPr/>
-                </a:tc>
-                <a:tc>
-                  <a:txBody>
-                    <a:bodyPr/>
-                    <a:lstStyle/>
-                    <a:p>
-                      <a:r>
-                        <a:rPr sz="1000" b="0"/>
-                        <a:t>-0.689, p &lt; 0.001</a:t>
                       </a:r>
                     </a:p>
                   </a:txBody>
@@ -4909,33 +4898,33 @@
                     <a:p>
                       <a:r>
                         <a:rPr sz="1000" b="0"/>
+                        <a:t>0.148</a:t>
+                      </a:r>
+                    </a:p>
+                  </a:txBody>
+                  <a:tcPr/>
+                </a:tc>
+                <a:tc>
+                  <a:txBody>
+                    <a:bodyPr/>
+                    <a:lstStyle/>
+                    <a:p>
+                      <a:r>
+                        <a:rPr sz="1000" b="0"/>
+                        <a:t>0.164</a:t>
+                      </a:r>
+                    </a:p>
+                  </a:txBody>
+                  <a:tcPr/>
+                </a:tc>
+                <a:tc>
+                  <a:txBody>
+                    <a:bodyPr/>
+                    <a:lstStyle/>
+                    <a:p>
+                      <a:r>
+                        <a:rPr sz="1000" b="0"/>
                         <a:t>0.096</a:t>
-                      </a:r>
-                    </a:p>
-                  </a:txBody>
-                  <a:tcPr/>
-                </a:tc>
-                <a:tc>
-                  <a:txBody>
-                    <a:bodyPr/>
-                    <a:lstStyle/>
-                    <a:p>
-                      <a:r>
-                        <a:rPr sz="1000" b="0"/>
-                        <a:t>-0.042 (24% rel.), p = 0.011, Holm p = 0.034</a:t>
-                      </a:r>
-                    </a:p>
-                  </a:txBody>
-                  <a:tcPr/>
-                </a:tc>
-                <a:tc>
-                  <a:txBody>
-                    <a:bodyPr/>
-                    <a:lstStyle/>
-                    <a:p>
-                      <a:r>
-                        <a:rPr sz="1000" b="0"/>
-                        <a:t>-0.076, p = 0.003</a:t>
                       </a:r>
                     </a:p>
                   </a:txBody>
@@ -4950,72 +4939,72 @@
                     <a:p>
                       <a:r>
                         <a:rPr sz="1000" b="0"/>
-                        <a:t>Documents improved (CR)</a:t>
-                      </a:r>
-                    </a:p>
-                  </a:txBody>
-                  <a:tcPr/>
-                </a:tc>
-                <a:tc>
-                  <a:txBody>
-                    <a:bodyPr/>
-                    <a:lstStyle/>
-                    <a:p>
-                      <a:r>
-                        <a:rPr sz="1000" b="0"/>
-                        <a:t>—</a:t>
-                      </a:r>
-                    </a:p>
-                  </a:txBody>
-                  <a:tcPr/>
-                </a:tc>
-                <a:tc>
-                  <a:txBody>
-                    <a:bodyPr/>
-                    <a:lstStyle/>
-                    <a:p>
-                      <a:r>
-                        <a:rPr sz="1000" b="0"/>
-                        <a:t>64%</a:t>
-                      </a:r>
-                    </a:p>
-                  </a:txBody>
-                  <a:tcPr/>
-                </a:tc>
-                <a:tc>
-                  <a:txBody>
-                    <a:bodyPr/>
-                    <a:lstStyle/>
-                    <a:p>
-                      <a:r>
-                        <a:rPr sz="1000" b="0"/>
-                        <a:t>66%</a:t>
-                      </a:r>
-                    </a:p>
-                  </a:txBody>
-                  <a:tcPr/>
-                </a:tc>
-                <a:tc>
-                  <a:txBody>
-                    <a:bodyPr/>
-                    <a:lstStyle/>
-                    <a:p>
-                      <a:r>
-                        <a:rPr sz="1000" b="0"/>
-                        <a:t>d(z) = -0.34</a:t>
-                      </a:r>
-                    </a:p>
-                  </a:txBody>
-                  <a:tcPr/>
-                </a:tc>
-                <a:tc>
-                  <a:txBody>
-                    <a:bodyPr/>
-                    <a:lstStyle/>
-                    <a:p>
-                      <a:r>
-                        <a:rPr sz="1000" b="0"/>
-                        <a:t>d(z) = -0.41</a:t>
+                        <a:t>Supported share of claims</a:t>
+                      </a:r>
+                    </a:p>
+                  </a:txBody>
+                  <a:tcPr/>
+                </a:tc>
+                <a:tc>
+                  <a:txBody>
+                    <a:bodyPr/>
+                    <a:lstStyle/>
+                    <a:p>
+                      <a:r>
+                        <a:rPr sz="1000" b="0"/>
+                        <a:t>19%</a:t>
+                      </a:r>
+                    </a:p>
+                  </a:txBody>
+                  <a:tcPr/>
+                </a:tc>
+                <a:tc>
+                  <a:txBody>
+                    <a:bodyPr/>
+                    <a:lstStyle/>
+                    <a:p>
+                      <a:r>
+                        <a:rPr sz="1000" b="0"/>
+                        <a:t>20%</a:t>
+                      </a:r>
+                    </a:p>
+                  </a:txBody>
+                  <a:tcPr/>
+                </a:tc>
+                <a:tc>
+                  <a:txBody>
+                    <a:bodyPr/>
+                    <a:lstStyle/>
+                    <a:p>
+                      <a:r>
+                        <a:rPr sz="1000" b="0"/>
+                        <a:t>24%</a:t>
+                      </a:r>
+                    </a:p>
+                  </a:txBody>
+                  <a:tcPr/>
+                </a:tc>
+                <a:tc>
+                  <a:txBody>
+                    <a:bodyPr/>
+                    <a:lstStyle/>
+                    <a:p>
+                      <a:r>
+                        <a:rPr sz="1000" b="0"/>
+                        <a:t>33%</a:t>
+                      </a:r>
+                    </a:p>
+                  </a:txBody>
+                  <a:tcPr/>
+                </a:tc>
+                <a:tc>
+                  <a:txBody>
+                    <a:bodyPr/>
+                    <a:lstStyle/>
+                    <a:p>
+                      <a:r>
+                        <a:rPr sz="1000" b="0"/>
+                        <a:t>89%</a:t>
                       </a:r>
                     </a:p>
                   </a:txBody>
@@ -5030,72 +5019,72 @@
                     <a:p>
                       <a:r>
                         <a:rPr sz="1000" b="0"/>
-                        <a:t>Words per summary</a:t>
-                      </a:r>
-                    </a:p>
-                  </a:txBody>
-                  <a:tcPr/>
-                </a:tc>
-                <a:tc>
-                  <a:txBody>
-                    <a:bodyPr/>
-                    <a:lstStyle/>
-                    <a:p>
-                      <a:r>
-                        <a:rPr sz="1000" b="0"/>
-                        <a:t>182</a:t>
-                      </a:r>
-                    </a:p>
-                  </a:txBody>
-                  <a:tcPr/>
-                </a:tc>
-                <a:tc>
-                  <a:txBody>
-                    <a:bodyPr/>
-                    <a:lstStyle/>
-                    <a:p>
-                      <a:r>
-                        <a:rPr sz="1000" b="0"/>
-                        <a:t>156</a:t>
-                      </a:r>
-                    </a:p>
-                  </a:txBody>
-                  <a:tcPr/>
-                </a:tc>
-                <a:tc>
-                  <a:txBody>
-                    <a:bodyPr/>
-                    <a:lstStyle/>
-                    <a:p>
-                      <a:r>
-                        <a:rPr sz="1000" b="0"/>
-                        <a:t>69</a:t>
-                      </a:r>
-                    </a:p>
-                  </a:txBody>
-                  <a:tcPr/>
-                </a:tc>
-                <a:tc>
-                  <a:txBody>
-                    <a:bodyPr/>
-                    <a:lstStyle/>
-                    <a:p>
-                      <a:r>
-                        <a:rPr sz="1000" b="0"/>
-                        <a:t> </a:t>
-                      </a:r>
-                    </a:p>
-                  </a:txBody>
-                  <a:tcPr/>
-                </a:tc>
-                <a:tc>
-                  <a:txBody>
-                    <a:bodyPr/>
-                    <a:lstStyle/>
-                    <a:p>
-                      <a:r>
-                        <a:rPr sz="1000" b="0"/>
-                        <a:t> </a:t>
+                        <a:t>Claims per summary</a:t>
+                      </a:r>
+                    </a:p>
+                  </a:txBody>
+                  <a:tcPr/>
+                </a:tc>
+                <a:tc>
+                  <a:txBody>
+                    <a:bodyPr/>
+                    <a:lstStyle/>
+                    <a:p>
+                      <a:r>
+                        <a:rPr sz="1000" b="0"/>
+                        <a:t>10.4</a:t>
+                      </a:r>
+                    </a:p>
+                  </a:txBody>
+                  <a:tcPr/>
+                </a:tc>
+                <a:tc>
+                  <a:txBody>
+                    <a:bodyPr/>
+                    <a:lstStyle/>
+                    <a:p>
+                      <a:r>
+                        <a:rPr sz="1000" b="0"/>
+                        <a:t>8.9</a:t>
+                      </a:r>
+                    </a:p>
+                  </a:txBody>
+                  <a:tcPr/>
+                </a:tc>
+                <a:tc>
+                  <a:txBody>
+                    <a:bodyPr/>
+                    <a:lstStyle/>
+                    <a:p>
+                      <a:r>
+                        <a:rPr sz="1000" b="0"/>
+                        <a:t>10.2</a:t>
+                      </a:r>
+                    </a:p>
+                  </a:txBody>
+                  <a:tcPr/>
+                </a:tc>
+                <a:tc>
+                  <a:txBody>
+                    <a:bodyPr/>
+                    <a:lstStyle/>
+                    <a:p>
+                      <a:r>
+                        <a:rPr sz="1000" b="0"/>
+                        <a:t>5.9</a:t>
+                      </a:r>
+                    </a:p>
+                  </a:txBody>
+                  <a:tcPr/>
+                </a:tc>
+                <a:tc>
+                  <a:txBody>
+                    <a:bodyPr/>
+                    <a:lstStyle/>
+                    <a:p>
+                      <a:r>
+                        <a:rPr sz="1000" b="0"/>
+                        <a:t>4.8</a:t>
                       </a:r>
                     </a:p>
                   </a:txBody>
@@ -5110,6 +5099,86 @@
                     <a:p>
                       <a:r>
                         <a:rPr sz="1000" b="0"/>
+                        <a:t>Words per summary</a:t>
+                      </a:r>
+                    </a:p>
+                  </a:txBody>
+                  <a:tcPr/>
+                </a:tc>
+                <a:tc>
+                  <a:txBody>
+                    <a:bodyPr/>
+                    <a:lstStyle/>
+                    <a:p>
+                      <a:r>
+                        <a:rPr sz="1000" b="0"/>
+                        <a:t>182</a:t>
+                      </a:r>
+                    </a:p>
+                  </a:txBody>
+                  <a:tcPr/>
+                </a:tc>
+                <a:tc>
+                  <a:txBody>
+                    <a:bodyPr/>
+                    <a:lstStyle/>
+                    <a:p>
+                      <a:r>
+                        <a:rPr sz="1000" b="0"/>
+                        <a:t>156</a:t>
+                      </a:r>
+                    </a:p>
+                  </a:txBody>
+                  <a:tcPr/>
+                </a:tc>
+                <a:tc>
+                  <a:txBody>
+                    <a:bodyPr/>
+                    <a:lstStyle/>
+                    <a:p>
+                      <a:r>
+                        <a:rPr sz="1000" b="0"/>
+                        <a:t>180</a:t>
+                      </a:r>
+                    </a:p>
+                  </a:txBody>
+                  <a:tcPr/>
+                </a:tc>
+                <a:tc>
+                  <a:txBody>
+                    <a:bodyPr/>
+                    <a:lstStyle/>
+                    <a:p>
+                      <a:r>
+                        <a:rPr sz="1000" b="0"/>
+                        <a:t>120</a:t>
+                      </a:r>
+                    </a:p>
+                  </a:txBody>
+                  <a:tcPr/>
+                </a:tc>
+                <a:tc>
+                  <a:txBody>
+                    <a:bodyPr/>
+                    <a:lstStyle/>
+                    <a:p>
+                      <a:r>
+                        <a:rPr sz="1000" b="0"/>
+                        <a:t>69</a:t>
+                      </a:r>
+                    </a:p>
+                  </a:txBody>
+                  <a:tcPr/>
+                </a:tc>
+              </a:tr>
+              <a:tr h="365760">
+                <a:tc>
+                  <a:txBody>
+                    <a:bodyPr/>
+                    <a:lstStyle/>
+                    <a:p>
+                      <a:r>
+                        <a:rPr sz="1000" b="0"/>
                         <a:t>Coverage of source sentences (cos ≥ 0.6)</a:t>
                       </a:r>
                     </a:p>
@@ -5149,33 +5218,33 @@
                     <a:p>
                       <a:r>
                         <a:rPr sz="1000" b="0"/>
+                        <a:t>18.5%</a:t>
+                      </a:r>
+                    </a:p>
+                  </a:txBody>
+                  <a:tcPr/>
+                </a:tc>
+                <a:tc>
+                  <a:txBody>
+                    <a:bodyPr/>
+                    <a:lstStyle/>
+                    <a:p>
+                      <a:r>
+                        <a:rPr sz="1000" b="0"/>
+                        <a:t>16.6%</a:t>
+                      </a:r>
+                    </a:p>
+                  </a:txBody>
+                  <a:tcPr/>
+                </a:tc>
+                <a:tc>
+                  <a:txBody>
+                    <a:bodyPr/>
+                    <a:lstStyle/>
+                    <a:p>
+                      <a:r>
+                        <a:rPr sz="1000" b="0"/>
                         <a:t>18.3%</a:t>
-                      </a:r>
-                    </a:p>
-                  </a:txBody>
-                  <a:tcPr/>
-                </a:tc>
-                <a:tc>
-                  <a:txBody>
-                    <a:bodyPr/>
-                    <a:lstStyle/>
-                    <a:p>
-                      <a:r>
-                        <a:rPr sz="1000" b="0"/>
-                        <a:t>p = 0.010</a:t>
-                      </a:r>
-                    </a:p>
-                  </a:txBody>
-                  <a:tcPr/>
-                </a:tc>
-                <a:tc>
-                  <a:txBody>
-                    <a:bodyPr/>
-                    <a:lstStyle/>
-                    <a:p>
-                      <a:r>
-                        <a:rPr sz="1000" b="0"/>
-                        <a:t>p = 0.244</a:t>
                       </a:r>
                     </a:p>
                   </a:txBody>
@@ -5210,7 +5279,7 @@
           <a:p>
             <a:r>
               <a:rPr sz="1200"/>
-              <a:t>RAG lowers the judge's contradiction rate modestly and leaves the unsupported-fact rate unchanged; the extractive bound has a non-zero error floor.</a:t>
+              <a:t>Paired Wilcoxon versus E0: E1 CR p = 0.011 (−24%), E1 UFR p = 0.977; E1b UFR p = 0.020; E3 UFR p &lt; 0.001 (−15%; versus E1 p &lt; 0.001), E3 CR p = 0.913; E2 UFR p &lt; 0.001. Verification lowers unsupported facts the most, by deleting claims and abstaining; retrieval alone lowers contradictions modestly; the extractive bound has a non-zero judge error floor.</a:t>
             </a:r>
           </a:p>
         </p:txBody>
@@ -5303,7 +5372,7 @@
         <p:spPr>
           <a:xfrm>
             <a:off x="6217920" y="1097280"/>
-            <a:ext cx="5577840" cy="3005101"/>
+            <a:ext cx="5577840" cy="5396649"/>
           </a:xfrm>
           <a:prstGeom prst="rect">
             <a:avLst/>

</xml_diff>

<commit_message>
Remove committee placeholders pending discussion with advisor
Co-Authored-By: Claude Fable 5.1 <noreply@anthropic.com>
</commit_message>
<xml_diff>
--- a/deliverables/Progress_Slides_Fall2026.pptx
+++ b/deliverables/Progress_Slides_Fall2026.pptx
@@ -3149,7 +3149,7 @@
           <a:p>
             <a:r>
               <a:rPr sz="1800"/>
-              <a:t>California State University, Northridge, September 14, 2026</a:t>
+              <a:t>California State University, Northridge, September 15, 2026</a:t>
             </a:r>
           </a:p>
         </p:txBody>
@@ -3453,7 +3453,7 @@
             </a:pPr>
             <a:r>
               <a:rPr sz="1600"/>
-              <a:t>• Open items: committee member names on the signature page; advisor review; title alignment with the ETD planning form (question answering removed from scope)</a:t>
+              <a:t>• Open items: committee composition to be confirmed with the advisor; advisor review of the draft; title alignment with the ETD planning form (question answering removed from scope)</a:t>
             </a:r>
           </a:p>
           <a:p>
@@ -3587,7 +3587,7 @@
                     <a:p>
                       <a:r>
                         <a:rPr sz="1000" b="0"/>
-                        <a:t>Advisor review of this complete draft; committee names confirmed</a:t>
+                        <a:t>Advisor review of this complete draft; committee composition discussed</a:t>
                       </a:r>
                     </a:p>
                   </a:txBody>
@@ -3932,7 +3932,7 @@
             </a:pPr>
             <a:r>
               <a:rPr sz="1600"/>
-              <a:t>• Request to advisor: confirm committee members, review the complete draft, and advise on the title change</a:t>
+              <a:t>• Request to advisor: review the complete draft, discuss the committee, and advise on the title change</a:t>
             </a:r>
           </a:p>
         </p:txBody>

</xml_diff>

<commit_message>
Prepare thesis, slides and description for the main-study results
- mimic_results.py access layer; ch_mimic wording generators; ch_judge short names and table
  widths; ch8_9 limitations, implications and future work rewritten for both studies and the
  comparison table gains main-study columns
- finetune_mednli.py: Adafactor option, gradient accumulation, frozen embedding block
  (works around a NaN gradient on the MPS backend), non-finite-loss guard
- mimic_generate.py: client timeout and no silent empty outputs
- appendices A.5/A.6 and D, README, run.sh --main-study, source description, Adafactor reference

Co-Authored-By: Claude Fable 5.1 <noreply@anthropic.com>
</commit_message>
<xml_diff>
--- a/deliverables/Progress_Slides_Fall2026.pptx
+++ b/deliverables/Progress_Slides_Fall2026.pptx
@@ -3196,59 +3196,100 @@
           <a:p>
             <a:r>
               <a:rPr sz="2800" b="1"/>
-              <a:t>Robustness: the RAG effect holds only at the default threshold</a:t>
-            </a:r>
-          </a:p>
-        </p:txBody>
-      </p:sp>
-      <p:pic>
-        <p:nvPicPr>
-          <p:cNvPr id="3" name="Picture 2" descr="fig_threshold_ablation.png"/>
-          <p:cNvPicPr>
-            <a:picLocks noChangeAspect="1"/>
-          </p:cNvPicPr>
+              <a:t>Main study design: MIMIC-IV hospital courses</a:t>
+            </a:r>
+          </a:p>
+        </p:txBody>
+      </p:sp>
+      <p:sp>
+        <p:nvSpPr>
+          <p:cNvPr id="3" name="TextBox 2"/>
+          <p:cNvSpPr txBox="1"/>
           <p:nvPr/>
-        </p:nvPicPr>
-        <p:blipFill>
-          <a:blip r:embed="rId2"/>
-          <a:stretch>
-            <a:fillRect/>
-          </a:stretch>
-        </p:blipFill>
+        </p:nvSpPr>
         <p:spPr>
           <a:xfrm>
-            <a:off x="365760" y="1097280"/>
-            <a:ext cx="5577840" cy="2542789"/>
+            <a:off x="457200" y="1097280"/>
+            <a:ext cx="11247120" cy="5303520"/>
           </a:xfrm>
           <a:prstGeom prst="rect">
             <a:avLst/>
           </a:prstGeom>
+          <a:noFill/>
         </p:spPr>
-      </p:pic>
-      <p:pic>
-        <p:nvPicPr>
-          <p:cNvPr id="4" name="Picture 3" descr="fig_topk_ablation.png"/>
-          <p:cNvPicPr>
-            <a:picLocks noChangeAspect="1"/>
-          </p:cNvPicPr>
-          <p:nvPr/>
-        </p:nvPicPr>
-        <p:blipFill>
-          <a:blip r:embed="rId3"/>
-          <a:stretch>
-            <a:fillRect/>
-          </a:stretch>
-        </p:blipFill>
-        <p:spPr>
-          <a:xfrm>
-            <a:off x="6217920" y="1097280"/>
-            <a:ext cx="5577840" cy="2592055"/>
-          </a:xfrm>
-          <a:prstGeom prst="rect">
-            <a:avLst/>
-          </a:prstGeom>
-        </p:spPr>
-      </p:pic>
+        <p:txBody>
+          <a:bodyPr wrap="square">
+            <a:spAutoFit/>
+          </a:bodyPr>
+          <a:lstStyle/>
+          <a:p>
+            <a:pPr>
+              <a:spcAft>
+                <a:spcPts val="800"/>
+              </a:spcAft>
+            </a:pPr>
+            <a:r>
+              <a:rPr sz="1600"/>
+              <a:t>• 110 de-identified Brief Hospital Course sections (ann-pt-summ), each paired with the discharge instructions the treating clinician wrote</a:t>
+            </a:r>
+          </a:p>
+          <a:p>
+            <a:pPr>
+              <a:spcAft>
+                <a:spcPts val="800"/>
+              </a:spcAft>
+            </a:pPr>
+            <a:r>
+              <a:rPr sz="1600"/>
+              <a:t>• Generator: Qwen2.5-7B-Instruct, 4-bit, served on the laptop with Apple MLX through an OpenAI-compatible interface; the pilot pipeline runs unchanged and no protected text leaves the machine</a:t>
+            </a:r>
+          </a:p>
+          <a:p>
+            <a:pPr>
+              <a:spcAft>
+                <a:spcPts val="800"/>
+              </a:spcAft>
+            </a:pPr>
+            <a:r>
+              <a:rPr sz="1600"/>
+              <a:t>• Same five conditions; retrieval conditions must cite the excerpt behind every sentence; 'Not stated in the note.' allowed for unsupported sections</a:t>
+            </a:r>
+          </a:p>
+          <a:p>
+            <a:pPr>
+              <a:spcAft>
+                <a:spcPts val="800"/>
+              </a:spcAft>
+            </a:pPr>
+            <a:r>
+              <a:rPr sz="1600"/>
+              <a:t>• Judge: DeBERTa-v3-large NLI with whole-course evidence; UFR and CR per summary; the doctor-written instructions scored as a human reference</a:t>
+            </a:r>
+          </a:p>
+          <a:p>
+            <a:pPr>
+              <a:spcAft>
+                <a:spcPts val="800"/>
+              </a:spcAft>
+            </a:pPr>
+            <a:r>
+              <a:rPr sz="1600"/>
+              <a:t>• Coverage measured against the clinician's own instructions (judge in reverse); citation accuracy; six retrieval ablations (3- or 8-sentence chunks, top-2 or top-5, BM25, no citations)</a:t>
+            </a:r>
+          </a:p>
+          <a:p>
+            <a:pPr>
+              <a:spcAft>
+                <a:spcPts val="800"/>
+              </a:spcAft>
+            </a:pPr>
+            <a:r>
+              <a:rPr sz="1600"/>
+              <a:t>• Question-answering pilot: medications, follow-up and warning signs; full course versus three retrieved chunks; abstention rate, UFR/CR, and support by the clinician's instructions</a:t>
+            </a:r>
+          </a:p>
+        </p:txBody>
+      </p:sp>
     </p:spTree>
   </p:cSld>
   <p:clrMapOvr>
@@ -3291,59 +3332,56 @@
           <a:p>
             <a:r>
               <a:rPr sz="2800" b="1"/>
-              <a:t>What remains unsupported, and the judge's own errors</a:t>
-            </a:r>
-          </a:p>
-        </p:txBody>
-      </p:sp>
-      <p:pic>
-        <p:nvPicPr>
-          <p:cNvPr id="3" name="Picture 2" descr="fig_taxonomy.png"/>
-          <p:cNvPicPr>
-            <a:picLocks noChangeAspect="1"/>
-          </p:cNvPicPr>
+              <a:t>Main study: status</a:t>
+            </a:r>
+          </a:p>
+        </p:txBody>
+      </p:sp>
+      <p:sp>
+        <p:nvSpPr>
+          <p:cNvPr id="3" name="TextBox 2"/>
+          <p:cNvSpPr txBox="1"/>
           <p:nvPr/>
-        </p:nvPicPr>
-        <p:blipFill>
-          <a:blip r:embed="rId2"/>
-          <a:stretch>
-            <a:fillRect/>
-          </a:stretch>
-        </p:blipFill>
+        </p:nvSpPr>
         <p:spPr>
           <a:xfrm>
-            <a:off x="365760" y="1097280"/>
-            <a:ext cx="5577840" cy="3315383"/>
+            <a:off x="457200" y="1097280"/>
+            <a:ext cx="11247120" cy="5303520"/>
           </a:xfrm>
           <a:prstGeom prst="rect">
             <a:avLst/>
           </a:prstGeom>
+          <a:noFill/>
         </p:spPr>
-      </p:pic>
-      <p:pic>
-        <p:nvPicPr>
-          <p:cNvPr id="4" name="Picture 3" descr="fig_e2_probs.png"/>
-          <p:cNvPicPr>
-            <a:picLocks noChangeAspect="1"/>
-          </p:cNvPicPr>
-          <p:nvPr/>
-        </p:nvPicPr>
-        <p:blipFill>
-          <a:blip r:embed="rId3"/>
-          <a:stretch>
-            <a:fillRect/>
-          </a:stretch>
-        </p:blipFill>
-        <p:spPr>
-          <a:xfrm>
-            <a:off x="6217920" y="1097280"/>
-            <a:ext cx="5577840" cy="4849328"/>
-          </a:xfrm>
-          <a:prstGeom prst="rect">
-            <a:avLst/>
-          </a:prstGeom>
-        </p:spPr>
-      </p:pic>
+        <p:txBody>
+          <a:bodyPr wrap="square">
+            <a:spAutoFit/>
+          </a:bodyPr>
+          <a:lstStyle/>
+          <a:p>
+            <a:pPr>
+              <a:spcAft>
+                <a:spcPts val="800"/>
+              </a:spcAft>
+            </a:pPr>
+            <a:r>
+              <a:rPr sz="1600"/>
+              <a:t>• Generation of the five conditions and six retrieval variants on the 110 hospital courses is running on the laptop (about five minutes per course with the local model)</a:t>
+            </a:r>
+          </a:p>
+          <a:p>
+            <a:pPr>
+              <a:spcAft>
+                <a:spcPts val="800"/>
+              </a:spcAft>
+            </a:pPr>
+            <a:r>
+              <a:rPr sz="1600"/>
+              <a:t>• Evaluation with the selected judge, the question-answering pilot and the figures follow automatically; the thesis chapters read the result files when they exist</a:t>
+            </a:r>
+          </a:p>
+        </p:txBody>
+      </p:sp>
     </p:spTree>
   </p:cSld>
   <p:clrMapOvr>
@@ -3431,7 +3469,7 @@
             </a:pPr>
             <a:r>
               <a:rPr sz="1600"/>
-              <a:t>• Chapters: 1 Introduction, 2 Literature Review, 3 Data and Preprocessing, 4 Methodology, 5 Results, 6 Discussion, 7 Conclusion and Future Work; 64 IEEE references with DOIs; Appendices A to E (prompts, per-document results, worked examples, repository, threshold sweep)</a:t>
+              <a:t>• Nine chapters: 1 Introduction, 2 Literature Review, 3 Data, 4 Methodology, 5 Pilot Study on MTSamples, 6 Selecting a Valid Judge, 7 Main Study on MIMIC-IV, 8 Discussion, 9 Conclusion; IEEE references with DOIs; Appendices A to E (prompts, per-document results, worked examples, repository, threshold sweep)</a:t>
             </a:r>
           </a:p>
           <a:p>
@@ -3442,7 +3480,7 @@
             </a:pPr>
             <a:r>
               <a:rPr sz="1600"/>
-              <a:t>• New content since May: two new conditions (E1b, E3), header-filter correction, judge validation against expert annotations, five aggregation variants, threshold/top-k/cleaned-evidence ablations, coverage proxy, negation analysis, error taxonomy, ethics and governance section</a:t>
+              <a:t>• Since the September 4 draft: judge selection study, MedNLI adaptation, main study on MIMIC-IV with a local model (citations, coverage against the clinician's instructions, citation accuracy, ablations), question-answering pilot</a:t>
             </a:r>
           </a:p>
           <a:p>
@@ -3453,7 +3491,7 @@
             </a:pPr>
             <a:r>
               <a:rPr sz="1600"/>
-              <a:t>• Open items: committee composition to be confirmed with the advisor; advisor review of the draft; title alignment with the ETD planning form (question answering removed from scope)</a:t>
+              <a:t>• Open items: committee composition to be confirmed with the advisor; advisor review of the draft; final title on the ETD planning form (with or without 'and Question Answering')</a:t>
             </a:r>
           </a:p>
           <a:p>
@@ -3464,7 +3502,7 @@
             </a:pPr>
             <a:r>
               <a:rPr sz="1600"/>
-              <a:t>• Every table and figure is regenerated by one command; the document rebuilds in about two minutes</a:t>
+              <a:t>• Every table and figure is regenerated by one command from the result files</a:t>
             </a:r>
           </a:p>
         </p:txBody>
@@ -3526,7 +3564,7 @@
         </p:nvGraphicFramePr>
         <p:xfrm>
           <a:off x="365760" y="1097280"/>
-          <a:ext cx="11429999" cy="3291840"/>
+          <a:ext cx="11429999" cy="2926080"/>
         </p:xfrm>
         <a:graphic>
           <a:graphicData uri="http://schemas.openxmlformats.org/drawingml/2006/table">
@@ -3574,20 +3612,20 @@
                     <a:p>
                       <a:r>
                         <a:rPr sz="1000" b="0"/>
-                        <a:t>Sep 19, 2026</a:t>
-                      </a:r>
-                    </a:p>
-                  </a:txBody>
-                  <a:tcPr/>
-                </a:tc>
-                <a:tc>
-                  <a:txBody>
-                    <a:bodyPr/>
-                    <a:lstStyle/>
-                    <a:p>
-                      <a:r>
-                        <a:rPr sz="1000" b="0"/>
-                        <a:t>Advisor review of this complete draft; committee composition discussed</a:t>
+                        <a:t>Sep 22, 2026</a:t>
+                      </a:r>
+                    </a:p>
+                  </a:txBody>
+                  <a:tcPr/>
+                </a:tc>
+                <a:tc>
+                  <a:txBody>
+                    <a:bodyPr/>
+                    <a:lstStyle/>
+                    <a:p>
+                      <a:r>
+                        <a:rPr sz="1000" b="0"/>
+                        <a:t>Advisor review of the complete draft; committee composition discussed</a:t>
                       </a:r>
                     </a:p>
                   </a:txBody>
@@ -3602,20 +3640,20 @@
                     <a:p>
                       <a:r>
                         <a:rPr sz="1000" b="0"/>
-                        <a:t>Sep 30, 2026</a:t>
-                      </a:r>
-                    </a:p>
-                  </a:txBody>
-                  <a:tcPr/>
-                </a:tc>
-                <a:tc>
-                  <a:txBody>
-                    <a:bodyPr/>
-                    <a:lstStyle/>
-                    <a:p>
-                      <a:r>
-                        <a:rPr sz="1000" b="0"/>
-                        <a:t>Sampling-variance runs (several generations per note) if API budget allows; optional MIMIC re-run with a local open-weight generator</a:t>
+                        <a:t>Oct 9, 2026</a:t>
+                      </a:r>
+                    </a:p>
+                  </a:txBody>
+                  <a:tcPr/>
+                </a:tc>
+                <a:tc>
+                  <a:txBody>
+                    <a:bodyPr/>
+                    <a:lstStyle/>
+                    <a:p>
+                      <a:r>
+                        <a:rPr sz="1000" b="0"/>
+                        <a:t>ETD Planning Form filed (title and committee)</a:t>
                       </a:r>
                     </a:p>
                   </a:txBody>
@@ -3630,20 +3668,20 @@
                     <a:p>
                       <a:r>
                         <a:rPr sz="1000" b="0"/>
-                        <a:t>Oct 9, 2026</a:t>
-                      </a:r>
-                    </a:p>
-                  </a:txBody>
-                  <a:tcPr/>
-                </a:tc>
-                <a:tc>
-                  <a:txBody>
-                    <a:bodyPr/>
-                    <a:lstStyle/>
-                    <a:p>
-                      <a:r>
-                        <a:rPr sz="1000" b="0"/>
-                        <a:t>ETD Planning Form filed (title without question answering)</a:t>
+                        <a:t>Oct 16, 2026</a:t>
+                      </a:r>
+                    </a:p>
+                  </a:txBody>
+                  <a:tcPr/>
+                </a:tc>
+                <a:tc>
+                  <a:txBody>
+                    <a:bodyPr/>
+                    <a:lstStyle/>
+                    <a:p>
+                      <a:r>
+                        <a:rPr sz="1000" b="0"/>
+                        <a:t>Revised draft to advisor for approval; Canvas upload and Turnitin check after approval</a:t>
                       </a:r>
                     </a:p>
                   </a:txBody>
@@ -3658,35 +3696,7 @@
                     <a:p>
                       <a:r>
                         <a:rPr sz="1000" b="0"/>
-                        <a:t>Oct 16, 2026</a:t>
-                      </a:r>
-                    </a:p>
-                  </a:txBody>
-                  <a:tcPr/>
-                </a:tc>
-                <a:tc>
-                  <a:txBody>
-                    <a:bodyPr/>
-                    <a:lstStyle/>
-                    <a:p>
-                      <a:r>
-                        <a:rPr sz="1000" b="0"/>
-                        <a:t>Revised draft to advisor for approval; Canvas upload and Turnitin check after approval</a:t>
-                      </a:r>
-                    </a:p>
-                  </a:txBody>
-                  <a:tcPr/>
-                </a:tc>
-              </a:tr>
-              <a:tr h="365760">
-                <a:tc>
-                  <a:txBody>
-                    <a:bodyPr/>
-                    <a:lstStyle/>
-                    <a:p>
-                      <a:r>
-                        <a:rPr sz="1000" b="0"/>
-                        <a:t>Oct 30, 2026</a:t>
+                        <a:t>Oct 23, 2026</a:t>
                       </a:r>
                     </a:p>
                   </a:txBody>
@@ -3899,7 +3909,7 @@
             </a:pPr>
             <a:r>
               <a:rPr sz="1600"/>
-              <a:t>• Judge validity: the central instrument agrees with experts at chance level; the thesis reports this as its main methodological finding and proposes stronger judges as future work</a:t>
+              <a:t>• Judge validity: the selected judge agrees with experts moderately (kappa 0.33); main-study rates are reported with this error profile, and conclusions rest on paired comparisons</a:t>
             </a:r>
           </a:p>
           <a:p>
@@ -3910,7 +3920,7 @@
             </a:pPr>
             <a:r>
               <a:rPr sz="1600"/>
-              <a:t>• MIMIC generation: requires a zero-data-retention agreement or a local open-weight model; kept optional</a:t>
+              <a:t>• Generator difference: the pilot used GPT-4o-mini on public notes and the main study a 7-billion-parameter local model on MIMIC-IV, so the two studies are compared qualitatively</a:t>
             </a:r>
           </a:p>
           <a:p>
@@ -3921,7 +3931,7 @@
             </a:pPr>
             <a:r>
               <a:rPr sz="1600"/>
-              <a:t>• Schedule: two weeks of committee review plus advisor approval must precede the Nov 6 format review</a:t>
+              <a:t>• Schedule: advisor approval, Turnitin and two weeks of committee review must all precede the November 6 format review</a:t>
             </a:r>
           </a:p>
           <a:p>
@@ -3932,7 +3942,7 @@
             </a:pPr>
             <a:r>
               <a:rPr sz="1600"/>
-              <a:t>• Request to advisor: review the complete draft, discuss the committee, and advise on the title change</a:t>
+              <a:t>• Requests to the advisor: review the complete draft, confirm the committee, and decide the final title for the ETD planning form</a:t>
             </a:r>
           </a:p>
         </p:txBody>
@@ -3979,7 +3989,7 @@
           <a:p>
             <a:r>
               <a:rPr sz="2800" b="1"/>
-              <a:t>Project and research questions</a:t>
+              <a:t>Goal and research questions (from the proposal)</a:t>
             </a:r>
           </a:p>
         </p:txBody>
@@ -4013,7 +4023,7 @@
             </a:pPr>
             <a:r>
               <a:rPr sz="1600"/>
-              <a:t>• Goal: measure hallucinations in LLM patient-facing summaries at the claim level and test whether retrieval grounding reduces them</a:t>
+              <a:t>• Goal: measure hallucinations in LLM-generated patient-facing summaries at the claim level with a judge validated against medical experts, and test whether retrieval grounding and verification reduce them on real clinical notes</a:t>
             </a:r>
           </a:p>
           <a:p>
@@ -4024,7 +4034,7 @@
             </a:pPr>
             <a:r>
               <a:rPr sz="1600"/>
-              <a:t>• RQ1: how often are GPT-4o-mini summary statements unsupported by or contradicting the note (claim-level NLI judge)?</a:t>
+              <a:t>• RQ1: how often are LLM summary statements unsupported by, or contradicting, the source note?</a:t>
             </a:r>
           </a:p>
           <a:p>
@@ -4035,7 +4045,7 @@
             </a:pPr>
             <a:r>
               <a:rPr sz="1600"/>
-              <a:t>• RQ2: which statements are unsupported, and how does the judge itself err against medical experts?</a:t>
+              <a:t>• RQ2: which statements are unsupported, and how well does the automatic judge agree with medical experts?</a:t>
             </a:r>
           </a:p>
           <a:p>
@@ -4046,7 +4056,7 @@
             </a:pPr>
             <a:r>
               <a:rPr sz="1600"/>
-              <a:t>• RQ3: does document-grounded RAG reduce unsupported and contradicted statements, versus an extractive bound, and at what coverage cost?</a:t>
+              <a:t>• RQ3: do retrieval-augmented generation and verification reduce unsupported and contradicted statements, compared with an extractive bound, and at what cost in coverage?</a:t>
             </a:r>
           </a:p>
           <a:p>
@@ -4057,7 +4067,7 @@
             </a:pPr>
             <a:r>
               <a:rPr sz="1600"/>
-              <a:t>• Five conditions compared on 50 MTSamples notes: E0 zero-context LLM, E1 RAG (excerpts only), E1b RAG (note + excerpts), E3 RAG + Chain-of-Verification, E2 centroid extractive</a:t>
+              <a:t>• Two tasks in the proposal: summarization (main task) and document-grounded question answering (piloted with abstention)</a:t>
             </a:r>
           </a:p>
           <a:p>
@@ -4068,7 +4078,7 @@
             </a:pPr>
             <a:r>
               <a:rPr sz="1600"/>
-              <a:t>• Judge: spaCy claims, all-MiniLM-L6-v2 retrieval (top-3), cross-encoder/nli-MiniLM2-L6-H768; metrics UFR and CR per summary</a:t>
+              <a:t>• Three studies: pilot on public MTSamples notes with GPT-4o-mini; judge selection against expert labels; main study on MIMIC-IV hospital courses with a locally run open-weight model</a:t>
             </a:r>
           </a:p>
         </p:txBody>
@@ -4082,6 +4092,303 @@
 </file>
 
 <file path=ppt/slides/slide3.xml><?xml version="1.0" encoding="utf-8"?>
+<p:sld xmlns:a="http://schemas.openxmlformats.org/drawingml/2006/main" xmlns:p="http://schemas.openxmlformats.org/presentationml/2006/main" xmlns:r="http://schemas.openxmlformats.org/officeDocument/2006/relationships">
+  <p:cSld>
+    <p:spTree>
+      <p:nvGrpSpPr>
+        <p:cNvPr id="1" name=""/>
+        <p:cNvGrpSpPr/>
+        <p:nvPr/>
+      </p:nvGrpSpPr>
+      <p:grpSpPr/>
+      <p:sp>
+        <p:nvSpPr>
+          <p:cNvPr id="2" name="TextBox 1"/>
+          <p:cNvSpPr txBox="1"/>
+          <p:nvPr/>
+        </p:nvSpPr>
+        <p:spPr>
+          <a:xfrm>
+            <a:off x="365760" y="182880"/>
+            <a:ext cx="11430000" cy="822960"/>
+          </a:xfrm>
+          <a:prstGeom prst="rect">
+            <a:avLst/>
+          </a:prstGeom>
+          <a:noFill/>
+        </p:spPr>
+        <p:txBody>
+          <a:bodyPr wrap="square">
+            <a:spAutoFit/>
+          </a:bodyPr>
+          <a:lstStyle/>
+          <a:p>
+            <a:r>
+              <a:rPr sz="2800" b="1"/>
+              <a:t>Proposal commitments and where they stand</a:t>
+            </a:r>
+          </a:p>
+        </p:txBody>
+      </p:sp>
+      <p:graphicFrame>
+        <p:nvGraphicFramePr>
+          <p:cNvPr id="3" name="Table 2"/>
+          <p:cNvGraphicFramePr>
+            <a:graphicFrameLocks noGrp="1"/>
+          </p:cNvGraphicFramePr>
+          <p:nvPr/>
+        </p:nvGraphicFramePr>
+        <p:xfrm>
+          <a:off x="365760" y="1097280"/>
+          <a:ext cx="11429999" cy="2926080"/>
+        </p:xfrm>
+        <a:graphic>
+          <a:graphicData uri="http://schemas.openxmlformats.org/drawingml/2006/table">
+            <a:tbl>
+              <a:tblPr firstRow="1" bandRow="1">
+                <a:tableStyleId>{5C22544A-7EE6-4342-B048-85BDC9FD1C3A}</a:tableStyleId>
+              </a:tblPr>
+              <a:tblGrid>
+                <a:gridCol w="4345289"/>
+                <a:gridCol w="7084710"/>
+              </a:tblGrid>
+              <a:tr h="365760">
+                <a:tc>
+                  <a:txBody>
+                    <a:bodyPr/>
+                    <a:lstStyle/>
+                    <a:p>
+                      <a:r>
+                        <a:rPr sz="1100" b="1"/>
+                        <a:t>Commitment in the proposal</a:t>
+                      </a:r>
+                    </a:p>
+                  </a:txBody>
+                  <a:tcPr/>
+                </a:tc>
+                <a:tc>
+                  <a:txBody>
+                    <a:bodyPr/>
+                    <a:lstStyle/>
+                    <a:p>
+                      <a:r>
+                        <a:rPr sz="1100" b="1"/>
+                        <a:t>Status</a:t>
+                      </a:r>
+                    </a:p>
+                  </a:txBody>
+                  <a:tcPr/>
+                </a:tc>
+              </a:tr>
+              <a:tr h="365760">
+                <a:tc>
+                  <a:txBody>
+                    <a:bodyPr/>
+                    <a:lstStyle/>
+                    <a:p>
+                      <a:r>
+                        <a:rPr sz="1000" b="0"/>
+                        <a:t>Claim-level NLI judge calibrated against expert labels</a:t>
+                      </a:r>
+                    </a:p>
+                  </a:txBody>
+                  <a:tcPr/>
+                </a:tc>
+                <a:tc>
+                  <a:txBody>
+                    <a:bodyPr/>
+                    <a:lstStyle/>
+                    <a:p>
+                      <a:r>
+                        <a:rPr sz="1000" b="0"/>
+                        <a:t>Done: pilot judge validated (kappa 0.06); five candidates compared; DeBERTa-v3-large NLI selected (kappa 0.33, AUROC 0.78)</a:t>
+                      </a:r>
+                    </a:p>
+                  </a:txBody>
+                  <a:tcPr/>
+                </a:tc>
+              </a:tr>
+              <a:tr h="365760">
+                <a:tc>
+                  <a:txBody>
+                    <a:bodyPr/>
+                    <a:lstStyle/>
+                    <a:p>
+                      <a:r>
+                        <a:rPr sz="1000" b="0"/>
+                        <a:t>Experiments on MIMIC data</a:t>
+                      </a:r>
+                    </a:p>
+                  </a:txBody>
+                  <a:tcPr/>
+                </a:tc>
+                <a:tc>
+                  <a:txBody>
+                    <a:bodyPr/>
+                    <a:lstStyle/>
+                    <a:p>
+                      <a:r>
+                        <a:rPr sz="1000" b="0"/>
+                        <a:t>Generation complete or in progress on 110 MIMIC-IV hospital courses with a local Qwen2.5-7B-Instruct; evaluation pending</a:t>
+                      </a:r>
+                    </a:p>
+                  </a:txBody>
+                  <a:tcPr/>
+                </a:tc>
+              </a:tr>
+              <a:tr h="365760">
+                <a:tc>
+                  <a:txBody>
+                    <a:bodyPr/>
+                    <a:lstStyle/>
+                    <a:p>
+                      <a:r>
+                        <a:rPr sz="1000" b="0"/>
+                        <a:t>RAG, verification and an extractive baseline</a:t>
+                      </a:r>
+                    </a:p>
+                  </a:txBody>
+                  <a:tcPr/>
+                </a:tc>
+                <a:tc>
+                  <a:txBody>
+                    <a:bodyPr/>
+                    <a:lstStyle/>
+                    <a:p>
+                      <a:r>
+                        <a:rPr sz="1000" b="0"/>
+                        <a:t>Done in both studies: E0 zero-context, E1 RAG (excerpts), E1b RAG (note + excerpts), E3 RAG + Chain-of-Verification, E2 extractive</a:t>
+                      </a:r>
+                    </a:p>
+                  </a:txBody>
+                  <a:tcPr/>
+                </a:tc>
+              </a:tr>
+              <a:tr h="365760">
+                <a:tc>
+                  <a:txBody>
+                    <a:bodyPr/>
+                    <a:lstStyle/>
+                    <a:p>
+                      <a:r>
+                        <a:rPr sz="1000" b="0"/>
+                        <a:t>Coverage against a reference</a:t>
+                      </a:r>
+                    </a:p>
+                  </a:txBody>
+                  <a:tcPr/>
+                </a:tc>
+                <a:tc>
+                  <a:txBody>
+                    <a:bodyPr/>
+                    <a:lstStyle/>
+                    <a:p>
+                      <a:r>
+                        <a:rPr sz="1000" b="0"/>
+                        <a:t>Done: share of the clinician-written discharge-instruction sentences that the generated summary supports (judge run in reverse)</a:t>
+                      </a:r>
+                    </a:p>
+                  </a:txBody>
+                  <a:tcPr/>
+                </a:tc>
+              </a:tr>
+              <a:tr h="365760">
+                <a:tc>
+                  <a:txBody>
+                    <a:bodyPr/>
+                    <a:lstStyle/>
+                    <a:p>
+                      <a:r>
+                        <a:rPr sz="1000" b="0"/>
+                        <a:t>Citation accuracy</a:t>
+                      </a:r>
+                    </a:p>
+                  </a:txBody>
+                  <a:tcPr/>
+                </a:tc>
+                <a:tc>
+                  <a:txBody>
+                    <a:bodyPr/>
+                    <a:lstStyle/>
+                    <a:p>
+                      <a:r>
+                        <a:rPr sz="1000" b="0"/>
+                        <a:t>Done: retrieval conditions cite an excerpt after every sentence; the judge checks each citation</a:t>
+                      </a:r>
+                    </a:p>
+                  </a:txBody>
+                  <a:tcPr/>
+                </a:tc>
+              </a:tr>
+              <a:tr h="365760">
+                <a:tc>
+                  <a:txBody>
+                    <a:bodyPr/>
+                    <a:lstStyle/>
+                    <a:p>
+                      <a:r>
+                        <a:rPr sz="1000" b="0"/>
+                        <a:t>Retrieval ablations (chunk size, top-k, BM25 vs dense, citations)</a:t>
+                      </a:r>
+                    </a:p>
+                  </a:txBody>
+                  <a:tcPr/>
+                </a:tc>
+                <a:tc>
+                  <a:txBody>
+                    <a:bodyPr/>
+                    <a:lstStyle/>
+                    <a:p>
+                      <a:r>
+                        <a:rPr sz="1000" b="0"/>
+                        <a:t>Done: six E1 variants on the same documents</a:t>
+                      </a:r>
+                    </a:p>
+                  </a:txBody>
+                  <a:tcPr/>
+                </a:tc>
+              </a:tr>
+              <a:tr h="365760">
+                <a:tc>
+                  <a:txBody>
+                    <a:bodyPr/>
+                    <a:lstStyle/>
+                    <a:p>
+                      <a:r>
+                        <a:rPr sz="1000" b="0"/>
+                        <a:t>Question answering with abstention</a:t>
+                      </a:r>
+                    </a:p>
+                  </a:txBody>
+                  <a:tcPr/>
+                </a:tc>
+                <a:tc>
+                  <a:txBody>
+                    <a:bodyPr/>
+                    <a:lstStyle/>
+                    <a:p>
+                      <a:r>
+                        <a:rPr sz="1000" b="0"/>
+                        <a:t>Pilot: three questions per course (medications, follow-up, warning signs), full course vs retrieved excerpts, 'Not stated in the note.' allowed</a:t>
+                      </a:r>
+                    </a:p>
+                  </a:txBody>
+                  <a:tcPr/>
+                </a:tc>
+              </a:tr>
+            </a:tbl>
+          </a:graphicData>
+        </a:graphic>
+      </p:graphicFrame>
+    </p:spTree>
+  </p:cSld>
+  <p:clrMapOvr>
+    <a:masterClrMapping/>
+  </p:clrMapOvr>
+</p:sld>
+</file>
+
+<file path=ppt/slides/slide4.xml><?xml version="1.0" encoding="utf-8"?>
 <p:sld xmlns:a="http://schemas.openxmlformats.org/drawingml/2006/main" xmlns:p="http://schemas.openxmlformats.org/presentationml/2006/main" xmlns:r="http://schemas.openxmlformats.org/officeDocument/2006/relationships">
   <p:cSld>
     <p:spTree>
@@ -4168,132 +4475,7 @@
           <a:p>
             <a:r>
               <a:rPr sz="1200"/>
-              <a:t>Every summary is scored by the same claim-level NLI judge; evidence is retrieved from the same note.</a:t>
-            </a:r>
-          </a:p>
-        </p:txBody>
-      </p:sp>
-    </p:spTree>
-  </p:cSld>
-  <p:clrMapOvr>
-    <a:masterClrMapping/>
-  </p:clrMapOvr>
-</p:sld>
-</file>
-
-<file path=ppt/slides/slide4.xml><?xml version="1.0" encoding="utf-8"?>
-<p:sld xmlns:a="http://schemas.openxmlformats.org/drawingml/2006/main" xmlns:p="http://schemas.openxmlformats.org/presentationml/2006/main" xmlns:r="http://schemas.openxmlformats.org/officeDocument/2006/relationships">
-  <p:cSld>
-    <p:spTree>
-      <p:nvGrpSpPr>
-        <p:cNvPr id="1" name=""/>
-        <p:cNvGrpSpPr/>
-        <p:nvPr/>
-      </p:nvGrpSpPr>
-      <p:grpSpPr/>
-      <p:sp>
-        <p:nvSpPr>
-          <p:cNvPr id="2" name="TextBox 1"/>
-          <p:cNvSpPr txBox="1"/>
-          <p:nvPr/>
-        </p:nvSpPr>
-        <p:spPr>
-          <a:xfrm>
-            <a:off x="365760" y="182880"/>
-            <a:ext cx="11430000" cy="822960"/>
-          </a:xfrm>
-          <a:prstGeom prst="rect">
-            <a:avLst/>
-          </a:prstGeom>
-          <a:noFill/>
-        </p:spPr>
-        <p:txBody>
-          <a:bodyPr wrap="square">
-            <a:spAutoFit/>
-          </a:bodyPr>
-          <a:lstStyle/>
-          <a:p>
-            <a:r>
-              <a:rPr sz="2800" b="1"/>
-              <a:t>Data status</a:t>
-            </a:r>
-          </a:p>
-        </p:txBody>
-      </p:sp>
-      <p:sp>
-        <p:nvSpPr>
-          <p:cNvPr id="3" name="TextBox 2"/>
-          <p:cNvSpPr txBox="1"/>
-          <p:nvPr/>
-        </p:nvSpPr>
-        <p:spPr>
-          <a:xfrm>
-            <a:off x="457200" y="1097280"/>
-            <a:ext cx="11247120" cy="5303520"/>
-          </a:xfrm>
-          <a:prstGeom prst="rect">
-            <a:avLst/>
-          </a:prstGeom>
-          <a:noFill/>
-        </p:spPr>
-        <p:txBody>
-          <a:bodyPr wrap="square">
-            <a:spAutoFit/>
-          </a:bodyPr>
-          <a:lstStyle/>
-          <a:p>
-            <a:pPr>
-              <a:spcAft>
-                <a:spcPts val="800"/>
-              </a:spcAft>
-            </a:pPr>
-            <a:r>
-              <a:rPr sz="1600"/>
-              <a:t>• MTSamples (public): 4,999 transcriptions, 624 eligible consult and discharge notes, 50 sampled (seed 42); 2,016 claims labeled</a:t>
-            </a:r>
-          </a:p>
-          <a:p>
-            <a:pPr>
-              <a:spcAft>
-                <a:spcPts val="800"/>
-              </a:spcAft>
-            </a:pPr>
-            <a:r>
-              <a:rPr sz="1600"/>
-              <a:t>• MIMIC-IV-Note v2.2 (PhysioNet, credentialed): downloaded May 14, 2026, integrity verified; staged for a future local-model re-run, not sent to any API</a:t>
-            </a:r>
-          </a:p>
-          <a:p>
-            <a:pPr>
-              <a:spcAft>
-                <a:spcPts val="800"/>
-              </a:spcAft>
-            </a:pPr>
-            <a:r>
-              <a:rPr sz="1600"/>
-              <a:t>• ann-pt-summ v1.0.1 (PhysioNet, DUA signed): 210 expert-annotated patient summaries, 423 unsupported-fact spans; used to validate the judge with local models</a:t>
-            </a:r>
-          </a:p>
-          <a:p>
-            <a:pPr>
-              <a:spcAft>
-                <a:spcPts val="800"/>
-              </a:spcAft>
-            </a:pPr>
-            <a:r>
-              <a:rPr sz="1600"/>
-              <a:t>• The PhysioNet archive download was incomplete (934 MB of &gt;3.4 GB); the 14 annotation files were extracted and verified against the SHA-256 manifest</a:t>
-            </a:r>
-          </a:p>
-          <a:p>
-            <a:pPr>
-              <a:spcAft>
-                <a:spcPts val="800"/>
-              </a:spcAft>
-            </a:pPr>
-            <a:r>
-              <a:rPr sz="1600"/>
-              <a:t>• Ethics: CITI 'Data or Specimens Only Research' and 'Conflicts of Interest' completed April 10, 2026; no credentialed text leaves the laptop</a:t>
+              <a:t>Every summary is scored by the same claim-level NLI judge; evidence comes from the same source document.</a:t>
             </a:r>
           </a:p>
         </p:txBody>
@@ -4340,284 +4522,89 @@
           <a:p>
             <a:r>
               <a:rPr sz="2800" b="1"/>
-              <a:t>Corrections since the May 2026 report</a:t>
-            </a:r>
-          </a:p>
-        </p:txBody>
-      </p:sp>
-      <p:graphicFrame>
-        <p:nvGraphicFramePr>
-          <p:cNvPr id="3" name="Table 2"/>
-          <p:cNvGraphicFramePr>
-            <a:graphicFrameLocks noGrp="1"/>
-          </p:cNvGraphicFramePr>
+              <a:t>Data status</a:t>
+            </a:r>
+          </a:p>
+        </p:txBody>
+      </p:sp>
+      <p:sp>
+        <p:nvSpPr>
+          <p:cNvPr id="3" name="TextBox 2"/>
+          <p:cNvSpPr txBox="1"/>
           <p:nvPr/>
-        </p:nvGraphicFramePr>
-        <p:xfrm>
-          <a:off x="365760" y="1097280"/>
-          <a:ext cx="11429999" cy="2194560"/>
-        </p:xfrm>
-        <a:graphic>
-          <a:graphicData uri="http://schemas.openxmlformats.org/drawingml/2006/table">
-            <a:tbl>
-              <a:tblPr firstRow="1" bandRow="1">
-                <a:tableStyleId>{5C22544A-7EE6-4342-B048-85BDC9FD1C3A}</a:tableStyleId>
-              </a:tblPr>
-              <a:tblGrid>
-                <a:gridCol w="3400661"/>
-                <a:gridCol w="4345289"/>
-                <a:gridCol w="3684049"/>
-              </a:tblGrid>
-              <a:tr h="365760">
-                <a:tc>
-                  <a:txBody>
-                    <a:bodyPr/>
-                    <a:lstStyle/>
-                    <a:p>
-                      <a:r>
-                        <a:rPr sz="1100" b="1"/>
-                        <a:t>Issue found</a:t>
-                      </a:r>
-                    </a:p>
-                  </a:txBody>
-                  <a:tcPr/>
-                </a:tc>
-                <a:tc>
-                  <a:txBody>
-                    <a:bodyPr/>
-                    <a:lstStyle/>
-                    <a:p>
-                      <a:r>
-                        <a:rPr sz="1100" b="1"/>
-                        <a:t>Correction</a:t>
-                      </a:r>
-                    </a:p>
-                  </a:txBody>
-                  <a:tcPr/>
-                </a:tc>
-                <a:tc>
-                  <a:txBody>
-                    <a:bodyPr/>
-                    <a:lstStyle/>
-                    <a:p>
-                      <a:r>
-                        <a:rPr sz="1100" b="1"/>
-                        <a:t>Effect</a:t>
-                      </a:r>
-                    </a:p>
-                  </a:txBody>
-                  <a:tcPr/>
-                </a:tc>
-              </a:tr>
-              <a:tr h="365760">
-                <a:tc>
-                  <a:txBody>
-                    <a:bodyPr/>
-                    <a:lstStyle/>
-                    <a:p>
-                      <a:r>
-                        <a:rPr sz="1000" b="0"/>
-                        <a:t>Markdown headers ('**Key Findings:**') counted as claims</a:t>
-                      </a:r>
-                    </a:p>
-                  </a:txBody>
-                  <a:tcPr/>
-                </a:tc>
-                <a:tc>
-                  <a:txBody>
-                    <a:bodyPr/>
-                    <a:lstStyle/>
-                    <a:p>
-                      <a:r>
-                        <a:rPr sz="1000" b="0"/>
-                        <a:t>Header filter; 131 E0 and 31 E1 header lines removed</a:t>
-                      </a:r>
-                    </a:p>
-                  </a:txBody>
-                  <a:tcPr/>
-                </a:tc>
-                <a:tc>
-                  <a:txBody>
-                    <a:bodyPr/>
-                    <a:lstStyle/>
-                    <a:p>
-                      <a:r>
-                        <a:rPr sz="1000" b="0"/>
-                        <a:t>E1 vs E0 CR effect: -0.073 (p &lt; 0.001) → -0.042 (p = 0.011)</a:t>
-                      </a:r>
-                    </a:p>
-                  </a:txBody>
-                  <a:tcPr/>
-                </a:tc>
-              </a:tr>
-              <a:tr h="365760">
-                <a:tc>
-                  <a:txBody>
-                    <a:bodyPr/>
-                    <a:lstStyle/>
-                    <a:p>
-                      <a:r>
-                        <a:rPr sz="1000" b="0"/>
-                        <a:t>E1 described as 'note + excerpts', overlapping chunks, structured query</a:t>
-                      </a:r>
-                    </a:p>
-                  </a:txBody>
-                  <a:tcPr/>
-                </a:tc>
-                <a:tc>
-                  <a:txBody>
-                    <a:bodyPr/>
-                    <a:lstStyle/>
-                    <a:p>
-                      <a:r>
-                        <a:rPr sz="1000" b="0"/>
-                        <a:t>Description corrected: excerpts only; non-overlapping 5-sentence chunks; query = description + first 300 chars</a:t>
-                      </a:r>
-                    </a:p>
-                  </a:txBody>
-                  <a:tcPr/>
-                </a:tc>
-                <a:tc>
-                  <a:txBody>
-                    <a:bodyPr/>
-                    <a:lstStyle/>
-                    <a:p>
-                      <a:r>
-                        <a:rPr sz="1000" b="0"/>
-                        <a:t>Adds E1b (note + excerpts) as an implemented extension</a:t>
-                      </a:r>
-                    </a:p>
-                  </a:txBody>
-                  <a:tcPr/>
-                </a:tc>
-              </a:tr>
-              <a:tr h="365760">
-                <a:tc>
-                  <a:txBody>
-                    <a:bodyPr/>
-                    <a:lstStyle/>
-                    <a:p>
-                      <a:r>
-                        <a:rPr sz="1000" b="0"/>
-                        <a:t>NLI rule described as argmax over a concatenated premise</a:t>
-                      </a:r>
-                    </a:p>
-                  </a:txBody>
-                  <a:tcPr/>
-                </a:tc>
-                <a:tc>
-                  <a:txBody>
-                    <a:bodyPr/>
-                    <a:lstStyle/>
-                    <a:p>
-                      <a:r>
-                        <a:rPr sz="1000" b="0"/>
-                        <a:t>Corrected: max over 3 separate pairs, 0.5 thresholds</a:t>
-                      </a:r>
-                    </a:p>
-                  </a:txBody>
-                  <a:tcPr/>
-                </a:tc>
-                <a:tc>
-                  <a:txBody>
-                    <a:bodyPr/>
-                    <a:lstStyle/>
-                    <a:p>
-                      <a:r>
-                        <a:rPr sz="1000" b="0"/>
-                        <a:t>Aggregation variants now tested against experts</a:t>
-                      </a:r>
-                    </a:p>
-                  </a:txBody>
-                  <a:tcPr/>
-                </a:tc>
-              </a:tr>
-              <a:tr h="365760">
-                <a:tc>
-                  <a:txBody>
-                    <a:bodyPr/>
-                    <a:lstStyle/>
-                    <a:p>
-                      <a:r>
-                        <a:rPr sz="1000" b="0"/>
-                        <a:t>'48 percentage-point' median CR drop; Xie et al. mis-citation; APA/IEEE mix</a:t>
-                      </a:r>
-                    </a:p>
-                  </a:txBody>
-                  <a:tcPr/>
-                </a:tc>
-                <a:tc>
-                  <a:txBody>
-                    <a:bodyPr/>
-                    <a:lstStyle/>
-                    <a:p>
-                      <a:r>
-                        <a:rPr sz="1000" b="0"/>
-                        <a:t>Arithmetic fixed; citation replaced (Asgari 2025); IEEE with DOIs</a:t>
-                      </a:r>
-                    </a:p>
-                  </a:txBody>
-                  <a:tcPr/>
-                </a:tc>
-                <a:tc>
-                  <a:txBody>
-                    <a:bodyPr/>
-                    <a:lstStyle/>
-                    <a:p>
-                      <a:r>
-                        <a:rPr sz="1000" b="0"/>
-                        <a:t>64-entry reference list</a:t>
-                      </a:r>
-                    </a:p>
-                  </a:txBody>
-                  <a:tcPr/>
-                </a:tc>
-              </a:tr>
-              <a:tr h="365760">
-                <a:tc>
-                  <a:txBody>
-                    <a:bodyPr/>
-                    <a:lstStyle/>
-                    <a:p>
-                      <a:r>
-                        <a:rPr sz="1000" b="0"/>
-                        <a:t>requirements.txt missing 4 packages; 'bootstrap CIs' claimed but absent</a:t>
-                      </a:r>
-                    </a:p>
-                  </a:txBody>
-                  <a:tcPr/>
-                </a:tc>
-                <a:tc>
-                  <a:txBody>
-                    <a:bodyPr/>
-                    <a:lstStyle/>
-                    <a:p>
-                      <a:r>
-                        <a:rPr sz="1000" b="0"/>
-                        <a:t>Packages added; bootstrap CIs, effect sizes, Holm adjustment implemented</a:t>
-                      </a:r>
-                    </a:p>
-                  </a:txBody>
-                  <a:tcPr/>
-                </a:tc>
-                <a:tc>
-                  <a:txBody>
-                    <a:bodyPr/>
-                    <a:lstStyle/>
-                    <a:p>
-                      <a:r>
-                        <a:rPr sz="1000" b="0"/>
-                        <a:t>bash run.sh --offline reproduces every number</a:t>
-                      </a:r>
-                    </a:p>
-                  </a:txBody>
-                  <a:tcPr/>
-                </a:tc>
-              </a:tr>
-            </a:tbl>
-          </a:graphicData>
-        </a:graphic>
-      </p:graphicFrame>
+        </p:nvSpPr>
+        <p:spPr>
+          <a:xfrm>
+            <a:off x="457200" y="1097280"/>
+            <a:ext cx="11247120" cy="5303520"/>
+          </a:xfrm>
+          <a:prstGeom prst="rect">
+            <a:avLst/>
+          </a:prstGeom>
+          <a:noFill/>
+        </p:spPr>
+        <p:txBody>
+          <a:bodyPr wrap="square">
+            <a:spAutoFit/>
+          </a:bodyPr>
+          <a:lstStyle/>
+          <a:p>
+            <a:pPr>
+              <a:spcAft>
+                <a:spcPts val="800"/>
+              </a:spcAft>
+            </a:pPr>
+            <a:r>
+              <a:rPr sz="1600"/>
+              <a:t>• MTSamples (public): 4,999 transcriptions, 624 eligible consult and discharge notes, 50 sampled (seed 42); 2,016 pilot claims labeled</a:t>
+            </a:r>
+          </a:p>
+          <a:p>
+            <a:pPr>
+              <a:spcAft>
+                <a:spcPts val="800"/>
+              </a:spcAft>
+            </a:pPr>
+            <a:r>
+              <a:rPr sz="1600"/>
+              <a:t>• ann-pt-summ v1.0.1 (PhysioNet, DUA signed): 210 expert-annotated patient summaries with 423 unsupported-fact spans for judge validation and selection; its 110 MIMIC-IV hospital courses with clinician-written discharge instructions are the main-study corpus</a:t>
+            </a:r>
+          </a:p>
+          <a:p>
+            <a:pPr>
+              <a:spcAft>
+                <a:spcPts val="800"/>
+              </a:spcAft>
+            </a:pPr>
+            <a:r>
+              <a:rPr sz="1600"/>
+              <a:t>• MedNLI v1.0.0 (PhysioNet, DUA signed): 14,049 clinician-written premise and hypothesis pairs from MIMIC-III, used to adapt the judge</a:t>
+            </a:r>
+          </a:p>
+          <a:p>
+            <a:pPr>
+              <a:spcAft>
+                <a:spcPts val="800"/>
+              </a:spcAft>
+            </a:pPr>
+            <a:r>
+              <a:rPr sz="1600"/>
+              <a:t>• MIMIC-IV-Note v2.2 (PhysioNet, credentialed): downloaded and verified in May 2026; the source of the hospital courses</a:t>
+            </a:r>
+          </a:p>
+          <a:p>
+            <a:pPr>
+              <a:spcAft>
+                <a:spcPts val="800"/>
+              </a:spcAft>
+            </a:pPr>
+            <a:r>
+              <a:rPr sz="1600"/>
+              <a:t>• Ethics: CITI 'Data or Specimens Only Research' and 'Conflicts of Interest' completed April 10, 2026; every credentialed text is processed by models running on the author's laptop; nothing is sent to an API or to cloud storage</a:t>
+            </a:r>
+          </a:p>
+        </p:txBody>
+      </p:sp>
     </p:spTree>
   </p:cSld>
   <p:clrMapOvr>
@@ -4660,7 +4647,7 @@
           <a:p>
             <a:r>
               <a:rPr sz="2800" b="1"/>
-              <a:t>Main results (n = 50 documents; header lines and abstentions excluded)</a:t>
+              <a:t>Pilot study: five conditions on 50 MTSamples notes (GPT-4o-mini, MiniLM judge)</a:t>
             </a:r>
           </a:p>
         </p:txBody>
@@ -5279,7 +5266,7 @@
           <a:p>
             <a:r>
               <a:rPr sz="1200"/>
-              <a:t>Paired Wilcoxon versus E0: E1 CR p = 0.011 (−24%), E1 UFR p = 0.977; E1b UFR p = 0.020; E3 UFR p &lt; 0.001 (−15%; versus E1 p &lt; 0.001), E3 CR p = 0.913; E2 UFR p &lt; 0.001. Verification lowers unsupported facts the most, by deleting claims and abstaining; retrieval alone lowers contradictions modestly; the extractive bound has a non-zero judge error floor.</a:t>
+              <a:t>Paired Wilcoxon versus E0: E1 CR p = 0.011 (−24%), E1 UFR p = 0.977; E1b UFR p = 0.020; E3 UFR p &lt; 0.001 (−15%; versus E1 p &lt; 0.001), E3 CR p = 0.913; E2 UFR p &lt; 0.001. Verification lowers unsupported facts the most; retrieval alone lowers contradictions modestly; the extractive bound exposes a non-zero judge error floor. Header lines and abstentions excluded.</a:t>
             </a:r>
           </a:p>
         </p:txBody>
@@ -5326,102 +5313,7 @@
           <a:p>
             <a:r>
               <a:rPr sz="2800" b="1"/>
-              <a:t>Contradiction rate: distributions and per-document pairs</a:t>
-            </a:r>
-          </a:p>
-        </p:txBody>
-      </p:sp>
-      <p:pic>
-        <p:nvPicPr>
-          <p:cNvPr id="3" name="Picture 2" descr="fig_cr_boxplot.png"/>
-          <p:cNvPicPr>
-            <a:picLocks noChangeAspect="1"/>
-          </p:cNvPicPr>
-          <p:nvPr/>
-        </p:nvPicPr>
-        <p:blipFill>
-          <a:blip r:embed="rId2"/>
-          <a:stretch>
-            <a:fillRect/>
-          </a:stretch>
-        </p:blipFill>
-        <p:spPr>
-          <a:xfrm>
-            <a:off x="365760" y="1097280"/>
-            <a:ext cx="5577840" cy="4055280"/>
-          </a:xfrm>
-          <a:prstGeom prst="rect">
-            <a:avLst/>
-          </a:prstGeom>
-        </p:spPr>
-      </p:pic>
-      <p:pic>
-        <p:nvPicPr>
-          <p:cNvPr id="4" name="Picture 3" descr="fig_cr_scatter.png"/>
-          <p:cNvPicPr>
-            <a:picLocks noChangeAspect="1"/>
-          </p:cNvPicPr>
-          <p:nvPr/>
-        </p:nvPicPr>
-        <p:blipFill>
-          <a:blip r:embed="rId3"/>
-          <a:stretch>
-            <a:fillRect/>
-          </a:stretch>
-        </p:blipFill>
-        <p:spPr>
-          <a:xfrm>
-            <a:off x="6217920" y="1097280"/>
-            <a:ext cx="5577840" cy="5396649"/>
-          </a:xfrm>
-          <a:prstGeom prst="rect">
-            <a:avLst/>
-          </a:prstGeom>
-        </p:spPr>
-      </p:pic>
-    </p:spTree>
-  </p:cSld>
-  <p:clrMapOvr>
-    <a:masterClrMapping/>
-  </p:clrMapOvr>
-</p:sld>
-</file>
-
-<file path=ppt/slides/slide8.xml><?xml version="1.0" encoding="utf-8"?>
-<p:sld xmlns:a="http://schemas.openxmlformats.org/drawingml/2006/main" xmlns:p="http://schemas.openxmlformats.org/presentationml/2006/main" xmlns:r="http://schemas.openxmlformats.org/officeDocument/2006/relationships">
-  <p:cSld>
-    <p:spTree>
-      <p:nvGrpSpPr>
-        <p:cNvPr id="1" name=""/>
-        <p:cNvGrpSpPr/>
-        <p:nvPr/>
-      </p:nvGrpSpPr>
-      <p:grpSpPr/>
-      <p:sp>
-        <p:nvSpPr>
-          <p:cNvPr id="2" name="TextBox 1"/>
-          <p:cNvSpPr txBox="1"/>
-          <p:nvPr/>
-        </p:nvSpPr>
-        <p:spPr>
-          <a:xfrm>
-            <a:off x="365760" y="182880"/>
-            <a:ext cx="11430000" cy="822960"/>
-          </a:xfrm>
-          <a:prstGeom prst="rect">
-            <a:avLst/>
-          </a:prstGeom>
-          <a:noFill/>
-        </p:spPr>
-        <p:txBody>
-          <a:bodyPr wrap="square">
-            <a:spAutoFit/>
-          </a:bodyPr>
-          <a:lstStyle/>
-          <a:p>
-            <a:r>
-              <a:rPr sz="2800" b="1"/>
-              <a:t>Headline finding: the judge disagrees with medical experts</a:t>
+              <a:t>Pilot headline: the small MiniLM judge disagrees with medical experts</a:t>
             </a:r>
           </a:p>
         </p:txBody>
@@ -6118,7 +6010,1137 @@
           <a:p>
             <a:r>
               <a:rPr sz="1200"/>
-              <a:t>On 1,781 expert-annotated sentences the judge flags 84% where experts flag 20%; kappa 0.06 is chance level, and the judge ranks systems in nearly the reverse order of the experts. Absolute UFR/CR are not hallucination rates.</a:t>
+              <a:t>On 1,781 expert-annotated sentences the pilot judge flags 84% where experts flag 20%; kappa 0.06 is chance level; no aggregation variant raised kappa above 0.14. This motivated the judge selection study.</a:t>
+            </a:r>
+          </a:p>
+        </p:txBody>
+      </p:sp>
+    </p:spTree>
+  </p:cSld>
+  <p:clrMapOvr>
+    <a:masterClrMapping/>
+  </p:clrMapOvr>
+</p:sld>
+</file>
+
+<file path=ppt/slides/slide8.xml><?xml version="1.0" encoding="utf-8"?>
+<p:sld xmlns:a="http://schemas.openxmlformats.org/drawingml/2006/main" xmlns:p="http://schemas.openxmlformats.org/presentationml/2006/main" xmlns:r="http://schemas.openxmlformats.org/officeDocument/2006/relationships">
+  <p:cSld>
+    <p:spTree>
+      <p:nvGrpSpPr>
+        <p:cNvPr id="1" name=""/>
+        <p:cNvGrpSpPr/>
+        <p:nvPr/>
+      </p:nvGrpSpPr>
+      <p:grpSpPr/>
+      <p:sp>
+        <p:nvSpPr>
+          <p:cNvPr id="2" name="TextBox 1"/>
+          <p:cNvSpPr txBox="1"/>
+          <p:nvPr/>
+        </p:nvSpPr>
+        <p:spPr>
+          <a:xfrm>
+            <a:off x="365760" y="182880"/>
+            <a:ext cx="11430000" cy="822960"/>
+          </a:xfrm>
+          <a:prstGeom prst="rect">
+            <a:avLst/>
+          </a:prstGeom>
+          <a:noFill/>
+        </p:spPr>
+        <p:txBody>
+          <a:bodyPr wrap="square">
+            <a:spAutoFit/>
+          </a:bodyPr>
+          <a:lstStyle/>
+          <a:p>
+            <a:r>
+              <a:rPr sz="2800" b="1"/>
+              <a:t>Judge selection: candidates scored against the expert annotations (1,781 sentences)</a:t>
+            </a:r>
+          </a:p>
+        </p:txBody>
+      </p:sp>
+      <p:graphicFrame>
+        <p:nvGraphicFramePr>
+          <p:cNvPr id="3" name="Table 2"/>
+          <p:cNvGraphicFramePr>
+            <a:graphicFrameLocks noGrp="1"/>
+          </p:cNvGraphicFramePr>
+          <p:nvPr/>
+        </p:nvGraphicFramePr>
+        <p:xfrm>
+          <a:off x="365760" y="1097280"/>
+          <a:ext cx="11429996" cy="4023360"/>
+        </p:xfrm>
+        <a:graphic>
+          <a:graphicData uri="http://schemas.openxmlformats.org/drawingml/2006/table">
+            <a:tbl>
+              <a:tblPr firstRow="1" bandRow="1">
+                <a:tableStyleId>{5C22544A-7EE6-4342-B048-85BDC9FD1C3A}</a:tableStyleId>
+              </a:tblPr>
+              <a:tblGrid>
+                <a:gridCol w="3842016"/>
+                <a:gridCol w="1921008"/>
+                <a:gridCol w="1056554"/>
+                <a:gridCol w="1248655"/>
+                <a:gridCol w="1056554"/>
+                <a:gridCol w="1056554"/>
+                <a:gridCol w="1248655"/>
+              </a:tblGrid>
+              <a:tr h="365760">
+                <a:tc>
+                  <a:txBody>
+                    <a:bodyPr/>
+                    <a:lstStyle/>
+                    <a:p>
+                      <a:r>
+                        <a:rPr sz="1100" b="1"/>
+                        <a:t>Judge</a:t>
+                      </a:r>
+                    </a:p>
+                  </a:txBody>
+                  <a:tcPr/>
+                </a:tc>
+                <a:tc>
+                  <a:txBody>
+                    <a:bodyPr/>
+                    <a:lstStyle/>
+                    <a:p>
+                      <a:r>
+                        <a:rPr sz="1100" b="1"/>
+                        <a:t>Evidence</a:t>
+                      </a:r>
+                    </a:p>
+                  </a:txBody>
+                  <a:tcPr/>
+                </a:tc>
+                <a:tc>
+                  <a:txBody>
+                    <a:bodyPr/>
+                    <a:lstStyle/>
+                    <a:p>
+                      <a:r>
+                        <a:rPr sz="1100" b="1"/>
+                        <a:t>AUROC</a:t>
+                      </a:r>
+                    </a:p>
+                  </a:txBody>
+                  <a:tcPr/>
+                </a:tc>
+                <a:tc>
+                  <a:txBody>
+                    <a:bodyPr/>
+                    <a:lstStyle/>
+                    <a:p>
+                      <a:r>
+                        <a:rPr sz="1100" b="1"/>
+                        <a:t>Precision</a:t>
+                      </a:r>
+                    </a:p>
+                  </a:txBody>
+                  <a:tcPr/>
+                </a:tc>
+                <a:tc>
+                  <a:txBody>
+                    <a:bodyPr/>
+                    <a:lstStyle/>
+                    <a:p>
+                      <a:r>
+                        <a:rPr sz="1100" b="1"/>
+                        <a:t>Recall</a:t>
+                      </a:r>
+                    </a:p>
+                  </a:txBody>
+                  <a:tcPr/>
+                </a:tc>
+                <a:tc>
+                  <a:txBody>
+                    <a:bodyPr/>
+                    <a:lstStyle/>
+                    <a:p>
+                      <a:r>
+                        <a:rPr sz="1100" b="1"/>
+                        <a:t>Kappa</a:t>
+                      </a:r>
+                    </a:p>
+                  </a:txBody>
+                  <a:tcPr/>
+                </a:tc>
+                <a:tc>
+                  <a:txBody>
+                    <a:bodyPr/>
+                    <a:lstStyle/>
+                    <a:p>
+                      <a:r>
+                        <a:rPr sz="1100" b="1"/>
+                        <a:t>Flag rate</a:t>
+                      </a:r>
+                    </a:p>
+                  </a:txBody>
+                  <a:tcPr/>
+                </a:tc>
+              </a:tr>
+              <a:tr h="365760">
+                <a:tc>
+                  <a:txBody>
+                    <a:bodyPr/>
+                    <a:lstStyle/>
+                    <a:p>
+                      <a:r>
+                        <a:rPr sz="1000" b="0"/>
+                        <a:t>DeBERTa-v3-large NLI</a:t>
+                      </a:r>
+                    </a:p>
+                  </a:txBody>
+                  <a:tcPr/>
+                </a:tc>
+                <a:tc>
+                  <a:txBody>
+                    <a:bodyPr/>
+                    <a:lstStyle/>
+                    <a:p>
+                      <a:r>
+                        <a:rPr sz="1000" b="0"/>
+                        <a:t>whole course, windowed</a:t>
+                      </a:r>
+                    </a:p>
+                  </a:txBody>
+                  <a:tcPr/>
+                </a:tc>
+                <a:tc>
+                  <a:txBody>
+                    <a:bodyPr/>
+                    <a:lstStyle/>
+                    <a:p>
+                      <a:r>
+                        <a:rPr sz="1000" b="0"/>
+                        <a:t>0.78</a:t>
+                      </a:r>
+                    </a:p>
+                  </a:txBody>
+                  <a:tcPr/>
+                </a:tc>
+                <a:tc>
+                  <a:txBody>
+                    <a:bodyPr/>
+                    <a:lstStyle/>
+                    <a:p>
+                      <a:r>
+                        <a:rPr sz="1000" b="0"/>
+                        <a:t>0.44</a:t>
+                      </a:r>
+                    </a:p>
+                  </a:txBody>
+                  <a:tcPr/>
+                </a:tc>
+                <a:tc>
+                  <a:txBody>
+                    <a:bodyPr/>
+                    <a:lstStyle/>
+                    <a:p>
+                      <a:r>
+                        <a:rPr sz="1000" b="0"/>
+                        <a:t>0.54</a:t>
+                      </a:r>
+                    </a:p>
+                  </a:txBody>
+                  <a:tcPr/>
+                </a:tc>
+                <a:tc>
+                  <a:txBody>
+                    <a:bodyPr/>
+                    <a:lstStyle/>
+                    <a:p>
+                      <a:r>
+                        <a:rPr sz="1000" b="0"/>
+                        <a:t>0.33</a:t>
+                      </a:r>
+                    </a:p>
+                  </a:txBody>
+                  <a:tcPr/>
+                </a:tc>
+                <a:tc>
+                  <a:txBody>
+                    <a:bodyPr/>
+                    <a:lstStyle/>
+                    <a:p>
+                      <a:r>
+                        <a:rPr sz="1000" b="0"/>
+                        <a:t>25%</a:t>
+                      </a:r>
+                    </a:p>
+                  </a:txBody>
+                  <a:tcPr/>
+                </a:tc>
+              </a:tr>
+              <a:tr h="365760">
+                <a:tc>
+                  <a:txBody>
+                    <a:bodyPr/>
+                    <a:lstStyle/>
+                    <a:p>
+                      <a:r>
+                        <a:rPr sz="1000" b="0"/>
+                        <a:t>MiniCheck DeBERTa-v3-large</a:t>
+                      </a:r>
+                    </a:p>
+                  </a:txBody>
+                  <a:tcPr/>
+                </a:tc>
+                <a:tc>
+                  <a:txBody>
+                    <a:bodyPr/>
+                    <a:lstStyle/>
+                    <a:p>
+                      <a:r>
+                        <a:rPr sz="1000" b="0"/>
+                        <a:t>whole course, windowed</a:t>
+                      </a:r>
+                    </a:p>
+                  </a:txBody>
+                  <a:tcPr/>
+                </a:tc>
+                <a:tc>
+                  <a:txBody>
+                    <a:bodyPr/>
+                    <a:lstStyle/>
+                    <a:p>
+                      <a:r>
+                        <a:rPr sz="1000" b="0"/>
+                        <a:t>0.73</a:t>
+                      </a:r>
+                    </a:p>
+                  </a:txBody>
+                  <a:tcPr/>
+                </a:tc>
+                <a:tc>
+                  <a:txBody>
+                    <a:bodyPr/>
+                    <a:lstStyle/>
+                    <a:p>
+                      <a:r>
+                        <a:rPr sz="1000" b="0"/>
+                        <a:t>0.41</a:t>
+                      </a:r>
+                    </a:p>
+                  </a:txBody>
+                  <a:tcPr/>
+                </a:tc>
+                <a:tc>
+                  <a:txBody>
+                    <a:bodyPr/>
+                    <a:lstStyle/>
+                    <a:p>
+                      <a:r>
+                        <a:rPr sz="1000" b="0"/>
+                        <a:t>0.57</a:t>
+                      </a:r>
+                    </a:p>
+                  </a:txBody>
+                  <a:tcPr/>
+                </a:tc>
+                <a:tc>
+                  <a:txBody>
+                    <a:bodyPr/>
+                    <a:lstStyle/>
+                    <a:p>
+                      <a:r>
+                        <a:rPr sz="1000" b="0"/>
+                        <a:t>0.31</a:t>
+                      </a:r>
+                    </a:p>
+                  </a:txBody>
+                  <a:tcPr/>
+                </a:tc>
+                <a:tc>
+                  <a:txBody>
+                    <a:bodyPr/>
+                    <a:lstStyle/>
+                    <a:p>
+                      <a:r>
+                        <a:rPr sz="1000" b="0"/>
+                        <a:t>28%</a:t>
+                      </a:r>
+                    </a:p>
+                  </a:txBody>
+                  <a:tcPr/>
+                </a:tc>
+              </a:tr>
+              <a:tr h="365760">
+                <a:tc>
+                  <a:txBody>
+                    <a:bodyPr/>
+                    <a:lstStyle/>
+                    <a:p>
+                      <a:r>
+                        <a:rPr sz="1000" b="0"/>
+                        <a:t>DeBERTa-v3-large NLI</a:t>
+                      </a:r>
+                    </a:p>
+                  </a:txBody>
+                  <a:tcPr/>
+                </a:tc>
+                <a:tc>
+                  <a:txBody>
+                    <a:bodyPr/>
+                    <a:lstStyle/>
+                    <a:p>
+                      <a:r>
+                        <a:rPr sz="1000" b="0"/>
+                        <a:t>top-3 sentences</a:t>
+                      </a:r>
+                    </a:p>
+                  </a:txBody>
+                  <a:tcPr/>
+                </a:tc>
+                <a:tc>
+                  <a:txBody>
+                    <a:bodyPr/>
+                    <a:lstStyle/>
+                    <a:p>
+                      <a:r>
+                        <a:rPr sz="1000" b="0"/>
+                        <a:t>0.75</a:t>
+                      </a:r>
+                    </a:p>
+                  </a:txBody>
+                  <a:tcPr/>
+                </a:tc>
+                <a:tc>
+                  <a:txBody>
+                    <a:bodyPr/>
+                    <a:lstStyle/>
+                    <a:p>
+                      <a:r>
+                        <a:rPr sz="1000" b="0"/>
+                        <a:t>0.36</a:t>
+                      </a:r>
+                    </a:p>
+                  </a:txBody>
+                  <a:tcPr/>
+                </a:tc>
+                <a:tc>
+                  <a:txBody>
+                    <a:bodyPr/>
+                    <a:lstStyle/>
+                    <a:p>
+                      <a:r>
+                        <a:rPr sz="1000" b="0"/>
+                        <a:t>0.74</a:t>
+                      </a:r>
+                    </a:p>
+                  </a:txBody>
+                  <a:tcPr/>
+                </a:tc>
+                <a:tc>
+                  <a:txBody>
+                    <a:bodyPr/>
+                    <a:lstStyle/>
+                    <a:p>
+                      <a:r>
+                        <a:rPr sz="1000" b="0"/>
+                        <a:t>0.29</a:t>
+                      </a:r>
+                    </a:p>
+                  </a:txBody>
+                  <a:tcPr/>
+                </a:tc>
+                <a:tc>
+                  <a:txBody>
+                    <a:bodyPr/>
+                    <a:lstStyle/>
+                    <a:p>
+                      <a:r>
+                        <a:rPr sz="1000" b="0"/>
+                        <a:t>42%</a:t>
+                      </a:r>
+                    </a:p>
+                  </a:txBody>
+                  <a:tcPr/>
+                </a:tc>
+              </a:tr>
+              <a:tr h="365760">
+                <a:tc>
+                  <a:txBody>
+                    <a:bodyPr/>
+                    <a:lstStyle/>
+                    <a:p>
+                      <a:r>
+                        <a:rPr sz="1000" b="0"/>
+                        <a:t>MiniCheck DeBERTa-v3-large</a:t>
+                      </a:r>
+                    </a:p>
+                  </a:txBody>
+                  <a:tcPr/>
+                </a:tc>
+                <a:tc>
+                  <a:txBody>
+                    <a:bodyPr/>
+                    <a:lstStyle/>
+                    <a:p>
+                      <a:r>
+                        <a:rPr sz="1000" b="0"/>
+                        <a:t>top-3 sentences</a:t>
+                      </a:r>
+                    </a:p>
+                  </a:txBody>
+                  <a:tcPr/>
+                </a:tc>
+                <a:tc>
+                  <a:txBody>
+                    <a:bodyPr/>
+                    <a:lstStyle/>
+                    <a:p>
+                      <a:r>
+                        <a:rPr sz="1000" b="0"/>
+                        <a:t>0.73</a:t>
+                      </a:r>
+                    </a:p>
+                  </a:txBody>
+                  <a:tcPr/>
+                </a:tc>
+                <a:tc>
+                  <a:txBody>
+                    <a:bodyPr/>
+                    <a:lstStyle/>
+                    <a:p>
+                      <a:r>
+                        <a:rPr sz="1000" b="0"/>
+                        <a:t>0.34</a:t>
+                      </a:r>
+                    </a:p>
+                  </a:txBody>
+                  <a:tcPr/>
+                </a:tc>
+                <a:tc>
+                  <a:txBody>
+                    <a:bodyPr/>
+                    <a:lstStyle/>
+                    <a:p>
+                      <a:r>
+                        <a:rPr sz="1000" b="0"/>
+                        <a:t>0.68</a:t>
+                      </a:r>
+                    </a:p>
+                  </a:txBody>
+                  <a:tcPr/>
+                </a:tc>
+                <a:tc>
+                  <a:txBody>
+                    <a:bodyPr/>
+                    <a:lstStyle/>
+                    <a:p>
+                      <a:r>
+                        <a:rPr sz="1000" b="0"/>
+                        <a:t>0.25</a:t>
+                      </a:r>
+                    </a:p>
+                  </a:txBody>
+                  <a:tcPr/>
+                </a:tc>
+                <a:tc>
+                  <a:txBody>
+                    <a:bodyPr/>
+                    <a:lstStyle/>
+                    <a:p>
+                      <a:r>
+                        <a:rPr sz="1000" b="0"/>
+                        <a:t>41%</a:t>
+                      </a:r>
+                    </a:p>
+                  </a:txBody>
+                  <a:tcPr/>
+                </a:tc>
+              </a:tr>
+              <a:tr h="365760">
+                <a:tc>
+                  <a:txBody>
+                    <a:bodyPr/>
+                    <a:lstStyle/>
+                    <a:p>
+                      <a:r>
+                        <a:rPr sz="1000" b="0"/>
+                        <a:t>MiniCheck RoBERTa-large</a:t>
+                      </a:r>
+                    </a:p>
+                  </a:txBody>
+                  <a:tcPr/>
+                </a:tc>
+                <a:tc>
+                  <a:txBody>
+                    <a:bodyPr/>
+                    <a:lstStyle/>
+                    <a:p>
+                      <a:r>
+                        <a:rPr sz="1000" b="0"/>
+                        <a:t>whole course, windowed</a:t>
+                      </a:r>
+                    </a:p>
+                  </a:txBody>
+                  <a:tcPr/>
+                </a:tc>
+                <a:tc>
+                  <a:txBody>
+                    <a:bodyPr/>
+                    <a:lstStyle/>
+                    <a:p>
+                      <a:r>
+                        <a:rPr sz="1000" b="0"/>
+                        <a:t>0.72</a:t>
+                      </a:r>
+                    </a:p>
+                  </a:txBody>
+                  <a:tcPr/>
+                </a:tc>
+                <a:tc>
+                  <a:txBody>
+                    <a:bodyPr/>
+                    <a:lstStyle/>
+                    <a:p>
+                      <a:r>
+                        <a:rPr sz="1000" b="0"/>
+                        <a:t>0.41</a:t>
+                      </a:r>
+                    </a:p>
+                  </a:txBody>
+                  <a:tcPr/>
+                </a:tc>
+                <a:tc>
+                  <a:txBody>
+                    <a:bodyPr/>
+                    <a:lstStyle/>
+                    <a:p>
+                      <a:r>
+                        <a:rPr sz="1000" b="0"/>
+                        <a:t>0.36</a:t>
+                      </a:r>
+                    </a:p>
+                  </a:txBody>
+                  <a:tcPr/>
+                </a:tc>
+                <a:tc>
+                  <a:txBody>
+                    <a:bodyPr/>
+                    <a:lstStyle/>
+                    <a:p>
+                      <a:r>
+                        <a:rPr sz="1000" b="0"/>
+                        <a:t>0.24</a:t>
+                      </a:r>
+                    </a:p>
+                  </a:txBody>
+                  <a:tcPr/>
+                </a:tc>
+                <a:tc>
+                  <a:txBody>
+                    <a:bodyPr/>
+                    <a:lstStyle/>
+                    <a:p>
+                      <a:r>
+                        <a:rPr sz="1000" b="0"/>
+                        <a:t>18%</a:t>
+                      </a:r>
+                    </a:p>
+                  </a:txBody>
+                  <a:tcPr/>
+                </a:tc>
+              </a:tr>
+              <a:tr h="365760">
+                <a:tc>
+                  <a:txBody>
+                    <a:bodyPr/>
+                    <a:lstStyle/>
+                    <a:p>
+                      <a:r>
+                        <a:rPr sz="1000" b="0"/>
+                        <a:t>MiniCheck RoBERTa-large</a:t>
+                      </a:r>
+                    </a:p>
+                  </a:txBody>
+                  <a:tcPr/>
+                </a:tc>
+                <a:tc>
+                  <a:txBody>
+                    <a:bodyPr/>
+                    <a:lstStyle/>
+                    <a:p>
+                      <a:r>
+                        <a:rPr sz="1000" b="0"/>
+                        <a:t>top-3 sentences</a:t>
+                      </a:r>
+                    </a:p>
+                  </a:txBody>
+                  <a:tcPr/>
+                </a:tc>
+                <a:tc>
+                  <a:txBody>
+                    <a:bodyPr/>
+                    <a:lstStyle/>
+                    <a:p>
+                      <a:r>
+                        <a:rPr sz="1000" b="0"/>
+                        <a:t>0.70</a:t>
+                      </a:r>
+                    </a:p>
+                  </a:txBody>
+                  <a:tcPr/>
+                </a:tc>
+                <a:tc>
+                  <a:txBody>
+                    <a:bodyPr/>
+                    <a:lstStyle/>
+                    <a:p>
+                      <a:r>
+                        <a:rPr sz="1000" b="0"/>
+                        <a:t>0.33</a:t>
+                      </a:r>
+                    </a:p>
+                  </a:txBody>
+                  <a:tcPr/>
+                </a:tc>
+                <a:tc>
+                  <a:txBody>
+                    <a:bodyPr/>
+                    <a:lstStyle/>
+                    <a:p>
+                      <a:r>
+                        <a:rPr sz="1000" b="0"/>
+                        <a:t>0.60</a:t>
+                      </a:r>
+                    </a:p>
+                  </a:txBody>
+                  <a:tcPr/>
+                </a:tc>
+                <a:tc>
+                  <a:txBody>
+                    <a:bodyPr/>
+                    <a:lstStyle/>
+                    <a:p>
+                      <a:r>
+                        <a:rPr sz="1000" b="0"/>
+                        <a:t>0.22</a:t>
+                      </a:r>
+                    </a:p>
+                  </a:txBody>
+                  <a:tcPr/>
+                </a:tc>
+                <a:tc>
+                  <a:txBody>
+                    <a:bodyPr/>
+                    <a:lstStyle/>
+                    <a:p>
+                      <a:r>
+                        <a:rPr sz="1000" b="0"/>
+                        <a:t>37%</a:t>
+                      </a:r>
+                    </a:p>
+                  </a:txBody>
+                  <a:tcPr/>
+                </a:tc>
+              </a:tr>
+              <a:tr h="365760">
+                <a:tc>
+                  <a:txBody>
+                    <a:bodyPr/>
+                    <a:lstStyle/>
+                    <a:p>
+                      <a:r>
+                        <a:rPr sz="1000" b="0"/>
+                        <a:t>DeBERTa-v3-large cross-encoder NLI</a:t>
+                      </a:r>
+                    </a:p>
+                  </a:txBody>
+                  <a:tcPr/>
+                </a:tc>
+                <a:tc>
+                  <a:txBody>
+                    <a:bodyPr/>
+                    <a:lstStyle/>
+                    <a:p>
+                      <a:r>
+                        <a:rPr sz="1000" b="0"/>
+                        <a:t>top-3 sentences</a:t>
+                      </a:r>
+                    </a:p>
+                  </a:txBody>
+                  <a:tcPr/>
+                </a:tc>
+                <a:tc>
+                  <a:txBody>
+                    <a:bodyPr/>
+                    <a:lstStyle/>
+                    <a:p>
+                      <a:r>
+                        <a:rPr sz="1000" b="0"/>
+                        <a:t>0.69</a:t>
+                      </a:r>
+                    </a:p>
+                  </a:txBody>
+                  <a:tcPr/>
+                </a:tc>
+                <a:tc>
+                  <a:txBody>
+                    <a:bodyPr/>
+                    <a:lstStyle/>
+                    <a:p>
+                      <a:r>
+                        <a:rPr sz="1000" b="0"/>
+                        <a:t>0.28</a:t>
+                      </a:r>
+                    </a:p>
+                  </a:txBody>
+                  <a:tcPr/>
+                </a:tc>
+                <a:tc>
+                  <a:txBody>
+                    <a:bodyPr/>
+                    <a:lstStyle/>
+                    <a:p>
+                      <a:r>
+                        <a:rPr sz="1000" b="0"/>
+                        <a:t>0.85</a:t>
+                      </a:r>
+                    </a:p>
+                  </a:txBody>
+                  <a:tcPr/>
+                </a:tc>
+                <a:tc>
+                  <a:txBody>
+                    <a:bodyPr/>
+                    <a:lstStyle/>
+                    <a:p>
+                      <a:r>
+                        <a:rPr sz="1000" b="0"/>
+                        <a:t>0.17</a:t>
+                      </a:r>
+                    </a:p>
+                  </a:txBody>
+                  <a:tcPr/>
+                </a:tc>
+                <a:tc>
+                  <a:txBody>
+                    <a:bodyPr/>
+                    <a:lstStyle/>
+                    <a:p>
+                      <a:r>
+                        <a:rPr sz="1000" b="0"/>
+                        <a:t>62%</a:t>
+                      </a:r>
+                    </a:p>
+                  </a:txBody>
+                  <a:tcPr/>
+                </a:tc>
+              </a:tr>
+              <a:tr h="365760">
+                <a:tc>
+                  <a:txBody>
+                    <a:bodyPr/>
+                    <a:lstStyle/>
+                    <a:p>
+                      <a:r>
+                        <a:rPr sz="1000" b="0"/>
+                        <a:t>MiniLM cross-encoder</a:t>
+                      </a:r>
+                    </a:p>
+                  </a:txBody>
+                  <a:tcPr/>
+                </a:tc>
+                <a:tc>
+                  <a:txBody>
+                    <a:bodyPr/>
+                    <a:lstStyle/>
+                    <a:p>
+                      <a:r>
+                        <a:rPr sz="1000" b="0"/>
+                        <a:t>top-3 sentences</a:t>
+                      </a:r>
+                    </a:p>
+                  </a:txBody>
+                  <a:tcPr/>
+                </a:tc>
+                <a:tc>
+                  <a:txBody>
+                    <a:bodyPr/>
+                    <a:lstStyle/>
+                    <a:p>
+                      <a:r>
+                        <a:rPr sz="1000" b="0"/>
+                        <a:t>0.66</a:t>
+                      </a:r>
+                    </a:p>
+                  </a:txBody>
+                  <a:tcPr/>
+                </a:tc>
+                <a:tc>
+                  <a:txBody>
+                    <a:bodyPr/>
+                    <a:lstStyle/>
+                    <a:p>
+                      <a:r>
+                        <a:rPr sz="1000" b="0"/>
+                        <a:t>0.28</a:t>
+                      </a:r>
+                    </a:p>
+                  </a:txBody>
+                  <a:tcPr/>
+                </a:tc>
+                <a:tc>
+                  <a:txBody>
+                    <a:bodyPr/>
+                    <a:lstStyle/>
+                    <a:p>
+                      <a:r>
+                        <a:rPr sz="1000" b="0"/>
+                        <a:t>0.71</a:t>
+                      </a:r>
+                    </a:p>
+                  </a:txBody>
+                  <a:tcPr/>
+                </a:tc>
+                <a:tc>
+                  <a:txBody>
+                    <a:bodyPr/>
+                    <a:lstStyle/>
+                    <a:p>
+                      <a:r>
+                        <a:rPr sz="1000" b="0"/>
+                        <a:t>0.15</a:t>
+                      </a:r>
+                    </a:p>
+                  </a:txBody>
+                  <a:tcPr/>
+                </a:tc>
+                <a:tc>
+                  <a:txBody>
+                    <a:bodyPr/>
+                    <a:lstStyle/>
+                    <a:p>
+                      <a:r>
+                        <a:rPr sz="1000" b="0"/>
+                        <a:t>52%</a:t>
+                      </a:r>
+                    </a:p>
+                  </a:txBody>
+                  <a:tcPr/>
+                </a:tc>
+              </a:tr>
+              <a:tr h="365760">
+                <a:tc>
+                  <a:txBody>
+                    <a:bodyPr/>
+                    <a:lstStyle/>
+                    <a:p>
+                      <a:r>
+                        <a:rPr sz="1000" b="0"/>
+                        <a:t>DeBERTa-v3-large cross-encoder NLI</a:t>
+                      </a:r>
+                    </a:p>
+                  </a:txBody>
+                  <a:tcPr/>
+                </a:tc>
+                <a:tc>
+                  <a:txBody>
+                    <a:bodyPr/>
+                    <a:lstStyle/>
+                    <a:p>
+                      <a:r>
+                        <a:rPr sz="1000" b="0"/>
+                        <a:t>whole course, windowed</a:t>
+                      </a:r>
+                    </a:p>
+                  </a:txBody>
+                  <a:tcPr/>
+                </a:tc>
+                <a:tc>
+                  <a:txBody>
+                    <a:bodyPr/>
+                    <a:lstStyle/>
+                    <a:p>
+                      <a:r>
+                        <a:rPr sz="1000" b="0"/>
+                        <a:t>0.64</a:t>
+                      </a:r>
+                    </a:p>
+                  </a:txBody>
+                  <a:tcPr/>
+                </a:tc>
+                <a:tc>
+                  <a:txBody>
+                    <a:bodyPr/>
+                    <a:lstStyle/>
+                    <a:p>
+                      <a:r>
+                        <a:rPr sz="1000" b="0"/>
+                        <a:t>0.27</a:t>
+                      </a:r>
+                    </a:p>
+                  </a:txBody>
+                  <a:tcPr/>
+                </a:tc>
+                <a:tc>
+                  <a:txBody>
+                    <a:bodyPr/>
+                    <a:lstStyle/>
+                    <a:p>
+                      <a:r>
+                        <a:rPr sz="1000" b="0"/>
+                        <a:t>0.60</a:t>
+                      </a:r>
+                    </a:p>
+                  </a:txBody>
+                  <a:tcPr/>
+                </a:tc>
+                <a:tc>
+                  <a:txBody>
+                    <a:bodyPr/>
+                    <a:lstStyle/>
+                    <a:p>
+                      <a:r>
+                        <a:rPr sz="1000" b="0"/>
+                        <a:t>0.13</a:t>
+                      </a:r>
+                    </a:p>
+                  </a:txBody>
+                  <a:tcPr/>
+                </a:tc>
+                <a:tc>
+                  <a:txBody>
+                    <a:bodyPr/>
+                    <a:lstStyle/>
+                    <a:p>
+                      <a:r>
+                        <a:rPr sz="1000" b="0"/>
+                        <a:t>44%</a:t>
+                      </a:r>
+                    </a:p>
+                  </a:txBody>
+                  <a:tcPr/>
+                </a:tc>
+              </a:tr>
+              <a:tr h="365760">
+                <a:tc>
+                  <a:txBody>
+                    <a:bodyPr/>
+                    <a:lstStyle/>
+                    <a:p>
+                      <a:r>
+                        <a:rPr sz="1000" b="0"/>
+                        <a:t>MiniLM cross-encoder</a:t>
+                      </a:r>
+                    </a:p>
+                  </a:txBody>
+                  <a:tcPr/>
+                </a:tc>
+                <a:tc>
+                  <a:txBody>
+                    <a:bodyPr/>
+                    <a:lstStyle/>
+                    <a:p>
+                      <a:r>
+                        <a:rPr sz="1000" b="0"/>
+                        <a:t>whole course, windowed</a:t>
+                      </a:r>
+                    </a:p>
+                  </a:txBody>
+                  <a:tcPr/>
+                </a:tc>
+                <a:tc>
+                  <a:txBody>
+                    <a:bodyPr/>
+                    <a:lstStyle/>
+                    <a:p>
+                      <a:r>
+                        <a:rPr sz="1000" b="0"/>
+                        <a:t>0.58</a:t>
+                      </a:r>
+                    </a:p>
+                  </a:txBody>
+                  <a:tcPr/>
+                </a:tc>
+                <a:tc>
+                  <a:txBody>
+                    <a:bodyPr/>
+                    <a:lstStyle/>
+                    <a:p>
+                      <a:r>
+                        <a:rPr sz="1000" b="0"/>
+                        <a:t>0.24</a:t>
+                      </a:r>
+                    </a:p>
+                  </a:txBody>
+                  <a:tcPr/>
+                </a:tc>
+                <a:tc>
+                  <a:txBody>
+                    <a:bodyPr/>
+                    <a:lstStyle/>
+                    <a:p>
+                      <a:r>
+                        <a:rPr sz="1000" b="0"/>
+                        <a:t>0.68</a:t>
+                      </a:r>
+                    </a:p>
+                  </a:txBody>
+                  <a:tcPr/>
+                </a:tc>
+                <a:tc>
+                  <a:txBody>
+                    <a:bodyPr/>
+                    <a:lstStyle/>
+                    <a:p>
+                      <a:r>
+                        <a:rPr sz="1000" b="0"/>
+                        <a:t>0.07</a:t>
+                      </a:r>
+                    </a:p>
+                  </a:txBody>
+                  <a:tcPr/>
+                </a:tc>
+                <a:tc>
+                  <a:txBody>
+                    <a:bodyPr/>
+                    <a:lstStyle/>
+                    <a:p>
+                      <a:r>
+                        <a:rPr sz="1000" b="0"/>
+                        <a:t>58%</a:t>
+                      </a:r>
+                    </a:p>
+                  </a:txBody>
+                  <a:tcPr/>
+                </a:tc>
+              </a:tr>
+            </a:tbl>
+          </a:graphicData>
+        </a:graphic>
+      </p:graphicFrame>
+      <p:sp>
+        <p:nvSpPr>
+          <p:cNvPr id="4" name="TextBox 3"/>
+          <p:cNvSpPr txBox="1"/>
+          <p:nvPr/>
+        </p:nvSpPr>
+        <p:spPr>
+          <a:xfrm>
+            <a:off x="365760" y="5943600"/>
+            <a:ext cx="11430000" cy="731520"/>
+          </a:xfrm>
+          <a:prstGeom prst="rect">
+            <a:avLst/>
+          </a:prstGeom>
+          <a:noFill/>
+        </p:spPr>
+        <p:txBody>
+          <a:bodyPr wrap="square">
+            <a:spAutoFit/>
+          </a:bodyPr>
+          <a:lstStyle/>
+          <a:p>
+            <a:r>
+              <a:rPr sz="1200"/>
+              <a:t>Decision rule fixed in advance: highest kappa on all sentences, threshold chosen on the other subset. Selected: DeBERTa-v3-large NLI (whole course, windowed), kappa 0.33, AUROC 0.78, precision 0.44, recall 0.54: moderate agreement, so main-study rates are estimates from an instrument with a known error profile, and the paired comparisons carry the weight.</a:t>
             </a:r>
           </a:p>
         </p:txBody>
@@ -6165,14 +7187,14 @@
           <a:p>
             <a:r>
               <a:rPr sz="2800" b="1"/>
-              <a:t>No aggregation rule rescues the judge</a:t>
+              <a:t>Judge selection: AUROC and kappa by candidate and evidence mode</a:t>
             </a:r>
           </a:p>
         </p:txBody>
       </p:sp>
       <p:pic>
         <p:nvPicPr>
-          <p:cNvPr id="3" name="Picture 2" descr="fig_variants.png"/>
+          <p:cNvPr id="3" name="Picture 2" descr="fig_judges.png"/>
           <p:cNvPicPr>
             <a:picLocks noChangeAspect="1"/>
           </p:cNvPicPr>
@@ -6187,7 +7209,7 @@
         <p:spPr>
           <a:xfrm>
             <a:off x="365760" y="1097280"/>
-            <a:ext cx="11430000" cy="5196084"/>
+            <a:ext cx="11430000" cy="5184098"/>
           </a:xfrm>
           <a:prstGeom prst="rect">
             <a:avLst/>
@@ -6218,7 +7240,7 @@
           <a:p>
             <a:r>
               <a:rPr sz="1200"/>
-              <a:t>Best kappa over all variants and thresholds: 0.14; best AUROC 0.66. The limiting factor is the small general-domain NLI model on paraphrased patient-facing sentences.</a:t>
+              <a:t>Model size and training data matter more than the aggregation rule; whole-course evidence helps the large models.</a:t>
             </a:r>
           </a:p>
         </p:txBody>

</xml_diff>

<commit_message>
Main study evaluated at the pre-specified threshold (0.20); thesis, slides and description rebuilt
- results/mimic_*.csv at tau 0.20 (DeBERTa-v3-large NLI, whole-course evidence); tau 0.5
  aggregates kept in results/mimic_tau05 for the robustness section 7.8
- ablation statements made data-driven (requiring citations lowers UFR; three-sentence
  chunks raise CR; other settings change only coverage); robustness agreement rule fixed
- abstract covers all three studies in 347 words; thesis builds at 136 pages, 68 references,
  no missing contents entries; 18 progress slides; 6-page source and data description

Co-Authored-By: Claude Fable 5.1 <noreply@anthropic.com>
</commit_message>
<xml_diff>
--- a/deliverables/Progress_Slides_Fall2026.pptx
+++ b/deliverables/Progress_Slides_Fall2026.pptx
@@ -19,6 +19,10 @@
     <p:sldId id="267" r:id="rId18"/>
     <p:sldId id="268" r:id="rId19"/>
     <p:sldId id="269" r:id="rId20"/>
+    <p:sldId id="270" r:id="rId21"/>
+    <p:sldId id="271" r:id="rId22"/>
+    <p:sldId id="272" r:id="rId23"/>
+    <p:sldId id="273" r:id="rId24"/>
   </p:sldIdLst>
   <p:sldSz cx="12191695" cy="6858000" type="screen4x3"/>
   <p:notesSz cx="6858000" cy="9144000"/>
@@ -3149,7 +3153,7 @@
           <a:p>
             <a:r>
               <a:rPr sz="1800"/>
-              <a:t>California State University, Northridge, September 15, 2026</a:t>
+              <a:t>California State University, Northridge, September 16, 2026</a:t>
             </a:r>
           </a:p>
         </p:txBody>
@@ -3332,21 +3336,796 @@
           <a:p>
             <a:r>
               <a:rPr sz="2800" b="1"/>
-              <a:t>Main study: status</a:t>
+              <a:t>Main study results (n = 110 hospital courses; judge: DeBERTa-v3-large NLI, τ = 0.20)</a:t>
             </a:r>
           </a:p>
         </p:txBody>
       </p:sp>
+      <p:graphicFrame>
+        <p:nvGraphicFramePr>
+          <p:cNvPr id="3" name="Table 2"/>
+          <p:cNvGraphicFramePr>
+            <a:graphicFrameLocks noGrp="1"/>
+          </p:cNvGraphicFramePr>
+          <p:nvPr/>
+        </p:nvGraphicFramePr>
+        <p:xfrm>
+          <a:off x="365760" y="1097280"/>
+          <a:ext cx="11429993" cy="2926080"/>
+        </p:xfrm>
+        <a:graphic>
+          <a:graphicData uri="http://schemas.openxmlformats.org/drawingml/2006/table">
+            <a:tbl>
+              <a:tblPr firstRow="1" bandRow="1">
+                <a:tableStyleId>{5C22544A-7EE6-4342-B048-85BDC9FD1C3A}</a:tableStyleId>
+              </a:tblPr>
+              <a:tblGrid>
+                <a:gridCol w="2926079"/>
+                <a:gridCol w="1417319"/>
+                <a:gridCol w="1417319"/>
+                <a:gridCol w="1417319"/>
+                <a:gridCol w="1417319"/>
+                <a:gridCol w="1417319"/>
+                <a:gridCol w="1417319"/>
+              </a:tblGrid>
+              <a:tr h="365760">
+                <a:tc>
+                  <a:txBody>
+                    <a:bodyPr/>
+                    <a:lstStyle/>
+                    <a:p>
+                      <a:r>
+                        <a:rPr sz="1100" b="1"/>
+                        <a:t>Metric</a:t>
+                      </a:r>
+                    </a:p>
+                  </a:txBody>
+                  <a:tcPr/>
+                </a:tc>
+                <a:tc>
+                  <a:txBody>
+                    <a:bodyPr/>
+                    <a:lstStyle/>
+                    <a:p>
+                      <a:r>
+                        <a:rPr sz="1100" b="1"/>
+                        <a:t>E0 zero-context</a:t>
+                      </a:r>
+                    </a:p>
+                  </a:txBody>
+                  <a:tcPr/>
+                </a:tc>
+                <a:tc>
+                  <a:txBody>
+                    <a:bodyPr/>
+                    <a:lstStyle/>
+                    <a:p>
+                      <a:r>
+                        <a:rPr sz="1100" b="1"/>
+                        <a:t>E1 RAG excerpts</a:t>
+                      </a:r>
+                    </a:p>
+                  </a:txBody>
+                  <a:tcPr/>
+                </a:tc>
+                <a:tc>
+                  <a:txBody>
+                    <a:bodyPr/>
+                    <a:lstStyle/>
+                    <a:p>
+                      <a:r>
+                        <a:rPr sz="1100" b="1"/>
+                        <a:t>E1b RAG + course</a:t>
+                      </a:r>
+                    </a:p>
+                  </a:txBody>
+                  <a:tcPr/>
+                </a:tc>
+                <a:tc>
+                  <a:txBody>
+                    <a:bodyPr/>
+                    <a:lstStyle/>
+                    <a:p>
+                      <a:r>
+                        <a:rPr sz="1100" b="1"/>
+                        <a:t>E3 RAG + CoVe</a:t>
+                      </a:r>
+                    </a:p>
+                  </a:txBody>
+                  <a:tcPr/>
+                </a:tc>
+                <a:tc>
+                  <a:txBody>
+                    <a:bodyPr/>
+                    <a:lstStyle/>
+                    <a:p>
+                      <a:r>
+                        <a:rPr sz="1100" b="1"/>
+                        <a:t>E2 extractive</a:t>
+                      </a:r>
+                    </a:p>
+                  </a:txBody>
+                  <a:tcPr/>
+                </a:tc>
+                <a:tc>
+                  <a:txBody>
+                    <a:bodyPr/>
+                    <a:lstStyle/>
+                    <a:p>
+                      <a:r>
+                        <a:rPr sz="1100" b="1"/>
+                        <a:t>Clinician-written</a:t>
+                      </a:r>
+                    </a:p>
+                  </a:txBody>
+                  <a:tcPr/>
+                </a:tc>
+              </a:tr>
+              <a:tr h="365760">
+                <a:tc>
+                  <a:txBody>
+                    <a:bodyPr/>
+                    <a:lstStyle/>
+                    <a:p>
+                      <a:r>
+                        <a:rPr sz="1000" b="0"/>
+                        <a:t>UFR mean</a:t>
+                      </a:r>
+                    </a:p>
+                  </a:txBody>
+                  <a:tcPr/>
+                </a:tc>
+                <a:tc>
+                  <a:txBody>
+                    <a:bodyPr/>
+                    <a:lstStyle/>
+                    <a:p>
+                      <a:r>
+                        <a:rPr sz="1000" b="0"/>
+                        <a:t>0.135</a:t>
+                      </a:r>
+                    </a:p>
+                  </a:txBody>
+                  <a:tcPr/>
+                </a:tc>
+                <a:tc>
+                  <a:txBody>
+                    <a:bodyPr/>
+                    <a:lstStyle/>
+                    <a:p>
+                      <a:r>
+                        <a:rPr sz="1000" b="0"/>
+                        <a:t>0.066</a:t>
+                      </a:r>
+                    </a:p>
+                  </a:txBody>
+                  <a:tcPr/>
+                </a:tc>
+                <a:tc>
+                  <a:txBody>
+                    <a:bodyPr/>
+                    <a:lstStyle/>
+                    <a:p>
+                      <a:r>
+                        <a:rPr sz="1000" b="0"/>
+                        <a:t>0.072</a:t>
+                      </a:r>
+                    </a:p>
+                  </a:txBody>
+                  <a:tcPr/>
+                </a:tc>
+                <a:tc>
+                  <a:txBody>
+                    <a:bodyPr/>
+                    <a:lstStyle/>
+                    <a:p>
+                      <a:r>
+                        <a:rPr sz="1000" b="0"/>
+                        <a:t>0.070</a:t>
+                      </a:r>
+                    </a:p>
+                  </a:txBody>
+                  <a:tcPr/>
+                </a:tc>
+                <a:tc>
+                  <a:txBody>
+                    <a:bodyPr/>
+                    <a:lstStyle/>
+                    <a:p>
+                      <a:r>
+                        <a:rPr sz="1000" b="0"/>
+                        <a:t>0.056</a:t>
+                      </a:r>
+                    </a:p>
+                  </a:txBody>
+                  <a:tcPr/>
+                </a:tc>
+                <a:tc>
+                  <a:txBody>
+                    <a:bodyPr/>
+                    <a:lstStyle/>
+                    <a:p>
+                      <a:r>
+                        <a:rPr sz="1000" b="0"/>
+                        <a:t>0.289</a:t>
+                      </a:r>
+                    </a:p>
+                  </a:txBody>
+                  <a:tcPr/>
+                </a:tc>
+              </a:tr>
+              <a:tr h="365760">
+                <a:tc>
+                  <a:txBody>
+                    <a:bodyPr/>
+                    <a:lstStyle/>
+                    <a:p>
+                      <a:r>
+                        <a:rPr sz="1000" b="0"/>
+                        <a:t>CR mean</a:t>
+                      </a:r>
+                    </a:p>
+                  </a:txBody>
+                  <a:tcPr/>
+                </a:tc>
+                <a:tc>
+                  <a:txBody>
+                    <a:bodyPr/>
+                    <a:lstStyle/>
+                    <a:p>
+                      <a:r>
+                        <a:rPr sz="1000" b="0"/>
+                        <a:t>0.029</a:t>
+                      </a:r>
+                    </a:p>
+                  </a:txBody>
+                  <a:tcPr/>
+                </a:tc>
+                <a:tc>
+                  <a:txBody>
+                    <a:bodyPr/>
+                    <a:lstStyle/>
+                    <a:p>
+                      <a:r>
+                        <a:rPr sz="1000" b="0"/>
+                        <a:t>0.027</a:t>
+                      </a:r>
+                    </a:p>
+                  </a:txBody>
+                  <a:tcPr/>
+                </a:tc>
+                <a:tc>
+                  <a:txBody>
+                    <a:bodyPr/>
+                    <a:lstStyle/>
+                    <a:p>
+                      <a:r>
+                        <a:rPr sz="1000" b="0"/>
+                        <a:t>0.031</a:t>
+                      </a:r>
+                    </a:p>
+                  </a:txBody>
+                  <a:tcPr/>
+                </a:tc>
+                <a:tc>
+                  <a:txBody>
+                    <a:bodyPr/>
+                    <a:lstStyle/>
+                    <a:p>
+                      <a:r>
+                        <a:rPr sz="1000" b="0"/>
+                        <a:t>0.032</a:t>
+                      </a:r>
+                    </a:p>
+                  </a:txBody>
+                  <a:tcPr/>
+                </a:tc>
+                <a:tc>
+                  <a:txBody>
+                    <a:bodyPr/>
+                    <a:lstStyle/>
+                    <a:p>
+                      <a:r>
+                        <a:rPr sz="1000" b="0"/>
+                        <a:t>0.051</a:t>
+                      </a:r>
+                    </a:p>
+                  </a:txBody>
+                  <a:tcPr/>
+                </a:tc>
+                <a:tc>
+                  <a:txBody>
+                    <a:bodyPr/>
+                    <a:lstStyle/>
+                    <a:p>
+                      <a:r>
+                        <a:rPr sz="1000" b="0"/>
+                        <a:t>0.080</a:t>
+                      </a:r>
+                    </a:p>
+                  </a:txBody>
+                  <a:tcPr/>
+                </a:tc>
+              </a:tr>
+              <a:tr h="365760">
+                <a:tc>
+                  <a:txBody>
+                    <a:bodyPr/>
+                    <a:lstStyle/>
+                    <a:p>
+                      <a:r>
+                        <a:rPr sz="1000" b="0"/>
+                        <a:t>Coverage of the clinician's sentences</a:t>
+                      </a:r>
+                    </a:p>
+                  </a:txBody>
+                  <a:tcPr/>
+                </a:tc>
+                <a:tc>
+                  <a:txBody>
+                    <a:bodyPr/>
+                    <a:lstStyle/>
+                    <a:p>
+                      <a:r>
+                        <a:rPr sz="1000" b="0"/>
+                        <a:t>54.3%</a:t>
+                      </a:r>
+                    </a:p>
+                  </a:txBody>
+                  <a:tcPr/>
+                </a:tc>
+                <a:tc>
+                  <a:txBody>
+                    <a:bodyPr/>
+                    <a:lstStyle/>
+                    <a:p>
+                      <a:r>
+                        <a:rPr sz="1000" b="0"/>
+                        <a:t>36.9%</a:t>
+                      </a:r>
+                    </a:p>
+                  </a:txBody>
+                  <a:tcPr/>
+                </a:tc>
+                <a:tc>
+                  <a:txBody>
+                    <a:bodyPr/>
+                    <a:lstStyle/>
+                    <a:p>
+                      <a:r>
+                        <a:rPr sz="1000" b="0"/>
+                        <a:t>53.2%</a:t>
+                      </a:r>
+                    </a:p>
+                  </a:txBody>
+                  <a:tcPr/>
+                </a:tc>
+                <a:tc>
+                  <a:txBody>
+                    <a:bodyPr/>
+                    <a:lstStyle/>
+                    <a:p>
+                      <a:r>
+                        <a:rPr sz="1000" b="0"/>
+                        <a:t>33.6%</a:t>
+                      </a:r>
+                    </a:p>
+                  </a:txBody>
+                  <a:tcPr/>
+                </a:tc>
+                <a:tc>
+                  <a:txBody>
+                    <a:bodyPr/>
+                    <a:lstStyle/>
+                    <a:p>
+                      <a:r>
+                        <a:rPr sz="1000" b="0"/>
+                        <a:t>22.5%</a:t>
+                      </a:r>
+                    </a:p>
+                  </a:txBody>
+                  <a:tcPr/>
+                </a:tc>
+                <a:tc>
+                  <a:txBody>
+                    <a:bodyPr/>
+                    <a:lstStyle/>
+                    <a:p>
+                      <a:r>
+                        <a:rPr sz="1000" b="0"/>
+                        <a:t>—</a:t>
+                      </a:r>
+                    </a:p>
+                  </a:txBody>
+                  <a:tcPr/>
+                </a:tc>
+              </a:tr>
+              <a:tr h="365760">
+                <a:tc>
+                  <a:txBody>
+                    <a:bodyPr/>
+                    <a:lstStyle/>
+                    <a:p>
+                      <a:r>
+                        <a:rPr sz="1000" b="0"/>
+                        <a:t>Citation accuracy</a:t>
+                      </a:r>
+                    </a:p>
+                  </a:txBody>
+                  <a:tcPr/>
+                </a:tc>
+                <a:tc>
+                  <a:txBody>
+                    <a:bodyPr/>
+                    <a:lstStyle/>
+                    <a:p>
+                      <a:r>
+                        <a:rPr sz="1000" b="0"/>
+                        <a:t>—</a:t>
+                      </a:r>
+                    </a:p>
+                  </a:txBody>
+                  <a:tcPr/>
+                </a:tc>
+                <a:tc>
+                  <a:txBody>
+                    <a:bodyPr/>
+                    <a:lstStyle/>
+                    <a:p>
+                      <a:r>
+                        <a:rPr sz="1000" b="0"/>
+                        <a:t>71.8%</a:t>
+                      </a:r>
+                    </a:p>
+                  </a:txBody>
+                  <a:tcPr/>
+                </a:tc>
+                <a:tc>
+                  <a:txBody>
+                    <a:bodyPr/>
+                    <a:lstStyle/>
+                    <a:p>
+                      <a:r>
+                        <a:rPr sz="1000" b="0"/>
+                        <a:t>38.1%</a:t>
+                      </a:r>
+                    </a:p>
+                  </a:txBody>
+                  <a:tcPr/>
+                </a:tc>
+                <a:tc>
+                  <a:txBody>
+                    <a:bodyPr/>
+                    <a:lstStyle/>
+                    <a:p>
+                      <a:r>
+                        <a:rPr sz="1000" b="0"/>
+                        <a:t>—</a:t>
+                      </a:r>
+                    </a:p>
+                  </a:txBody>
+                  <a:tcPr/>
+                </a:tc>
+                <a:tc>
+                  <a:txBody>
+                    <a:bodyPr/>
+                    <a:lstStyle/>
+                    <a:p>
+                      <a:r>
+                        <a:rPr sz="1000" b="0"/>
+                        <a:t>—</a:t>
+                      </a:r>
+                    </a:p>
+                  </a:txBody>
+                  <a:tcPr/>
+                </a:tc>
+                <a:tc>
+                  <a:txBody>
+                    <a:bodyPr/>
+                    <a:lstStyle/>
+                    <a:p>
+                      <a:r>
+                        <a:rPr sz="1000" b="0"/>
+                        <a:t>—</a:t>
+                      </a:r>
+                    </a:p>
+                  </a:txBody>
+                  <a:tcPr/>
+                </a:tc>
+              </a:tr>
+              <a:tr h="365760">
+                <a:tc>
+                  <a:txBody>
+                    <a:bodyPr/>
+                    <a:lstStyle/>
+                    <a:p>
+                      <a:r>
+                        <a:rPr sz="1000" b="0"/>
+                        <a:t>Abstentions per summary</a:t>
+                      </a:r>
+                    </a:p>
+                  </a:txBody>
+                  <a:tcPr/>
+                </a:tc>
+                <a:tc>
+                  <a:txBody>
+                    <a:bodyPr/>
+                    <a:lstStyle/>
+                    <a:p>
+                      <a:r>
+                        <a:rPr sz="1000" b="0"/>
+                        <a:t>0.0</a:t>
+                      </a:r>
+                    </a:p>
+                  </a:txBody>
+                  <a:tcPr/>
+                </a:tc>
+                <a:tc>
+                  <a:txBody>
+                    <a:bodyPr/>
+                    <a:lstStyle/>
+                    <a:p>
+                      <a:r>
+                        <a:rPr sz="1000" b="0"/>
+                        <a:t>0.0</a:t>
+                      </a:r>
+                    </a:p>
+                  </a:txBody>
+                  <a:tcPr/>
+                </a:tc>
+                <a:tc>
+                  <a:txBody>
+                    <a:bodyPr/>
+                    <a:lstStyle/>
+                    <a:p>
+                      <a:r>
+                        <a:rPr sz="1000" b="0"/>
+                        <a:t>0.0</a:t>
+                      </a:r>
+                    </a:p>
+                  </a:txBody>
+                  <a:tcPr/>
+                </a:tc>
+                <a:tc>
+                  <a:txBody>
+                    <a:bodyPr/>
+                    <a:lstStyle/>
+                    <a:p>
+                      <a:r>
+                        <a:rPr sz="1000" b="0"/>
+                        <a:t>0.7</a:t>
+                      </a:r>
+                    </a:p>
+                  </a:txBody>
+                  <a:tcPr/>
+                </a:tc>
+                <a:tc>
+                  <a:txBody>
+                    <a:bodyPr/>
+                    <a:lstStyle/>
+                    <a:p>
+                      <a:r>
+                        <a:rPr sz="1000" b="0"/>
+                        <a:t>0.0</a:t>
+                      </a:r>
+                    </a:p>
+                  </a:txBody>
+                  <a:tcPr/>
+                </a:tc>
+                <a:tc>
+                  <a:txBody>
+                    <a:bodyPr/>
+                    <a:lstStyle/>
+                    <a:p>
+                      <a:r>
+                        <a:rPr sz="1000" b="0"/>
+                        <a:t>0.0</a:t>
+                      </a:r>
+                    </a:p>
+                  </a:txBody>
+                  <a:tcPr/>
+                </a:tc>
+              </a:tr>
+              <a:tr h="365760">
+                <a:tc>
+                  <a:txBody>
+                    <a:bodyPr/>
+                    <a:lstStyle/>
+                    <a:p>
+                      <a:r>
+                        <a:rPr sz="1000" b="0"/>
+                        <a:t>Claims per summary</a:t>
+                      </a:r>
+                    </a:p>
+                  </a:txBody>
+                  <a:tcPr/>
+                </a:tc>
+                <a:tc>
+                  <a:txBody>
+                    <a:bodyPr/>
+                    <a:lstStyle/>
+                    <a:p>
+                      <a:r>
+                        <a:rPr sz="1000" b="0"/>
+                        <a:t>16.0</a:t>
+                      </a:r>
+                    </a:p>
+                  </a:txBody>
+                  <a:tcPr/>
+                </a:tc>
+                <a:tc>
+                  <a:txBody>
+                    <a:bodyPr/>
+                    <a:lstStyle/>
+                    <a:p>
+                      <a:r>
+                        <a:rPr sz="1000" b="0"/>
+                        <a:t>8.4</a:t>
+                      </a:r>
+                    </a:p>
+                  </a:txBody>
+                  <a:tcPr/>
+                </a:tc>
+                <a:tc>
+                  <a:txBody>
+                    <a:bodyPr/>
+                    <a:lstStyle/>
+                    <a:p>
+                      <a:r>
+                        <a:rPr sz="1000" b="0"/>
+                        <a:t>13.8</a:t>
+                      </a:r>
+                    </a:p>
+                  </a:txBody>
+                  <a:tcPr/>
+                </a:tc>
+                <a:tc>
+                  <a:txBody>
+                    <a:bodyPr/>
+                    <a:lstStyle/>
+                    <a:p>
+                      <a:r>
+                        <a:rPr sz="1000" b="0"/>
+                        <a:t>7.9</a:t>
+                      </a:r>
+                    </a:p>
+                  </a:txBody>
+                  <a:tcPr/>
+                </a:tc>
+                <a:tc>
+                  <a:txBody>
+                    <a:bodyPr/>
+                    <a:lstStyle/>
+                    <a:p>
+                      <a:r>
+                        <a:rPr sz="1000" b="0"/>
+                        <a:t>4.9</a:t>
+                      </a:r>
+                    </a:p>
+                  </a:txBody>
+                  <a:tcPr/>
+                </a:tc>
+                <a:tc>
+                  <a:txBody>
+                    <a:bodyPr/>
+                    <a:lstStyle/>
+                    <a:p>
+                      <a:r>
+                        <a:rPr sz="1000" b="0"/>
+                        <a:t>8.9</a:t>
+                      </a:r>
+                    </a:p>
+                  </a:txBody>
+                  <a:tcPr/>
+                </a:tc>
+              </a:tr>
+              <a:tr h="365760">
+                <a:tc>
+                  <a:txBody>
+                    <a:bodyPr/>
+                    <a:lstStyle/>
+                    <a:p>
+                      <a:r>
+                        <a:rPr sz="1000" b="0"/>
+                        <a:t>Words per summary</a:t>
+                      </a:r>
+                    </a:p>
+                  </a:txBody>
+                  <a:tcPr/>
+                </a:tc>
+                <a:tc>
+                  <a:txBody>
+                    <a:bodyPr/>
+                    <a:lstStyle/>
+                    <a:p>
+                      <a:r>
+                        <a:rPr sz="1000" b="0"/>
+                        <a:t>261</a:t>
+                      </a:r>
+                    </a:p>
+                  </a:txBody>
+                  <a:tcPr/>
+                </a:tc>
+                <a:tc>
+                  <a:txBody>
+                    <a:bodyPr/>
+                    <a:lstStyle/>
+                    <a:p>
+                      <a:r>
+                        <a:rPr sz="1000" b="0"/>
+                        <a:t>151</a:t>
+                      </a:r>
+                    </a:p>
+                  </a:txBody>
+                  <a:tcPr/>
+                </a:tc>
+                <a:tc>
+                  <a:txBody>
+                    <a:bodyPr/>
+                    <a:lstStyle/>
+                    <a:p>
+                      <a:r>
+                        <a:rPr sz="1000" b="0"/>
+                        <a:t>228</a:t>
+                      </a:r>
+                    </a:p>
+                  </a:txBody>
+                  <a:tcPr/>
+                </a:tc>
+                <a:tc>
+                  <a:txBody>
+                    <a:bodyPr/>
+                    <a:lstStyle/>
+                    <a:p>
+                      <a:r>
+                        <a:rPr sz="1000" b="0"/>
+                        <a:t>150</a:t>
+                      </a:r>
+                    </a:p>
+                  </a:txBody>
+                  <a:tcPr/>
+                </a:tc>
+                <a:tc>
+                  <a:txBody>
+                    <a:bodyPr/>
+                    <a:lstStyle/>
+                    <a:p>
+                      <a:r>
+                        <a:rPr sz="1000" b="0"/>
+                        <a:t>87</a:t>
+                      </a:r>
+                    </a:p>
+                  </a:txBody>
+                  <a:tcPr/>
+                </a:tc>
+                <a:tc>
+                  <a:txBody>
+                    <a:bodyPr/>
+                    <a:lstStyle/>
+                    <a:p>
+                      <a:r>
+                        <a:rPr sz="1000" b="0"/>
+                        <a:t>133</a:t>
+                      </a:r>
+                    </a:p>
+                  </a:txBody>
+                  <a:tcPr/>
+                </a:tc>
+              </a:tr>
+            </a:tbl>
+          </a:graphicData>
+        </a:graphic>
+      </p:graphicFrame>
       <p:sp>
         <p:nvSpPr>
-          <p:cNvPr id="3" name="TextBox 2"/>
+          <p:cNvPr id="4" name="TextBox 3"/>
           <p:cNvSpPr txBox="1"/>
           <p:nvPr/>
         </p:nvSpPr>
         <p:spPr>
           <a:xfrm>
-            <a:off x="457200" y="1097280"/>
-            <a:ext cx="11247120" cy="5303520"/>
+            <a:off x="365760" y="5943600"/>
+            <a:ext cx="11430000" cy="731520"/>
           </a:xfrm>
           <a:prstGeom prst="rect">
             <a:avLst/>
@@ -3359,25 +4138,9 @@
           </a:bodyPr>
           <a:lstStyle/>
           <a:p>
-            <a:pPr>
-              <a:spcAft>
-                <a:spcPts val="800"/>
-              </a:spcAft>
-            </a:pPr>
-            <a:r>
-              <a:rPr sz="1600"/>
-              <a:t>• Generation of the five conditions and six retrieval variants on the 110 hospital courses is running on the laptop (about five minutes per course with the local model)</a:t>
-            </a:r>
-          </a:p>
-          <a:p>
-            <a:pPr>
-              <a:spcAft>
-                <a:spcPts val="800"/>
-              </a:spcAft>
-            </a:pPr>
-            <a:r>
-              <a:rPr sz="1600"/>
-              <a:t>• Evaluation with the selected judge, the question-answering pilot and the figures follow automatically; the thesis chapters read the result files when they exist</a:t>
+            <a:r>
+              <a:rPr sz="1200"/>
+              <a:t>E1 vs E0: UFR p &lt; 0.001, CR p = 0.791, coverage p &lt; 0.001. E1b vs E0: UFR p &lt; 0.001, CR p = 0.305, coverage p = 0.449. E3 vs E0: UFR p &lt; 0.001, CR p = 0.358, coverage p &lt; 0.001. E2 vs E0: UFR p &lt; 0.001, CR p = 0.125, coverage p &lt; 0.001. Paired two-sided Wilcoxon tests on the same documents.</a:t>
             </a:r>
           </a:p>
         </p:txBody>
@@ -3424,89 +4187,59 @@
           <a:p>
             <a:r>
               <a:rPr sz="2800" b="1"/>
-              <a:t>Thesis writing status</a:t>
+              <a:t>Main study: per-document distributions</a:t>
             </a:r>
           </a:p>
         </p:txBody>
       </p:sp>
-      <p:sp>
-        <p:nvSpPr>
-          <p:cNvPr id="3" name="TextBox 2"/>
-          <p:cNvSpPr txBox="1"/>
+      <p:pic>
+        <p:nvPicPr>
+          <p:cNvPr id="3" name="Picture 2" descr="fig_mimic_box.png"/>
+          <p:cNvPicPr>
+            <a:picLocks noChangeAspect="1"/>
+          </p:cNvPicPr>
           <p:nvPr/>
-        </p:nvSpPr>
+        </p:nvPicPr>
+        <p:blipFill>
+          <a:blip r:embed="rId2"/>
+          <a:stretch>
+            <a:fillRect/>
+          </a:stretch>
+        </p:blipFill>
         <p:spPr>
           <a:xfrm>
-            <a:off x="457200" y="1097280"/>
-            <a:ext cx="11247120" cy="5303520"/>
+            <a:off x="365760" y="1097280"/>
+            <a:ext cx="5577840" cy="2601014"/>
           </a:xfrm>
           <a:prstGeom prst="rect">
             <a:avLst/>
           </a:prstGeom>
-          <a:noFill/>
         </p:spPr>
-        <p:txBody>
-          <a:bodyPr wrap="square">
-            <a:spAutoFit/>
-          </a:bodyPr>
-          <a:lstStyle/>
-          <a:p>
-            <a:pPr>
-              <a:spcAft>
-                <a:spcPts val="800"/>
-              </a:spcAft>
-            </a:pPr>
-            <a:r>
-              <a:rPr sz="1600"/>
-              <a:t>• Complete draft generated from the result files: 107 pages in CSUN format (1-inch margins, 12-pt Times New Roman, double-spaced, roman-numbered preliminary pages, arabic body)</a:t>
-            </a:r>
-          </a:p>
-          <a:p>
-            <a:pPr>
-              <a:spcAft>
-                <a:spcPts val="800"/>
-              </a:spcAft>
-            </a:pPr>
-            <a:r>
-              <a:rPr sz="1600"/>
-              <a:t>• Nine chapters: 1 Introduction, 2 Literature Review, 3 Data, 4 Methodology, 5 Pilot Study on MTSamples, 6 Selecting a Valid Judge, 7 Main Study on MIMIC-IV, 8 Discussion, 9 Conclusion; IEEE references with DOIs; Appendices A to E (prompts, per-document results, worked examples, repository, threshold sweep)</a:t>
-            </a:r>
-          </a:p>
-          <a:p>
-            <a:pPr>
-              <a:spcAft>
-                <a:spcPts val="800"/>
-              </a:spcAft>
-            </a:pPr>
-            <a:r>
-              <a:rPr sz="1600"/>
-              <a:t>• Since the September 4 draft: judge selection study, MedNLI adaptation, main study on MIMIC-IV with a local model (citations, coverage against the clinician's instructions, citation accuracy, ablations), question-answering pilot</a:t>
-            </a:r>
-          </a:p>
-          <a:p>
-            <a:pPr>
-              <a:spcAft>
-                <a:spcPts val="800"/>
-              </a:spcAft>
-            </a:pPr>
-            <a:r>
-              <a:rPr sz="1600"/>
-              <a:t>• Open items: committee composition to be confirmed with the advisor; advisor review of the draft; final title on the ETD planning form (with or without 'and Question Answering')</a:t>
-            </a:r>
-          </a:p>
-          <a:p>
-            <a:pPr>
-              <a:spcAft>
-                <a:spcPts val="800"/>
-              </a:spcAft>
-            </a:pPr>
-            <a:r>
-              <a:rPr sz="1600"/>
-              <a:t>• Every table and figure is regenerated by one command from the result files</a:t>
-            </a:r>
-          </a:p>
-        </p:txBody>
-      </p:sp>
+      </p:pic>
+      <p:pic>
+        <p:nvPicPr>
+          <p:cNvPr id="4" name="Picture 3" descr="fig_mimic_coverage.png"/>
+          <p:cNvPicPr>
+            <a:picLocks noChangeAspect="1"/>
+          </p:cNvPicPr>
+          <p:nvPr/>
+        </p:nvPicPr>
+        <p:blipFill>
+          <a:blip r:embed="rId3"/>
+          <a:stretch>
+            <a:fillRect/>
+          </a:stretch>
+        </p:blipFill>
+        <p:spPr>
+          <a:xfrm>
+            <a:off x="6217920" y="1097280"/>
+            <a:ext cx="5577840" cy="3776238"/>
+          </a:xfrm>
+          <a:prstGeom prst="rect">
+            <a:avLst/>
+          </a:prstGeom>
+        </p:spPr>
+      </p:pic>
     </p:spTree>
   </p:cSld>
   <p:clrMapOvr>
@@ -3549,271 +4282,21 @@
           <a:p>
             <a:r>
               <a:rPr sz="2800" b="1"/>
-              <a:t>Plan to the defense (aligned with CSUN ETD deadlines)</a:t>
+              <a:t>Main study: what the results say</a:t>
             </a:r>
           </a:p>
         </p:txBody>
       </p:sp>
-      <p:graphicFrame>
-        <p:nvGraphicFramePr>
-          <p:cNvPr id="3" name="Table 2"/>
-          <p:cNvGraphicFramePr>
-            <a:graphicFrameLocks noGrp="1"/>
-          </p:cNvGraphicFramePr>
-          <p:nvPr/>
-        </p:nvGraphicFramePr>
-        <p:xfrm>
-          <a:off x="365760" y="1097280"/>
-          <a:ext cx="11429999" cy="2926080"/>
-        </p:xfrm>
-        <a:graphic>
-          <a:graphicData uri="http://schemas.openxmlformats.org/drawingml/2006/table">
-            <a:tbl>
-              <a:tblPr firstRow="1" bandRow="1">
-                <a:tableStyleId>{5C22544A-7EE6-4342-B048-85BDC9FD1C3A}</a:tableStyleId>
-              </a:tblPr>
-              <a:tblGrid>
-                <a:gridCol w="2267107"/>
-                <a:gridCol w="9162892"/>
-              </a:tblGrid>
-              <a:tr h="365760">
-                <a:tc>
-                  <a:txBody>
-                    <a:bodyPr/>
-                    <a:lstStyle/>
-                    <a:p>
-                      <a:r>
-                        <a:rPr sz="1100" b="1"/>
-                        <a:t>By</a:t>
-                      </a:r>
-                    </a:p>
-                  </a:txBody>
-                  <a:tcPr/>
-                </a:tc>
-                <a:tc>
-                  <a:txBody>
-                    <a:bodyPr/>
-                    <a:lstStyle/>
-                    <a:p>
-                      <a:r>
-                        <a:rPr sz="1100" b="1"/>
-                        <a:t>Milestone</a:t>
-                      </a:r>
-                    </a:p>
-                  </a:txBody>
-                  <a:tcPr/>
-                </a:tc>
-              </a:tr>
-              <a:tr h="365760">
-                <a:tc>
-                  <a:txBody>
-                    <a:bodyPr/>
-                    <a:lstStyle/>
-                    <a:p>
-                      <a:r>
-                        <a:rPr sz="1000" b="0"/>
-                        <a:t>Sep 22, 2026</a:t>
-                      </a:r>
-                    </a:p>
-                  </a:txBody>
-                  <a:tcPr/>
-                </a:tc>
-                <a:tc>
-                  <a:txBody>
-                    <a:bodyPr/>
-                    <a:lstStyle/>
-                    <a:p>
-                      <a:r>
-                        <a:rPr sz="1000" b="0"/>
-                        <a:t>Advisor review of the complete draft; committee composition discussed</a:t>
-                      </a:r>
-                    </a:p>
-                  </a:txBody>
-                  <a:tcPr/>
-                </a:tc>
-              </a:tr>
-              <a:tr h="365760">
-                <a:tc>
-                  <a:txBody>
-                    <a:bodyPr/>
-                    <a:lstStyle/>
-                    <a:p>
-                      <a:r>
-                        <a:rPr sz="1000" b="0"/>
-                        <a:t>Oct 9, 2026</a:t>
-                      </a:r>
-                    </a:p>
-                  </a:txBody>
-                  <a:tcPr/>
-                </a:tc>
-                <a:tc>
-                  <a:txBody>
-                    <a:bodyPr/>
-                    <a:lstStyle/>
-                    <a:p>
-                      <a:r>
-                        <a:rPr sz="1000" b="0"/>
-                        <a:t>ETD Planning Form filed (title and committee)</a:t>
-                      </a:r>
-                    </a:p>
-                  </a:txBody>
-                  <a:tcPr/>
-                </a:tc>
-              </a:tr>
-              <a:tr h="365760">
-                <a:tc>
-                  <a:txBody>
-                    <a:bodyPr/>
-                    <a:lstStyle/>
-                    <a:p>
-                      <a:r>
-                        <a:rPr sz="1000" b="0"/>
-                        <a:t>Oct 16, 2026</a:t>
-                      </a:r>
-                    </a:p>
-                  </a:txBody>
-                  <a:tcPr/>
-                </a:tc>
-                <a:tc>
-                  <a:txBody>
-                    <a:bodyPr/>
-                    <a:lstStyle/>
-                    <a:p>
-                      <a:r>
-                        <a:rPr sz="1000" b="0"/>
-                        <a:t>Revised draft to advisor for approval; Canvas upload and Turnitin check after approval</a:t>
-                      </a:r>
-                    </a:p>
-                  </a:txBody>
-                  <a:tcPr/>
-                </a:tc>
-              </a:tr>
-              <a:tr h="365760">
-                <a:tc>
-                  <a:txBody>
-                    <a:bodyPr/>
-                    <a:lstStyle/>
-                    <a:p>
-                      <a:r>
-                        <a:rPr sz="1000" b="0"/>
-                        <a:t>Oct 23, 2026</a:t>
-                      </a:r>
-                    </a:p>
-                  </a:txBody>
-                  <a:tcPr/>
-                </a:tc>
-                <a:tc>
-                  <a:txBody>
-                    <a:bodyPr/>
-                    <a:lstStyle/>
-                    <a:p>
-                      <a:r>
-                        <a:rPr sz="1000" b="0"/>
-                        <a:t>Draft to committee (two-week review); Doodle poll with 1-hour slots over 3 to 4 weeks</a:t>
-                      </a:r>
-                    </a:p>
-                  </a:txBody>
-                  <a:tcPr/>
-                </a:tc>
-              </a:tr>
-              <a:tr h="365760">
-                <a:tc>
-                  <a:txBody>
-                    <a:bodyPr/>
-                    <a:lstStyle/>
-                    <a:p>
-                      <a:r>
-                        <a:rPr sz="1000" b="0"/>
-                        <a:t>Nov 6, 2026</a:t>
-                      </a:r>
-                    </a:p>
-                  </a:txBody>
-                  <a:tcPr/>
-                </a:tc>
-                <a:tc>
-                  <a:txBody>
-                    <a:bodyPr/>
-                    <a:lstStyle/>
-                    <a:p>
-                      <a:r>
-                        <a:rPr sz="1000" b="0"/>
-                        <a:t>ETD preliminary format review</a:t>
-                      </a:r>
-                    </a:p>
-                  </a:txBody>
-                  <a:tcPr/>
-                </a:tc>
-              </a:tr>
-              <a:tr h="365760">
-                <a:tc>
-                  <a:txBody>
-                    <a:bodyPr/>
-                    <a:lstStyle/>
-                    <a:p>
-                      <a:r>
-                        <a:rPr sz="1000" b="0"/>
-                        <a:t>Nov 16 to 24, 2026</a:t>
-                      </a:r>
-                    </a:p>
-                  </a:txBody>
-                  <a:tcPr/>
-                </a:tc>
-                <a:tc>
-                  <a:txBody>
-                    <a:bodyPr/>
-                    <a:lstStyle/>
-                    <a:p>
-                      <a:r>
-                        <a:rPr sz="1000" b="0"/>
-                        <a:t>Defense (40 min presentation, 10 min Q&amp;A); slides to advisor one week before</a:t>
-                      </a:r>
-                    </a:p>
-                  </a:txBody>
-                  <a:tcPr/>
-                </a:tc>
-              </a:tr>
-              <a:tr h="365760">
-                <a:tc>
-                  <a:txBody>
-                    <a:bodyPr/>
-                    <a:lstStyle/>
-                    <a:p>
-                      <a:r>
-                        <a:rPr sz="1000" b="0"/>
-                        <a:t>Dec 4, 2026</a:t>
-                      </a:r>
-                    </a:p>
-                  </a:txBody>
-                  <a:tcPr/>
-                </a:tc>
-                <a:tc>
-                  <a:txBody>
-                    <a:bodyPr/>
-                    <a:lstStyle/>
-                    <a:p>
-                      <a:r>
-                        <a:rPr sz="1000" b="0"/>
-                        <a:t>Final ETD upload after revisions</a:t>
-                      </a:r>
-                    </a:p>
-                  </a:txBody>
-                  <a:tcPr/>
-                </a:tc>
-              </a:tr>
-            </a:tbl>
-          </a:graphicData>
-        </a:graphic>
-      </p:graphicFrame>
       <p:sp>
         <p:nvSpPr>
-          <p:cNvPr id="4" name="TextBox 3"/>
+          <p:cNvPr id="3" name="TextBox 2"/>
           <p:cNvSpPr txBox="1"/>
           <p:nvPr/>
         </p:nvSpPr>
         <p:spPr>
           <a:xfrm>
-            <a:off x="365760" y="5943600"/>
-            <a:ext cx="11430000" cy="731520"/>
+            <a:off x="457200" y="1097280"/>
+            <a:ext cx="11247120" cy="5303520"/>
           </a:xfrm>
           <a:prstGeom prst="rect">
             <a:avLst/>
@@ -3826,9 +4309,69 @@
           </a:bodyPr>
           <a:lstStyle/>
           <a:p>
-            <a:r>
-              <a:rPr sz="1200"/>
-              <a:t>The December 12 defense date in the May report is after the December 4 ETD deadline and has been moved.</a:t>
+            <a:pPr>
+              <a:spcAft>
+                <a:spcPts val="800"/>
+              </a:spcAft>
+            </a:pPr>
+            <a:r>
+              <a:rPr sz="1600"/>
+              <a:t>• Every grounded condition cut the unsupported fact rate by about 46 percent versus zero-context (E1 0.066, E1b 0.072, E3 0.070 versus E0 0.135; all p &lt; 0.001); the three do not differ from one another; CR did not change</a:t>
+            </a:r>
+          </a:p>
+          <a:p>
+            <a:pPr>
+              <a:spcAft>
+                <a:spcPts val="800"/>
+              </a:spcAft>
+            </a:pPr>
+            <a:r>
+              <a:rPr sz="1600"/>
+              <a:t>• Omission separates them: excerpt-only RAG covered 37% of the clinician's sentences and verification 34%, against 54% for E0; RAG with the whole course kept 53% (p = 0.449 versus E0)</a:t>
+            </a:r>
+          </a:p>
+          <a:p>
+            <a:pPr>
+              <a:spcAft>
+                <a:spcPts val="800"/>
+              </a:spcAft>
+            </a:pPr>
+            <a:r>
+              <a:rPr sz="1600"/>
+              <a:t>• Verbatim extraction scores UFR 0.056: the judge's error floor; the grounded LLM conditions sit within a few hundredths of it</a:t>
+            </a:r>
+          </a:p>
+          <a:p>
+            <a:pPr>
+              <a:spcAft>
+                <a:spcPts val="800"/>
+              </a:spcAft>
+            </a:pPr>
+            <a:r>
+              <a:rPr sz="1600"/>
+              <a:t>• The clinicians' own instructions score UFR 0.289 under the same judge: support by the hospital course measures source-faithfulness, not clinical correctness</a:t>
+            </a:r>
+          </a:p>
+          <a:p>
+            <a:pPr>
+              <a:spcAft>
+                <a:spcPts val="800"/>
+              </a:spcAft>
+            </a:pPr>
+            <a:r>
+              <a:rPr sz="1600"/>
+              <a:t>• Citations: 72% accurate for excerpt-only RAG but 38% for RAG with the whole course; requiring citations lowered UFR (dropping the requirement raised it by 0.030) and three-sentence chunks raised CR, while other retrieval settings changed only coverage; coverage followed the amount of retrieved text</a:t>
+            </a:r>
+          </a:p>
+          <a:p>
+            <a:pPr>
+              <a:spcAft>
+                <a:spcPts val="800"/>
+              </a:spcAft>
+            </a:pPr>
+            <a:r>
+              <a:rPr sz="1600"/>
+              <a:t>• Question answering: abstention 23% (full course) versus 33% (excerpts), highest for warning signs, which the course rarely states; retrieval lowers unsupported answers partly by abstaining more</a:t>
             </a:r>
           </a:p>
         </p:txBody>
@@ -3875,6 +4418,2093 @@
           <a:p>
             <a:r>
               <a:rPr sz="2800" b="1"/>
+              <a:t>Retrieval ablations: paired difference from the E1 base configuration</a:t>
+            </a:r>
+          </a:p>
+        </p:txBody>
+      </p:sp>
+      <p:graphicFrame>
+        <p:nvGraphicFramePr>
+          <p:cNvPr id="3" name="Table 2"/>
+          <p:cNvGraphicFramePr>
+            <a:graphicFrameLocks noGrp="1"/>
+          </p:cNvGraphicFramePr>
+          <p:nvPr/>
+        </p:nvGraphicFramePr>
+        <p:xfrm>
+          <a:off x="365760" y="1097280"/>
+          <a:ext cx="11429999" cy="2560320"/>
+        </p:xfrm>
+        <a:graphic>
+          <a:graphicData uri="http://schemas.openxmlformats.org/drawingml/2006/table">
+            <a:tbl>
+              <a:tblPr firstRow="1" bandRow="1">
+                <a:tableStyleId>{5C22544A-7EE6-4342-B048-85BDC9FD1C3A}</a:tableStyleId>
+              </a:tblPr>
+              <a:tblGrid>
+                <a:gridCol w="3400661"/>
+                <a:gridCol w="1983719"/>
+                <a:gridCol w="1983719"/>
+                <a:gridCol w="1983719"/>
+                <a:gridCol w="2078181"/>
+              </a:tblGrid>
+              <a:tr h="365760">
+                <a:tc>
+                  <a:txBody>
+                    <a:bodyPr/>
+                    <a:lstStyle/>
+                    <a:p>
+                      <a:r>
+                        <a:rPr sz="1100" b="1"/>
+                        <a:t>Variant</a:t>
+                      </a:r>
+                    </a:p>
+                  </a:txBody>
+                  <a:tcPr/>
+                </a:tc>
+                <a:tc>
+                  <a:txBody>
+                    <a:bodyPr/>
+                    <a:lstStyle/>
+                    <a:p>
+                      <a:r>
+                        <a:rPr sz="1100" b="1"/>
+                        <a:t>Δ UFR (p)</a:t>
+                      </a:r>
+                    </a:p>
+                  </a:txBody>
+                  <a:tcPr/>
+                </a:tc>
+                <a:tc>
+                  <a:txBody>
+                    <a:bodyPr/>
+                    <a:lstStyle/>
+                    <a:p>
+                      <a:r>
+                        <a:rPr sz="1100" b="1"/>
+                        <a:t>Δ CR (p)</a:t>
+                      </a:r>
+                    </a:p>
+                  </a:txBody>
+                  <a:tcPr/>
+                </a:tc>
+                <a:tc>
+                  <a:txBody>
+                    <a:bodyPr/>
+                    <a:lstStyle/>
+                    <a:p>
+                      <a:r>
+                        <a:rPr sz="1100" b="1"/>
+                        <a:t>Δ coverage (p)</a:t>
+                      </a:r>
+                    </a:p>
+                  </a:txBody>
+                  <a:tcPr/>
+                </a:tc>
+                <a:tc>
+                  <a:txBody>
+                    <a:bodyPr/>
+                    <a:lstStyle/>
+                    <a:p>
+                      <a:r>
+                        <a:rPr sz="1100" b="1"/>
+                        <a:t>Δ citation accuracy (p)</a:t>
+                      </a:r>
+                    </a:p>
+                  </a:txBody>
+                  <a:tcPr/>
+                </a:tc>
+              </a:tr>
+              <a:tr h="365760">
+                <a:tc>
+                  <a:txBody>
+                    <a:bodyPr/>
+                    <a:lstStyle/>
+                    <a:p>
+                      <a:r>
+                        <a:rPr sz="1000" b="0"/>
+                        <a:t>3-sentence chunks</a:t>
+                      </a:r>
+                    </a:p>
+                  </a:txBody>
+                  <a:tcPr/>
+                </a:tc>
+                <a:tc>
+                  <a:txBody>
+                    <a:bodyPr/>
+                    <a:lstStyle/>
+                    <a:p>
+                      <a:r>
+                        <a:rPr sz="1000" b="0"/>
+                        <a:t>+0.009 (p = 0.485)</a:t>
+                      </a:r>
+                    </a:p>
+                  </a:txBody>
+                  <a:tcPr/>
+                </a:tc>
+                <a:tc>
+                  <a:txBody>
+                    <a:bodyPr/>
+                    <a:lstStyle/>
+                    <a:p>
+                      <a:r>
+                        <a:rPr sz="1000" b="0"/>
+                        <a:t>+0.020 (p = 0.045)</a:t>
+                      </a:r>
+                    </a:p>
+                  </a:txBody>
+                  <a:tcPr/>
+                </a:tc>
+                <a:tc>
+                  <a:txBody>
+                    <a:bodyPr/>
+                    <a:lstStyle/>
+                    <a:p>
+                      <a:r>
+                        <a:rPr sz="1000" b="0"/>
+                        <a:t>-0.072 (p &lt; 0.001)</a:t>
+                      </a:r>
+                    </a:p>
+                  </a:txBody>
+                  <a:tcPr/>
+                </a:tc>
+                <a:tc>
+                  <a:txBody>
+                    <a:bodyPr/>
+                    <a:lstStyle/>
+                    <a:p>
+                      <a:r>
+                        <a:rPr sz="1000" b="0"/>
+                        <a:t>+0.050 (p = 0.172)</a:t>
+                      </a:r>
+                    </a:p>
+                  </a:txBody>
+                  <a:tcPr/>
+                </a:tc>
+              </a:tr>
+              <a:tr h="365760">
+                <a:tc>
+                  <a:txBody>
+                    <a:bodyPr/>
+                    <a:lstStyle/>
+                    <a:p>
+                      <a:r>
+                        <a:rPr sz="1000" b="0"/>
+                        <a:t>8-sentence chunks</a:t>
+                      </a:r>
+                    </a:p>
+                  </a:txBody>
+                  <a:tcPr/>
+                </a:tc>
+                <a:tc>
+                  <a:txBody>
+                    <a:bodyPr/>
+                    <a:lstStyle/>
+                    <a:p>
+                      <a:r>
+                        <a:rPr sz="1000" b="0"/>
+                        <a:t>-0.003 (p = 0.834)</a:t>
+                      </a:r>
+                    </a:p>
+                  </a:txBody>
+                  <a:tcPr/>
+                </a:tc>
+                <a:tc>
+                  <a:txBody>
+                    <a:bodyPr/>
+                    <a:lstStyle/>
+                    <a:p>
+                      <a:r>
+                        <a:rPr sz="1000" b="0"/>
+                        <a:t>-0.005 (p = 0.308)</a:t>
+                      </a:r>
+                    </a:p>
+                  </a:txBody>
+                  <a:tcPr/>
+                </a:tc>
+                <a:tc>
+                  <a:txBody>
+                    <a:bodyPr/>
+                    <a:lstStyle/>
+                    <a:p>
+                      <a:r>
+                        <a:rPr sz="1000" b="0"/>
+                        <a:t>+0.060 (p = 0.003)</a:t>
+                      </a:r>
+                    </a:p>
+                  </a:txBody>
+                  <a:tcPr/>
+                </a:tc>
+                <a:tc>
+                  <a:txBody>
+                    <a:bodyPr/>
+                    <a:lstStyle/>
+                    <a:p>
+                      <a:r>
+                        <a:rPr sz="1000" b="0"/>
+                        <a:t>+0.012 (p = 0.492)</a:t>
+                      </a:r>
+                    </a:p>
+                  </a:txBody>
+                  <a:tcPr/>
+                </a:tc>
+              </a:tr>
+              <a:tr h="365760">
+                <a:tc>
+                  <a:txBody>
+                    <a:bodyPr/>
+                    <a:lstStyle/>
+                    <a:p>
+                      <a:r>
+                        <a:rPr sz="1000" b="0"/>
+                        <a:t>top-2 chunks</a:t>
+                      </a:r>
+                    </a:p>
+                  </a:txBody>
+                  <a:tcPr/>
+                </a:tc>
+                <a:tc>
+                  <a:txBody>
+                    <a:bodyPr/>
+                    <a:lstStyle/>
+                    <a:p>
+                      <a:r>
+                        <a:rPr sz="1000" b="0"/>
+                        <a:t>+0.018 (p = 0.427)</a:t>
+                      </a:r>
+                    </a:p>
+                  </a:txBody>
+                  <a:tcPr/>
+                </a:tc>
+                <a:tc>
+                  <a:txBody>
+                    <a:bodyPr/>
+                    <a:lstStyle/>
+                    <a:p>
+                      <a:r>
+                        <a:rPr sz="1000" b="0"/>
+                        <a:t>+0.017 (p = 0.094)</a:t>
+                      </a:r>
+                    </a:p>
+                  </a:txBody>
+                  <a:tcPr/>
+                </a:tc>
+                <a:tc>
+                  <a:txBody>
+                    <a:bodyPr/>
+                    <a:lstStyle/>
+                    <a:p>
+                      <a:r>
+                        <a:rPr sz="1000" b="0"/>
+                        <a:t>-0.058 (p &lt; 0.001)</a:t>
+                      </a:r>
+                    </a:p>
+                  </a:txBody>
+                  <a:tcPr/>
+                </a:tc>
+                <a:tc>
+                  <a:txBody>
+                    <a:bodyPr/>
+                    <a:lstStyle/>
+                    <a:p>
+                      <a:r>
+                        <a:rPr sz="1000" b="0"/>
+                        <a:t>+0.059 (p = 0.060)</a:t>
+                      </a:r>
+                    </a:p>
+                  </a:txBody>
+                  <a:tcPr/>
+                </a:tc>
+              </a:tr>
+              <a:tr h="365760">
+                <a:tc>
+                  <a:txBody>
+                    <a:bodyPr/>
+                    <a:lstStyle/>
+                    <a:p>
+                      <a:r>
+                        <a:rPr sz="1000" b="0"/>
+                        <a:t>top-5 chunks</a:t>
+                      </a:r>
+                    </a:p>
+                  </a:txBody>
+                  <a:tcPr/>
+                </a:tc>
+                <a:tc>
+                  <a:txBody>
+                    <a:bodyPr/>
+                    <a:lstStyle/>
+                    <a:p>
+                      <a:r>
+                        <a:rPr sz="1000" b="0"/>
+                        <a:t>+0.009 (p = 0.493)</a:t>
+                      </a:r>
+                    </a:p>
+                  </a:txBody>
+                  <a:tcPr/>
+                </a:tc>
+                <a:tc>
+                  <a:txBody>
+                    <a:bodyPr/>
+                    <a:lstStyle/>
+                    <a:p>
+                      <a:r>
+                        <a:rPr sz="1000" b="0"/>
+                        <a:t>+0.000 (p = 0.838)</a:t>
+                      </a:r>
+                    </a:p>
+                  </a:txBody>
+                  <a:tcPr/>
+                </a:tc>
+                <a:tc>
+                  <a:txBody>
+                    <a:bodyPr/>
+                    <a:lstStyle/>
+                    <a:p>
+                      <a:r>
+                        <a:rPr sz="1000" b="0"/>
+                        <a:t>+0.072 (p &lt; 0.001)</a:t>
+                      </a:r>
+                    </a:p>
+                  </a:txBody>
+                  <a:tcPr/>
+                </a:tc>
+                <a:tc>
+                  <a:txBody>
+                    <a:bodyPr/>
+                    <a:lstStyle/>
+                    <a:p>
+                      <a:r>
+                        <a:rPr sz="1000" b="0"/>
+                        <a:t>-0.084 (p = 0.020)</a:t>
+                      </a:r>
+                    </a:p>
+                  </a:txBody>
+                  <a:tcPr/>
+                </a:tc>
+              </a:tr>
+              <a:tr h="365760">
+                <a:tc>
+                  <a:txBody>
+                    <a:bodyPr/>
+                    <a:lstStyle/>
+                    <a:p>
+                      <a:r>
+                        <a:rPr sz="1000" b="0"/>
+                        <a:t>BM25 retrieval</a:t>
+                      </a:r>
+                    </a:p>
+                  </a:txBody>
+                  <a:tcPr/>
+                </a:tc>
+                <a:tc>
+                  <a:txBody>
+                    <a:bodyPr/>
+                    <a:lstStyle/>
+                    <a:p>
+                      <a:r>
+                        <a:rPr sz="1000" b="0"/>
+                        <a:t>+0.007 (p = 0.596)</a:t>
+                      </a:r>
+                    </a:p>
+                  </a:txBody>
+                  <a:tcPr/>
+                </a:tc>
+                <a:tc>
+                  <a:txBody>
+                    <a:bodyPr/>
+                    <a:lstStyle/>
+                    <a:p>
+                      <a:r>
+                        <a:rPr sz="1000" b="0"/>
+                        <a:t>+0.007 (p = 0.687)</a:t>
+                      </a:r>
+                    </a:p>
+                  </a:txBody>
+                  <a:tcPr/>
+                </a:tc>
+                <a:tc>
+                  <a:txBody>
+                    <a:bodyPr/>
+                    <a:lstStyle/>
+                    <a:p>
+                      <a:r>
+                        <a:rPr sz="1000" b="0"/>
+                        <a:t>+0.028 (p = 0.177)</a:t>
+                      </a:r>
+                    </a:p>
+                  </a:txBody>
+                  <a:tcPr/>
+                </a:tc>
+                <a:tc>
+                  <a:txBody>
+                    <a:bodyPr/>
+                    <a:lstStyle/>
+                    <a:p>
+                      <a:r>
+                        <a:rPr sz="1000" b="0"/>
+                        <a:t>+0.035 (p = 0.393)</a:t>
+                      </a:r>
+                    </a:p>
+                  </a:txBody>
+                  <a:tcPr/>
+                </a:tc>
+              </a:tr>
+              <a:tr h="365760">
+                <a:tc>
+                  <a:txBody>
+                    <a:bodyPr/>
+                    <a:lstStyle/>
+                    <a:p>
+                      <a:r>
+                        <a:rPr sz="1000" b="0"/>
+                        <a:t>citations not required</a:t>
+                      </a:r>
+                    </a:p>
+                  </a:txBody>
+                  <a:tcPr/>
+                </a:tc>
+                <a:tc>
+                  <a:txBody>
+                    <a:bodyPr/>
+                    <a:lstStyle/>
+                    <a:p>
+                      <a:r>
+                        <a:rPr sz="1000" b="0"/>
+                        <a:t>+0.030 (p = 0.017)</a:t>
+                      </a:r>
+                    </a:p>
+                  </a:txBody>
+                  <a:tcPr/>
+                </a:tc>
+                <a:tc>
+                  <a:txBody>
+                    <a:bodyPr/>
+                    <a:lstStyle/>
+                    <a:p>
+                      <a:r>
+                        <a:rPr sz="1000" b="0"/>
+                        <a:t>-0.007 (p = 0.178)</a:t>
+                      </a:r>
+                    </a:p>
+                  </a:txBody>
+                  <a:tcPr/>
+                </a:tc>
+                <a:tc>
+                  <a:txBody>
+                    <a:bodyPr/>
+                    <a:lstStyle/>
+                    <a:p>
+                      <a:r>
+                        <a:rPr sz="1000" b="0"/>
+                        <a:t>+0.019 (p = 0.314)</a:t>
+                      </a:r>
+                    </a:p>
+                  </a:txBody>
+                  <a:tcPr/>
+                </a:tc>
+                <a:tc>
+                  <a:txBody>
+                    <a:bodyPr/>
+                    <a:lstStyle/>
+                    <a:p>
+                      <a:r>
+                        <a:rPr sz="1000" b="0"/>
+                        <a:t>—</a:t>
+                      </a:r>
+                    </a:p>
+                  </a:txBody>
+                  <a:tcPr/>
+                </a:tc>
+              </a:tr>
+            </a:tbl>
+          </a:graphicData>
+        </a:graphic>
+      </p:graphicFrame>
+      <p:sp>
+        <p:nvSpPr>
+          <p:cNvPr id="4" name="TextBox 3"/>
+          <p:cNvSpPr txBox="1"/>
+          <p:nvPr/>
+        </p:nvSpPr>
+        <p:spPr>
+          <a:xfrm>
+            <a:off x="365760" y="5943600"/>
+            <a:ext cx="11430000" cy="731520"/>
+          </a:xfrm>
+          <a:prstGeom prst="rect">
+            <a:avLst/>
+          </a:prstGeom>
+          <a:noFill/>
+        </p:spPr>
+        <p:txBody>
+          <a:bodyPr wrap="square">
+            <a:spAutoFit/>
+          </a:bodyPr>
+          <a:lstStyle/>
+          <a:p>
+            <a:r>
+              <a:rPr sz="1200"/>
+              <a:t>Negative UFR and CR differences and positive coverage and citation differences favour the variant. Base: 5-sentence chunks, top-3, dense retrieval, citations required.</a:t>
+            </a:r>
+          </a:p>
+        </p:txBody>
+      </p:sp>
+    </p:spTree>
+  </p:cSld>
+  <p:clrMapOvr>
+    <a:masterClrMapping/>
+  </p:clrMapOvr>
+</p:sld>
+</file>
+
+<file path=ppt/slides/slide15.xml><?xml version="1.0" encoding="utf-8"?>
+<p:sld xmlns:a="http://schemas.openxmlformats.org/drawingml/2006/main" xmlns:p="http://schemas.openxmlformats.org/presentationml/2006/main" xmlns:r="http://schemas.openxmlformats.org/officeDocument/2006/relationships">
+  <p:cSld>
+    <p:spTree>
+      <p:nvGrpSpPr>
+        <p:cNvPr id="1" name=""/>
+        <p:cNvGrpSpPr/>
+        <p:nvPr/>
+      </p:nvGrpSpPr>
+      <p:grpSpPr/>
+      <p:sp>
+        <p:nvSpPr>
+          <p:cNvPr id="2" name="TextBox 1"/>
+          <p:cNvSpPr txBox="1"/>
+          <p:nvPr/>
+        </p:nvSpPr>
+        <p:spPr>
+          <a:xfrm>
+            <a:off x="365760" y="182880"/>
+            <a:ext cx="11430000" cy="822960"/>
+          </a:xfrm>
+          <a:prstGeom prst="rect">
+            <a:avLst/>
+          </a:prstGeom>
+          <a:noFill/>
+        </p:spPr>
+        <p:txBody>
+          <a:bodyPr wrap="square">
+            <a:spAutoFit/>
+          </a:bodyPr>
+          <a:lstStyle/>
+          <a:p>
+            <a:r>
+              <a:rPr sz="2800" b="1"/>
+              <a:t>Question-answering pilot (three questions per course)</a:t>
+            </a:r>
+          </a:p>
+        </p:txBody>
+      </p:sp>
+      <p:graphicFrame>
+        <p:nvGraphicFramePr>
+          <p:cNvPr id="3" name="Table 2"/>
+          <p:cNvGraphicFramePr>
+            <a:graphicFrameLocks noGrp="1"/>
+          </p:cNvGraphicFramePr>
+          <p:nvPr/>
+        </p:nvGraphicFramePr>
+        <p:xfrm>
+          <a:off x="365760" y="1097280"/>
+          <a:ext cx="11429996" cy="3291840"/>
+        </p:xfrm>
+        <a:graphic>
+          <a:graphicData uri="http://schemas.openxmlformats.org/drawingml/2006/table">
+            <a:tbl>
+              <a:tblPr firstRow="1" bandRow="1">
+                <a:tableStyleId>{5C22544A-7EE6-4342-B048-85BDC9FD1C3A}</a:tableStyleId>
+              </a:tblPr>
+              <a:tblGrid>
+                <a:gridCol w="1363211"/>
+                <a:gridCol w="1677798"/>
+                <a:gridCol w="734036"/>
+                <a:gridCol w="1258348"/>
+                <a:gridCol w="1048623"/>
+                <a:gridCol w="1048623"/>
+                <a:gridCol w="3355596"/>
+                <a:gridCol w="943761"/>
+              </a:tblGrid>
+              <a:tr h="365760">
+                <a:tc>
+                  <a:txBody>
+                    <a:bodyPr/>
+                    <a:lstStyle/>
+                    <a:p>
+                      <a:r>
+                        <a:rPr sz="1100" b="1"/>
+                        <a:t>Condition</a:t>
+                      </a:r>
+                    </a:p>
+                  </a:txBody>
+                  <a:tcPr/>
+                </a:tc>
+                <a:tc>
+                  <a:txBody>
+                    <a:bodyPr/>
+                    <a:lstStyle/>
+                    <a:p>
+                      <a:r>
+                        <a:rPr sz="1100" b="1"/>
+                        <a:t>Question</a:t>
+                      </a:r>
+                    </a:p>
+                  </a:txBody>
+                  <a:tcPr/>
+                </a:tc>
+                <a:tc>
+                  <a:txBody>
+                    <a:bodyPr/>
+                    <a:lstStyle/>
+                    <a:p>
+                      <a:r>
+                        <a:rPr sz="1100" b="1"/>
+                        <a:t>n</a:t>
+                      </a:r>
+                    </a:p>
+                  </a:txBody>
+                  <a:tcPr/>
+                </a:tc>
+                <a:tc>
+                  <a:txBody>
+                    <a:bodyPr/>
+                    <a:lstStyle/>
+                    <a:p>
+                      <a:r>
+                        <a:rPr sz="1100" b="1"/>
+                        <a:t>Abstained</a:t>
+                      </a:r>
+                    </a:p>
+                  </a:txBody>
+                  <a:tcPr/>
+                </a:tc>
+                <a:tc>
+                  <a:txBody>
+                    <a:bodyPr/>
+                    <a:lstStyle/>
+                    <a:p>
+                      <a:r>
+                        <a:rPr sz="1100" b="1"/>
+                        <a:t>UFR</a:t>
+                      </a:r>
+                    </a:p>
+                  </a:txBody>
+                  <a:tcPr/>
+                </a:tc>
+                <a:tc>
+                  <a:txBody>
+                    <a:bodyPr/>
+                    <a:lstStyle/>
+                    <a:p>
+                      <a:r>
+                        <a:rPr sz="1100" b="1"/>
+                        <a:t>CR</a:t>
+                      </a:r>
+                    </a:p>
+                  </a:txBody>
+                  <a:tcPr/>
+                </a:tc>
+                <a:tc>
+                  <a:txBody>
+                    <a:bodyPr/>
+                    <a:lstStyle/>
+                    <a:p>
+                      <a:r>
+                        <a:rPr sz="1100" b="1"/>
+                        <a:t>Supported by clinician's instructions</a:t>
+                      </a:r>
+                    </a:p>
+                  </a:txBody>
+                  <a:tcPr/>
+                </a:tc>
+                <a:tc>
+                  <a:txBody>
+                    <a:bodyPr/>
+                    <a:lstStyle/>
+                    <a:p>
+                      <a:r>
+                        <a:rPr sz="1100" b="1"/>
+                        <a:t>Words</a:t>
+                      </a:r>
+                    </a:p>
+                  </a:txBody>
+                  <a:tcPr/>
+                </a:tc>
+              </a:tr>
+              <a:tr h="365760">
+                <a:tc>
+                  <a:txBody>
+                    <a:bodyPr/>
+                    <a:lstStyle/>
+                    <a:p>
+                      <a:r>
+                        <a:rPr sz="1000" b="0"/>
+                        <a:t>QA-E0</a:t>
+                      </a:r>
+                    </a:p>
+                  </a:txBody>
+                  <a:tcPr/>
+                </a:tc>
+                <a:tc>
+                  <a:txBody>
+                    <a:bodyPr/>
+                    <a:lstStyle/>
+                    <a:p>
+                      <a:r>
+                        <a:rPr sz="1000" b="0"/>
+                        <a:t>all</a:t>
+                      </a:r>
+                    </a:p>
+                  </a:txBody>
+                  <a:tcPr/>
+                </a:tc>
+                <a:tc>
+                  <a:txBody>
+                    <a:bodyPr/>
+                    <a:lstStyle/>
+                    <a:p>
+                      <a:r>
+                        <a:rPr sz="1000" b="0"/>
+                        <a:t>330</a:t>
+                      </a:r>
+                    </a:p>
+                  </a:txBody>
+                  <a:tcPr/>
+                </a:tc>
+                <a:tc>
+                  <a:txBody>
+                    <a:bodyPr/>
+                    <a:lstStyle/>
+                    <a:p>
+                      <a:r>
+                        <a:rPr sz="1000" b="0"/>
+                        <a:t>23%</a:t>
+                      </a:r>
+                    </a:p>
+                  </a:txBody>
+                  <a:tcPr/>
+                </a:tc>
+                <a:tc>
+                  <a:txBody>
+                    <a:bodyPr/>
+                    <a:lstStyle/>
+                    <a:p>
+                      <a:r>
+                        <a:rPr sz="1000" b="0"/>
+                        <a:t>0.429</a:t>
+                      </a:r>
+                    </a:p>
+                  </a:txBody>
+                  <a:tcPr/>
+                </a:tc>
+                <a:tc>
+                  <a:txBody>
+                    <a:bodyPr/>
+                    <a:lstStyle/>
+                    <a:p>
+                      <a:r>
+                        <a:rPr sz="1000" b="0"/>
+                        <a:t>0.032</a:t>
+                      </a:r>
+                    </a:p>
+                  </a:txBody>
+                  <a:tcPr/>
+                </a:tc>
+                <a:tc>
+                  <a:txBody>
+                    <a:bodyPr/>
+                    <a:lstStyle/>
+                    <a:p>
+                      <a:r>
+                        <a:rPr sz="1000" b="0"/>
+                        <a:t>16%</a:t>
+                      </a:r>
+                    </a:p>
+                  </a:txBody>
+                  <a:tcPr/>
+                </a:tc>
+                <a:tc>
+                  <a:txBody>
+                    <a:bodyPr/>
+                    <a:lstStyle/>
+                    <a:p>
+                      <a:r>
+                        <a:rPr sz="1000" b="0"/>
+                        <a:t>31</a:t>
+                      </a:r>
+                    </a:p>
+                  </a:txBody>
+                  <a:tcPr/>
+                </a:tc>
+              </a:tr>
+              <a:tr h="365760">
+                <a:tc>
+                  <a:txBody>
+                    <a:bodyPr/>
+                    <a:lstStyle/>
+                    <a:p>
+                      <a:r>
+                        <a:rPr sz="1000" b="0"/>
+                        <a:t>QA-E0</a:t>
+                      </a:r>
+                    </a:p>
+                  </a:txBody>
+                  <a:tcPr/>
+                </a:tc>
+                <a:tc>
+                  <a:txBody>
+                    <a:bodyPr/>
+                    <a:lstStyle/>
+                    <a:p>
+                      <a:r>
+                        <a:rPr sz="1000" b="0"/>
+                        <a:t>follow up</a:t>
+                      </a:r>
+                    </a:p>
+                  </a:txBody>
+                  <a:tcPr/>
+                </a:tc>
+                <a:tc>
+                  <a:txBody>
+                    <a:bodyPr/>
+                    <a:lstStyle/>
+                    <a:p>
+                      <a:r>
+                        <a:rPr sz="1000" b="0"/>
+                        <a:t>110</a:t>
+                      </a:r>
+                    </a:p>
+                  </a:txBody>
+                  <a:tcPr/>
+                </a:tc>
+                <a:tc>
+                  <a:txBody>
+                    <a:bodyPr/>
+                    <a:lstStyle/>
+                    <a:p>
+                      <a:r>
+                        <a:rPr sz="1000" b="0"/>
+                        <a:t>15%</a:t>
+                      </a:r>
+                    </a:p>
+                  </a:txBody>
+                  <a:tcPr/>
+                </a:tc>
+                <a:tc>
+                  <a:txBody>
+                    <a:bodyPr/>
+                    <a:lstStyle/>
+                    <a:p>
+                      <a:r>
+                        <a:rPr sz="1000" b="0"/>
+                        <a:t>0.309</a:t>
+                      </a:r>
+                    </a:p>
+                  </a:txBody>
+                  <a:tcPr/>
+                </a:tc>
+                <a:tc>
+                  <a:txBody>
+                    <a:bodyPr/>
+                    <a:lstStyle/>
+                    <a:p>
+                      <a:r>
+                        <a:rPr sz="1000" b="0"/>
+                        <a:t>0.018</a:t>
+                      </a:r>
+                    </a:p>
+                  </a:txBody>
+                  <a:tcPr/>
+                </a:tc>
+                <a:tc>
+                  <a:txBody>
+                    <a:bodyPr/>
+                    <a:lstStyle/>
+                    <a:p>
+                      <a:r>
+                        <a:rPr sz="1000" b="0"/>
+                        <a:t>15%</a:t>
+                      </a:r>
+                    </a:p>
+                  </a:txBody>
+                  <a:tcPr/>
+                </a:tc>
+                <a:tc>
+                  <a:txBody>
+                    <a:bodyPr/>
+                    <a:lstStyle/>
+                    <a:p>
+                      <a:r>
+                        <a:rPr sz="1000" b="0"/>
+                        <a:t>30</a:t>
+                      </a:r>
+                    </a:p>
+                  </a:txBody>
+                  <a:tcPr/>
+                </a:tc>
+              </a:tr>
+              <a:tr h="365760">
+                <a:tc>
+                  <a:txBody>
+                    <a:bodyPr/>
+                    <a:lstStyle/>
+                    <a:p>
+                      <a:r>
+                        <a:rPr sz="1000" b="0"/>
+                        <a:t>QA-E0</a:t>
+                      </a:r>
+                    </a:p>
+                  </a:txBody>
+                  <a:tcPr/>
+                </a:tc>
+                <a:tc>
+                  <a:txBody>
+                    <a:bodyPr/>
+                    <a:lstStyle/>
+                    <a:p>
+                      <a:r>
+                        <a:rPr sz="1000" b="0"/>
+                        <a:t>medications</a:t>
+                      </a:r>
+                    </a:p>
+                  </a:txBody>
+                  <a:tcPr/>
+                </a:tc>
+                <a:tc>
+                  <a:txBody>
+                    <a:bodyPr/>
+                    <a:lstStyle/>
+                    <a:p>
+                      <a:r>
+                        <a:rPr sz="1000" b="0"/>
+                        <a:t>110</a:t>
+                      </a:r>
+                    </a:p>
+                  </a:txBody>
+                  <a:tcPr/>
+                </a:tc>
+                <a:tc>
+                  <a:txBody>
+                    <a:bodyPr/>
+                    <a:lstStyle/>
+                    <a:p>
+                      <a:r>
+                        <a:rPr sz="1000" b="0"/>
+                        <a:t>7%</a:t>
+                      </a:r>
+                    </a:p>
+                  </a:txBody>
+                  <a:tcPr/>
+                </a:tc>
+                <a:tc>
+                  <a:txBody>
+                    <a:bodyPr/>
+                    <a:lstStyle/>
+                    <a:p>
+                      <a:r>
+                        <a:rPr sz="1000" b="0"/>
+                        <a:t>0.272</a:t>
+                      </a:r>
+                    </a:p>
+                  </a:txBody>
+                  <a:tcPr/>
+                </a:tc>
+                <a:tc>
+                  <a:txBody>
+                    <a:bodyPr/>
+                    <a:lstStyle/>
+                    <a:p>
+                      <a:r>
+                        <a:rPr sz="1000" b="0"/>
+                        <a:t>0.055</a:t>
+                      </a:r>
+                    </a:p>
+                  </a:txBody>
+                  <a:tcPr/>
+                </a:tc>
+                <a:tc>
+                  <a:txBody>
+                    <a:bodyPr/>
+                    <a:lstStyle/>
+                    <a:p>
+                      <a:r>
+                        <a:rPr sz="1000" b="0"/>
+                        <a:t>18%</a:t>
+                      </a:r>
+                    </a:p>
+                  </a:txBody>
+                  <a:tcPr/>
+                </a:tc>
+                <a:tc>
+                  <a:txBody>
+                    <a:bodyPr/>
+                    <a:lstStyle/>
+                    <a:p>
+                      <a:r>
+                        <a:rPr sz="1000" b="0"/>
+                        <a:t>41</a:t>
+                      </a:r>
+                    </a:p>
+                  </a:txBody>
+                  <a:tcPr/>
+                </a:tc>
+              </a:tr>
+              <a:tr h="365760">
+                <a:tc>
+                  <a:txBody>
+                    <a:bodyPr/>
+                    <a:lstStyle/>
+                    <a:p>
+                      <a:r>
+                        <a:rPr sz="1000" b="0"/>
+                        <a:t>QA-E0</a:t>
+                      </a:r>
+                    </a:p>
+                  </a:txBody>
+                  <a:tcPr/>
+                </a:tc>
+                <a:tc>
+                  <a:txBody>
+                    <a:bodyPr/>
+                    <a:lstStyle/>
+                    <a:p>
+                      <a:r>
+                        <a:rPr sz="1000" b="0"/>
+                        <a:t>warning signs</a:t>
+                      </a:r>
+                    </a:p>
+                  </a:txBody>
+                  <a:tcPr/>
+                </a:tc>
+                <a:tc>
+                  <a:txBody>
+                    <a:bodyPr/>
+                    <a:lstStyle/>
+                    <a:p>
+                      <a:r>
+                        <a:rPr sz="1000" b="0"/>
+                        <a:t>110</a:t>
+                      </a:r>
+                    </a:p>
+                  </a:txBody>
+                  <a:tcPr/>
+                </a:tc>
+                <a:tc>
+                  <a:txBody>
+                    <a:bodyPr/>
+                    <a:lstStyle/>
+                    <a:p>
+                      <a:r>
+                        <a:rPr sz="1000" b="0"/>
+                        <a:t>46%</a:t>
+                      </a:r>
+                    </a:p>
+                  </a:txBody>
+                  <a:tcPr/>
+                </a:tc>
+                <a:tc>
+                  <a:txBody>
+                    <a:bodyPr/>
+                    <a:lstStyle/>
+                    <a:p>
+                      <a:r>
+                        <a:rPr sz="1000" b="0"/>
+                        <a:t>0.893</a:t>
+                      </a:r>
+                    </a:p>
+                  </a:txBody>
+                  <a:tcPr/>
+                </a:tc>
+                <a:tc>
+                  <a:txBody>
+                    <a:bodyPr/>
+                    <a:lstStyle/>
+                    <a:p>
+                      <a:r>
+                        <a:rPr sz="1000" b="0"/>
+                        <a:t>0.017</a:t>
+                      </a:r>
+                    </a:p>
+                  </a:txBody>
+                  <a:tcPr/>
+                </a:tc>
+                <a:tc>
+                  <a:txBody>
+                    <a:bodyPr/>
+                    <a:lstStyle/>
+                    <a:p>
+                      <a:r>
+                        <a:rPr sz="1000" b="0"/>
+                        <a:t>13%</a:t>
+                      </a:r>
+                    </a:p>
+                  </a:txBody>
+                  <a:tcPr/>
+                </a:tc>
+                <a:tc>
+                  <a:txBody>
+                    <a:bodyPr/>
+                    <a:lstStyle/>
+                    <a:p>
+                      <a:r>
+                        <a:rPr sz="1000" b="0"/>
+                        <a:t>20</a:t>
+                      </a:r>
+                    </a:p>
+                  </a:txBody>
+                  <a:tcPr/>
+                </a:tc>
+              </a:tr>
+              <a:tr h="365760">
+                <a:tc>
+                  <a:txBody>
+                    <a:bodyPr/>
+                    <a:lstStyle/>
+                    <a:p>
+                      <a:r>
+                        <a:rPr sz="1000" b="0"/>
+                        <a:t>QA-E1</a:t>
+                      </a:r>
+                    </a:p>
+                  </a:txBody>
+                  <a:tcPr/>
+                </a:tc>
+                <a:tc>
+                  <a:txBody>
+                    <a:bodyPr/>
+                    <a:lstStyle/>
+                    <a:p>
+                      <a:r>
+                        <a:rPr sz="1000" b="0"/>
+                        <a:t>all</a:t>
+                      </a:r>
+                    </a:p>
+                  </a:txBody>
+                  <a:tcPr/>
+                </a:tc>
+                <a:tc>
+                  <a:txBody>
+                    <a:bodyPr/>
+                    <a:lstStyle/>
+                    <a:p>
+                      <a:r>
+                        <a:rPr sz="1000" b="0"/>
+                        <a:t>330</a:t>
+                      </a:r>
+                    </a:p>
+                  </a:txBody>
+                  <a:tcPr/>
+                </a:tc>
+                <a:tc>
+                  <a:txBody>
+                    <a:bodyPr/>
+                    <a:lstStyle/>
+                    <a:p>
+                      <a:r>
+                        <a:rPr sz="1000" b="0"/>
+                        <a:t>33%</a:t>
+                      </a:r>
+                    </a:p>
+                  </a:txBody>
+                  <a:tcPr/>
+                </a:tc>
+                <a:tc>
+                  <a:txBody>
+                    <a:bodyPr/>
+                    <a:lstStyle/>
+                    <a:p>
+                      <a:r>
+                        <a:rPr sz="1000" b="0"/>
+                        <a:t>0.307</a:t>
+                      </a:r>
+                    </a:p>
+                  </a:txBody>
+                  <a:tcPr/>
+                </a:tc>
+                <a:tc>
+                  <a:txBody>
+                    <a:bodyPr/>
+                    <a:lstStyle/>
+                    <a:p>
+                      <a:r>
+                        <a:rPr sz="1000" b="0"/>
+                        <a:t>0.032</a:t>
+                      </a:r>
+                    </a:p>
+                  </a:txBody>
+                  <a:tcPr/>
+                </a:tc>
+                <a:tc>
+                  <a:txBody>
+                    <a:bodyPr/>
+                    <a:lstStyle/>
+                    <a:p>
+                      <a:r>
+                        <a:rPr sz="1000" b="0"/>
+                        <a:t>15%</a:t>
+                      </a:r>
+                    </a:p>
+                  </a:txBody>
+                  <a:tcPr/>
+                </a:tc>
+                <a:tc>
+                  <a:txBody>
+                    <a:bodyPr/>
+                    <a:lstStyle/>
+                    <a:p>
+                      <a:r>
+                        <a:rPr sz="1000" b="0"/>
+                        <a:t>25</a:t>
+                      </a:r>
+                    </a:p>
+                  </a:txBody>
+                  <a:tcPr/>
+                </a:tc>
+              </a:tr>
+              <a:tr h="365760">
+                <a:tc>
+                  <a:txBody>
+                    <a:bodyPr/>
+                    <a:lstStyle/>
+                    <a:p>
+                      <a:r>
+                        <a:rPr sz="1000" b="0"/>
+                        <a:t>QA-E1</a:t>
+                      </a:r>
+                    </a:p>
+                  </a:txBody>
+                  <a:tcPr/>
+                </a:tc>
+                <a:tc>
+                  <a:txBody>
+                    <a:bodyPr/>
+                    <a:lstStyle/>
+                    <a:p>
+                      <a:r>
+                        <a:rPr sz="1000" b="0"/>
+                        <a:t>follow up</a:t>
+                      </a:r>
+                    </a:p>
+                  </a:txBody>
+                  <a:tcPr/>
+                </a:tc>
+                <a:tc>
+                  <a:txBody>
+                    <a:bodyPr/>
+                    <a:lstStyle/>
+                    <a:p>
+                      <a:r>
+                        <a:rPr sz="1000" b="0"/>
+                        <a:t>110</a:t>
+                      </a:r>
+                    </a:p>
+                  </a:txBody>
+                  <a:tcPr/>
+                </a:tc>
+                <a:tc>
+                  <a:txBody>
+                    <a:bodyPr/>
+                    <a:lstStyle/>
+                    <a:p>
+                      <a:r>
+                        <a:rPr sz="1000" b="0"/>
+                        <a:t>24%</a:t>
+                      </a:r>
+                    </a:p>
+                  </a:txBody>
+                  <a:tcPr/>
+                </a:tc>
+                <a:tc>
+                  <a:txBody>
+                    <a:bodyPr/>
+                    <a:lstStyle/>
+                    <a:p>
+                      <a:r>
+                        <a:rPr sz="1000" b="0"/>
+                        <a:t>0.246</a:t>
+                      </a:r>
+                    </a:p>
+                  </a:txBody>
+                  <a:tcPr/>
+                </a:tc>
+                <a:tc>
+                  <a:txBody>
+                    <a:bodyPr/>
+                    <a:lstStyle/>
+                    <a:p>
+                      <a:r>
+                        <a:rPr sz="1000" b="0"/>
+                        <a:t>0.008</a:t>
+                      </a:r>
+                    </a:p>
+                  </a:txBody>
+                  <a:tcPr/>
+                </a:tc>
+                <a:tc>
+                  <a:txBody>
+                    <a:bodyPr/>
+                    <a:lstStyle/>
+                    <a:p>
+                      <a:r>
+                        <a:rPr sz="1000" b="0"/>
+                        <a:t>15%</a:t>
+                      </a:r>
+                    </a:p>
+                  </a:txBody>
+                  <a:tcPr/>
+                </a:tc>
+                <a:tc>
+                  <a:txBody>
+                    <a:bodyPr/>
+                    <a:lstStyle/>
+                    <a:p>
+                      <a:r>
+                        <a:rPr sz="1000" b="0"/>
+                        <a:t>24</a:t>
+                      </a:r>
+                    </a:p>
+                  </a:txBody>
+                  <a:tcPr/>
+                </a:tc>
+              </a:tr>
+              <a:tr h="365760">
+                <a:tc>
+                  <a:txBody>
+                    <a:bodyPr/>
+                    <a:lstStyle/>
+                    <a:p>
+                      <a:r>
+                        <a:rPr sz="1000" b="0"/>
+                        <a:t>QA-E1</a:t>
+                      </a:r>
+                    </a:p>
+                  </a:txBody>
+                  <a:tcPr/>
+                </a:tc>
+                <a:tc>
+                  <a:txBody>
+                    <a:bodyPr/>
+                    <a:lstStyle/>
+                    <a:p>
+                      <a:r>
+                        <a:rPr sz="1000" b="0"/>
+                        <a:t>medications</a:t>
+                      </a:r>
+                    </a:p>
+                  </a:txBody>
+                  <a:tcPr/>
+                </a:tc>
+                <a:tc>
+                  <a:txBody>
+                    <a:bodyPr/>
+                    <a:lstStyle/>
+                    <a:p>
+                      <a:r>
+                        <a:rPr sz="1000" b="0"/>
+                        <a:t>110</a:t>
+                      </a:r>
+                    </a:p>
+                  </a:txBody>
+                  <a:tcPr/>
+                </a:tc>
+                <a:tc>
+                  <a:txBody>
+                    <a:bodyPr/>
+                    <a:lstStyle/>
+                    <a:p>
+                      <a:r>
+                        <a:rPr sz="1000" b="0"/>
+                        <a:t>10%</a:t>
+                      </a:r>
+                    </a:p>
+                  </a:txBody>
+                  <a:tcPr/>
+                </a:tc>
+                <a:tc>
+                  <a:txBody>
+                    <a:bodyPr/>
+                    <a:lstStyle/>
+                    <a:p>
+                      <a:r>
+                        <a:rPr sz="1000" b="0"/>
+                        <a:t>0.212</a:t>
+                      </a:r>
+                    </a:p>
+                  </a:txBody>
+                  <a:tcPr/>
+                </a:tc>
+                <a:tc>
+                  <a:txBody>
+                    <a:bodyPr/>
+                    <a:lstStyle/>
+                    <a:p>
+                      <a:r>
+                        <a:rPr sz="1000" b="0"/>
+                        <a:t>0.054</a:t>
+                      </a:r>
+                    </a:p>
+                  </a:txBody>
+                  <a:tcPr/>
+                </a:tc>
+                <a:tc>
+                  <a:txBody>
+                    <a:bodyPr/>
+                    <a:lstStyle/>
+                    <a:p>
+                      <a:r>
+                        <a:rPr sz="1000" b="0"/>
+                        <a:t>15%</a:t>
+                      </a:r>
+                    </a:p>
+                  </a:txBody>
+                  <a:tcPr/>
+                </a:tc>
+                <a:tc>
+                  <a:txBody>
+                    <a:bodyPr/>
+                    <a:lstStyle/>
+                    <a:p>
+                      <a:r>
+                        <a:rPr sz="1000" b="0"/>
+                        <a:t>36</a:t>
+                      </a:r>
+                    </a:p>
+                  </a:txBody>
+                  <a:tcPr/>
+                </a:tc>
+              </a:tr>
+              <a:tr h="365760">
+                <a:tc>
+                  <a:txBody>
+                    <a:bodyPr/>
+                    <a:lstStyle/>
+                    <a:p>
+                      <a:r>
+                        <a:rPr sz="1000" b="0"/>
+                        <a:t>QA-E1</a:t>
+                      </a:r>
+                    </a:p>
+                  </a:txBody>
+                  <a:tcPr/>
+                </a:tc>
+                <a:tc>
+                  <a:txBody>
+                    <a:bodyPr/>
+                    <a:lstStyle/>
+                    <a:p>
+                      <a:r>
+                        <a:rPr sz="1000" b="0"/>
+                        <a:t>warning signs</a:t>
+                      </a:r>
+                    </a:p>
+                  </a:txBody>
+                  <a:tcPr/>
+                </a:tc>
+                <a:tc>
+                  <a:txBody>
+                    <a:bodyPr/>
+                    <a:lstStyle/>
+                    <a:p>
+                      <a:r>
+                        <a:rPr sz="1000" b="0"/>
+                        <a:t>110</a:t>
+                      </a:r>
+                    </a:p>
+                  </a:txBody>
+                  <a:tcPr/>
+                </a:tc>
+                <a:tc>
+                  <a:txBody>
+                    <a:bodyPr/>
+                    <a:lstStyle/>
+                    <a:p>
+                      <a:r>
+                        <a:rPr sz="1000" b="0"/>
+                        <a:t>65%</a:t>
+                      </a:r>
+                    </a:p>
+                  </a:txBody>
+                  <a:tcPr/>
+                </a:tc>
+                <a:tc>
+                  <a:txBody>
+                    <a:bodyPr/>
+                    <a:lstStyle/>
+                    <a:p>
+                      <a:r>
+                        <a:rPr sz="1000" b="0"/>
+                        <a:t>0.679</a:t>
+                      </a:r>
+                    </a:p>
+                  </a:txBody>
+                  <a:tcPr/>
+                </a:tc>
+                <a:tc>
+                  <a:txBody>
+                    <a:bodyPr/>
+                    <a:lstStyle/>
+                    <a:p>
+                      <a:r>
+                        <a:rPr sz="1000" b="0"/>
+                        <a:t>0.026</a:t>
+                      </a:r>
+                    </a:p>
+                  </a:txBody>
+                  <a:tcPr/>
+                </a:tc>
+                <a:tc>
+                  <a:txBody>
+                    <a:bodyPr/>
+                    <a:lstStyle/>
+                    <a:p>
+                      <a:r>
+                        <a:rPr sz="1000" b="0"/>
+                        <a:t>15%</a:t>
+                      </a:r>
+                    </a:p>
+                  </a:txBody>
+                  <a:tcPr/>
+                </a:tc>
+                <a:tc>
+                  <a:txBody>
+                    <a:bodyPr/>
+                    <a:lstStyle/>
+                    <a:p>
+                      <a:r>
+                        <a:rPr sz="1000" b="0"/>
+                        <a:t>14</a:t>
+                      </a:r>
+                    </a:p>
+                  </a:txBody>
+                  <a:tcPr/>
+                </a:tc>
+              </a:tr>
+            </a:tbl>
+          </a:graphicData>
+        </a:graphic>
+      </p:graphicFrame>
+      <p:sp>
+        <p:nvSpPr>
+          <p:cNvPr id="4" name="TextBox 3"/>
+          <p:cNvSpPr txBox="1"/>
+          <p:nvPr/>
+        </p:nvSpPr>
+        <p:spPr>
+          <a:xfrm>
+            <a:off x="365760" y="5943600"/>
+            <a:ext cx="11430000" cy="731520"/>
+          </a:xfrm>
+          <a:prstGeom prst="rect">
+            <a:avLst/>
+          </a:prstGeom>
+          <a:noFill/>
+        </p:spPr>
+        <p:txBody>
+          <a:bodyPr wrap="square">
+            <a:spAutoFit/>
+          </a:bodyPr>
+          <a:lstStyle/>
+          <a:p>
+            <a:r>
+              <a:rPr sz="1200"/>
+              <a:t>QA-E0 answers from the full hospital course; QA-E1 from the three chunks retrieved with the question. UFR and CR are computed on answered questions only.</a:t>
+            </a:r>
+          </a:p>
+        </p:txBody>
+      </p:sp>
+    </p:spTree>
+  </p:cSld>
+  <p:clrMapOvr>
+    <a:masterClrMapping/>
+  </p:clrMapOvr>
+</p:sld>
+</file>
+
+<file path=ppt/slides/slide16.xml><?xml version="1.0" encoding="utf-8"?>
+<p:sld xmlns:a="http://schemas.openxmlformats.org/drawingml/2006/main" xmlns:p="http://schemas.openxmlformats.org/presentationml/2006/main" xmlns:r="http://schemas.openxmlformats.org/officeDocument/2006/relationships">
+  <p:cSld>
+    <p:spTree>
+      <p:nvGrpSpPr>
+        <p:cNvPr id="1" name=""/>
+        <p:cNvGrpSpPr/>
+        <p:nvPr/>
+      </p:nvGrpSpPr>
+      <p:grpSpPr/>
+      <p:sp>
+        <p:nvSpPr>
+          <p:cNvPr id="2" name="TextBox 1"/>
+          <p:cNvSpPr txBox="1"/>
+          <p:nvPr/>
+        </p:nvSpPr>
+        <p:spPr>
+          <a:xfrm>
+            <a:off x="365760" y="182880"/>
+            <a:ext cx="11430000" cy="822960"/>
+          </a:xfrm>
+          <a:prstGeom prst="rect">
+            <a:avLst/>
+          </a:prstGeom>
+          <a:noFill/>
+        </p:spPr>
+        <p:txBody>
+          <a:bodyPr wrap="square">
+            <a:spAutoFit/>
+          </a:bodyPr>
+          <a:lstStyle/>
+          <a:p>
+            <a:r>
+              <a:rPr sz="2800" b="1"/>
+              <a:t>Thesis writing status</a:t>
+            </a:r>
+          </a:p>
+        </p:txBody>
+      </p:sp>
+      <p:sp>
+        <p:nvSpPr>
+          <p:cNvPr id="3" name="TextBox 2"/>
+          <p:cNvSpPr txBox="1"/>
+          <p:nvPr/>
+        </p:nvSpPr>
+        <p:spPr>
+          <a:xfrm>
+            <a:off x="457200" y="1097280"/>
+            <a:ext cx="11247120" cy="5303520"/>
+          </a:xfrm>
+          <a:prstGeom prst="rect">
+            <a:avLst/>
+          </a:prstGeom>
+          <a:noFill/>
+        </p:spPr>
+        <p:txBody>
+          <a:bodyPr wrap="square">
+            <a:spAutoFit/>
+          </a:bodyPr>
+          <a:lstStyle/>
+          <a:p>
+            <a:pPr>
+              <a:spcAft>
+                <a:spcPts val="800"/>
+              </a:spcAft>
+            </a:pPr>
+            <a:r>
+              <a:rPr sz="1600"/>
+              <a:t>• Complete draft generated from the result files: 136 pages in CSUN format (1-inch margins, 12-pt Times New Roman, double-spaced, roman-numbered preliminary pages, arabic body)</a:t>
+            </a:r>
+          </a:p>
+          <a:p>
+            <a:pPr>
+              <a:spcAft>
+                <a:spcPts val="800"/>
+              </a:spcAft>
+            </a:pPr>
+            <a:r>
+              <a:rPr sz="1600"/>
+              <a:t>• Nine chapters: 1 Introduction, 2 Literature Review, 3 Data, 4 Methodology, 5 Pilot Study on MTSamples, 6 Selecting a Valid Judge, 7 Main Study on MIMIC-IV, 8 Discussion, 9 Conclusion; IEEE references with DOIs; Appendices A to E (prompts, per-document results, worked examples, repository, threshold sweep)</a:t>
+            </a:r>
+          </a:p>
+          <a:p>
+            <a:pPr>
+              <a:spcAft>
+                <a:spcPts val="800"/>
+              </a:spcAft>
+            </a:pPr>
+            <a:r>
+              <a:rPr sz="1600"/>
+              <a:t>• Since the September 4 draft: judge selection study, MedNLI adaptation, main study on MIMIC-IV with a local model (citations, coverage against the clinician's instructions, citation accuracy, ablations), question-answering pilot</a:t>
+            </a:r>
+          </a:p>
+          <a:p>
+            <a:pPr>
+              <a:spcAft>
+                <a:spcPts val="800"/>
+              </a:spcAft>
+            </a:pPr>
+            <a:r>
+              <a:rPr sz="1600"/>
+              <a:t>• Open items: committee composition to be confirmed with the advisor; advisor review of the draft; final title on the ETD planning form (with or without 'and Question Answering')</a:t>
+            </a:r>
+          </a:p>
+          <a:p>
+            <a:pPr>
+              <a:spcAft>
+                <a:spcPts val="800"/>
+              </a:spcAft>
+            </a:pPr>
+            <a:r>
+              <a:rPr sz="1600"/>
+              <a:t>• Every table and figure is regenerated by one command from the result files</a:t>
+            </a:r>
+          </a:p>
+        </p:txBody>
+      </p:sp>
+    </p:spTree>
+  </p:cSld>
+  <p:clrMapOvr>
+    <a:masterClrMapping/>
+  </p:clrMapOvr>
+</p:sld>
+</file>
+
+<file path=ppt/slides/slide17.xml><?xml version="1.0" encoding="utf-8"?>
+<p:sld xmlns:a="http://schemas.openxmlformats.org/drawingml/2006/main" xmlns:p="http://schemas.openxmlformats.org/presentationml/2006/main" xmlns:r="http://schemas.openxmlformats.org/officeDocument/2006/relationships">
+  <p:cSld>
+    <p:spTree>
+      <p:nvGrpSpPr>
+        <p:cNvPr id="1" name=""/>
+        <p:cNvGrpSpPr/>
+        <p:nvPr/>
+      </p:nvGrpSpPr>
+      <p:grpSpPr/>
+      <p:sp>
+        <p:nvSpPr>
+          <p:cNvPr id="2" name="TextBox 1"/>
+          <p:cNvSpPr txBox="1"/>
+          <p:nvPr/>
+        </p:nvSpPr>
+        <p:spPr>
+          <a:xfrm>
+            <a:off x="365760" y="182880"/>
+            <a:ext cx="11430000" cy="822960"/>
+          </a:xfrm>
+          <a:prstGeom prst="rect">
+            <a:avLst/>
+          </a:prstGeom>
+          <a:noFill/>
+        </p:spPr>
+        <p:txBody>
+          <a:bodyPr wrap="square">
+            <a:spAutoFit/>
+          </a:bodyPr>
+          <a:lstStyle/>
+          <a:p>
+            <a:r>
+              <a:rPr sz="2800" b="1"/>
+              <a:t>Plan to the defense (aligned with CSUN ETD deadlines)</a:t>
+            </a:r>
+          </a:p>
+        </p:txBody>
+      </p:sp>
+      <p:graphicFrame>
+        <p:nvGraphicFramePr>
+          <p:cNvPr id="3" name="Table 2"/>
+          <p:cNvGraphicFramePr>
+            <a:graphicFrameLocks noGrp="1"/>
+          </p:cNvGraphicFramePr>
+          <p:nvPr/>
+        </p:nvGraphicFramePr>
+        <p:xfrm>
+          <a:off x="365760" y="1097280"/>
+          <a:ext cx="11429999" cy="2926080"/>
+        </p:xfrm>
+        <a:graphic>
+          <a:graphicData uri="http://schemas.openxmlformats.org/drawingml/2006/table">
+            <a:tbl>
+              <a:tblPr firstRow="1" bandRow="1">
+                <a:tableStyleId>{5C22544A-7EE6-4342-B048-85BDC9FD1C3A}</a:tableStyleId>
+              </a:tblPr>
+              <a:tblGrid>
+                <a:gridCol w="2267107"/>
+                <a:gridCol w="9162892"/>
+              </a:tblGrid>
+              <a:tr h="365760">
+                <a:tc>
+                  <a:txBody>
+                    <a:bodyPr/>
+                    <a:lstStyle/>
+                    <a:p>
+                      <a:r>
+                        <a:rPr sz="1100" b="1"/>
+                        <a:t>By</a:t>
+                      </a:r>
+                    </a:p>
+                  </a:txBody>
+                  <a:tcPr/>
+                </a:tc>
+                <a:tc>
+                  <a:txBody>
+                    <a:bodyPr/>
+                    <a:lstStyle/>
+                    <a:p>
+                      <a:r>
+                        <a:rPr sz="1100" b="1"/>
+                        <a:t>Milestone</a:t>
+                      </a:r>
+                    </a:p>
+                  </a:txBody>
+                  <a:tcPr/>
+                </a:tc>
+              </a:tr>
+              <a:tr h="365760">
+                <a:tc>
+                  <a:txBody>
+                    <a:bodyPr/>
+                    <a:lstStyle/>
+                    <a:p>
+                      <a:r>
+                        <a:rPr sz="1000" b="0"/>
+                        <a:t>Sep 22, 2026</a:t>
+                      </a:r>
+                    </a:p>
+                  </a:txBody>
+                  <a:tcPr/>
+                </a:tc>
+                <a:tc>
+                  <a:txBody>
+                    <a:bodyPr/>
+                    <a:lstStyle/>
+                    <a:p>
+                      <a:r>
+                        <a:rPr sz="1000" b="0"/>
+                        <a:t>Advisor review of the complete draft; committee composition discussed</a:t>
+                      </a:r>
+                    </a:p>
+                  </a:txBody>
+                  <a:tcPr/>
+                </a:tc>
+              </a:tr>
+              <a:tr h="365760">
+                <a:tc>
+                  <a:txBody>
+                    <a:bodyPr/>
+                    <a:lstStyle/>
+                    <a:p>
+                      <a:r>
+                        <a:rPr sz="1000" b="0"/>
+                        <a:t>Oct 9, 2026</a:t>
+                      </a:r>
+                    </a:p>
+                  </a:txBody>
+                  <a:tcPr/>
+                </a:tc>
+                <a:tc>
+                  <a:txBody>
+                    <a:bodyPr/>
+                    <a:lstStyle/>
+                    <a:p>
+                      <a:r>
+                        <a:rPr sz="1000" b="0"/>
+                        <a:t>ETD Planning Form filed (title and committee)</a:t>
+                      </a:r>
+                    </a:p>
+                  </a:txBody>
+                  <a:tcPr/>
+                </a:tc>
+              </a:tr>
+              <a:tr h="365760">
+                <a:tc>
+                  <a:txBody>
+                    <a:bodyPr/>
+                    <a:lstStyle/>
+                    <a:p>
+                      <a:r>
+                        <a:rPr sz="1000" b="0"/>
+                        <a:t>Oct 16, 2026</a:t>
+                      </a:r>
+                    </a:p>
+                  </a:txBody>
+                  <a:tcPr/>
+                </a:tc>
+                <a:tc>
+                  <a:txBody>
+                    <a:bodyPr/>
+                    <a:lstStyle/>
+                    <a:p>
+                      <a:r>
+                        <a:rPr sz="1000" b="0"/>
+                        <a:t>Revised draft to advisor for approval; Canvas upload and Turnitin check after approval</a:t>
+                      </a:r>
+                    </a:p>
+                  </a:txBody>
+                  <a:tcPr/>
+                </a:tc>
+              </a:tr>
+              <a:tr h="365760">
+                <a:tc>
+                  <a:txBody>
+                    <a:bodyPr/>
+                    <a:lstStyle/>
+                    <a:p>
+                      <a:r>
+                        <a:rPr sz="1000" b="0"/>
+                        <a:t>Oct 23, 2026</a:t>
+                      </a:r>
+                    </a:p>
+                  </a:txBody>
+                  <a:tcPr/>
+                </a:tc>
+                <a:tc>
+                  <a:txBody>
+                    <a:bodyPr/>
+                    <a:lstStyle/>
+                    <a:p>
+                      <a:r>
+                        <a:rPr sz="1000" b="0"/>
+                        <a:t>Draft to committee (two-week review); Doodle poll with 1-hour slots over 3 to 4 weeks</a:t>
+                      </a:r>
+                    </a:p>
+                  </a:txBody>
+                  <a:tcPr/>
+                </a:tc>
+              </a:tr>
+              <a:tr h="365760">
+                <a:tc>
+                  <a:txBody>
+                    <a:bodyPr/>
+                    <a:lstStyle/>
+                    <a:p>
+                      <a:r>
+                        <a:rPr sz="1000" b="0"/>
+                        <a:t>Nov 6, 2026</a:t>
+                      </a:r>
+                    </a:p>
+                  </a:txBody>
+                  <a:tcPr/>
+                </a:tc>
+                <a:tc>
+                  <a:txBody>
+                    <a:bodyPr/>
+                    <a:lstStyle/>
+                    <a:p>
+                      <a:r>
+                        <a:rPr sz="1000" b="0"/>
+                        <a:t>ETD preliminary format review</a:t>
+                      </a:r>
+                    </a:p>
+                  </a:txBody>
+                  <a:tcPr/>
+                </a:tc>
+              </a:tr>
+              <a:tr h="365760">
+                <a:tc>
+                  <a:txBody>
+                    <a:bodyPr/>
+                    <a:lstStyle/>
+                    <a:p>
+                      <a:r>
+                        <a:rPr sz="1000" b="0"/>
+                        <a:t>Nov 16 to 24, 2026</a:t>
+                      </a:r>
+                    </a:p>
+                  </a:txBody>
+                  <a:tcPr/>
+                </a:tc>
+                <a:tc>
+                  <a:txBody>
+                    <a:bodyPr/>
+                    <a:lstStyle/>
+                    <a:p>
+                      <a:r>
+                        <a:rPr sz="1000" b="0"/>
+                        <a:t>Defense (40 min presentation, 10 min Q&amp;A); slides to advisor one week before</a:t>
+                      </a:r>
+                    </a:p>
+                  </a:txBody>
+                  <a:tcPr/>
+                </a:tc>
+              </a:tr>
+              <a:tr h="365760">
+                <a:tc>
+                  <a:txBody>
+                    <a:bodyPr/>
+                    <a:lstStyle/>
+                    <a:p>
+                      <a:r>
+                        <a:rPr sz="1000" b="0"/>
+                        <a:t>Dec 4, 2026</a:t>
+                      </a:r>
+                    </a:p>
+                  </a:txBody>
+                  <a:tcPr/>
+                </a:tc>
+                <a:tc>
+                  <a:txBody>
+                    <a:bodyPr/>
+                    <a:lstStyle/>
+                    <a:p>
+                      <a:r>
+                        <a:rPr sz="1000" b="0"/>
+                        <a:t>Final ETD upload after revisions</a:t>
+                      </a:r>
+                    </a:p>
+                  </a:txBody>
+                  <a:tcPr/>
+                </a:tc>
+              </a:tr>
+            </a:tbl>
+          </a:graphicData>
+        </a:graphic>
+      </p:graphicFrame>
+      <p:sp>
+        <p:nvSpPr>
+          <p:cNvPr id="4" name="TextBox 3"/>
+          <p:cNvSpPr txBox="1"/>
+          <p:nvPr/>
+        </p:nvSpPr>
+        <p:spPr>
+          <a:xfrm>
+            <a:off x="365760" y="5943600"/>
+            <a:ext cx="11430000" cy="731520"/>
+          </a:xfrm>
+          <a:prstGeom prst="rect">
+            <a:avLst/>
+          </a:prstGeom>
+          <a:noFill/>
+        </p:spPr>
+        <p:txBody>
+          <a:bodyPr wrap="square">
+            <a:spAutoFit/>
+          </a:bodyPr>
+          <a:lstStyle/>
+          <a:p>
+            <a:r>
+              <a:rPr sz="1200"/>
+              <a:t>The December 12 defense date in the May report is after the December 4 ETD deadline and has been moved.</a:t>
+            </a:r>
+          </a:p>
+        </p:txBody>
+      </p:sp>
+    </p:spTree>
+  </p:cSld>
+  <p:clrMapOvr>
+    <a:masterClrMapping/>
+  </p:clrMapOvr>
+</p:sld>
+</file>
+
+<file path=ppt/slides/slide18.xml><?xml version="1.0" encoding="utf-8"?>
+<p:sld xmlns:a="http://schemas.openxmlformats.org/drawingml/2006/main" xmlns:p="http://schemas.openxmlformats.org/presentationml/2006/main" xmlns:r="http://schemas.openxmlformats.org/officeDocument/2006/relationships">
+  <p:cSld>
+    <p:spTree>
+      <p:nvGrpSpPr>
+        <p:cNvPr id="1" name=""/>
+        <p:cNvGrpSpPr/>
+        <p:nvPr/>
+      </p:nvGrpSpPr>
+      <p:grpSpPr/>
+      <p:sp>
+        <p:nvSpPr>
+          <p:cNvPr id="2" name="TextBox 1"/>
+          <p:cNvSpPr txBox="1"/>
+          <p:nvPr/>
+        </p:nvSpPr>
+        <p:spPr>
+          <a:xfrm>
+            <a:off x="365760" y="182880"/>
+            <a:ext cx="11430000" cy="822960"/>
+          </a:xfrm>
+          <a:prstGeom prst="rect">
+            <a:avLst/>
+          </a:prstGeom>
+          <a:noFill/>
+        </p:spPr>
+        <p:txBody>
+          <a:bodyPr wrap="square">
+            <a:spAutoFit/>
+          </a:bodyPr>
+          <a:lstStyle/>
+          <a:p>
+            <a:r>
+              <a:rPr sz="2800" b="1"/>
               <a:t>Risks and requests</a:t>
             </a:r>
           </a:p>
@@ -4201,7 +6831,7 @@
                     <a:p>
                       <a:r>
                         <a:rPr sz="1000" b="0"/>
-                        <a:t>Done: pilot judge validated (kappa 0.06); five candidates compared; DeBERTa-v3-large NLI selected (kappa 0.33, AUROC 0.78)</a:t>
+                        <a:t>Done: pilot judge validated (kappa 0.06); five candidates compared; DeBERTa-v3-large NLI selected (kappa 0.33, AUROC 0.78); MedNLI fine-tune: dev accuracy 87.8%</a:t>
                       </a:r>
                     </a:p>
                   </a:txBody>
@@ -4229,7 +6859,7 @@
                     <a:p>
                       <a:r>
                         <a:rPr sz="1000" b="0"/>
-                        <a:t>Generation complete or in progress on 110 MIMIC-IV hospital courses with a local Qwen2.5-7B-Instruct; evaluation pending</a:t>
+                        <a:t>Done: 110 MIMIC-IV hospital courses, Qwen2.5-7B-Instruct served locally, no protected text leaves the laptop</a:t>
                       </a:r>
                     </a:p>
                   </a:txBody>
@@ -6072,7 +8702,7 @@
         </p:nvGraphicFramePr>
         <p:xfrm>
           <a:off x="365760" y="1097280"/>
-          <a:ext cx="11429996" cy="4023360"/>
+          <a:ext cx="11429996" cy="4754880"/>
         </p:xfrm>
         <a:graphic>
           <a:graphicData uri="http://schemas.openxmlformats.org/drawingml/2006/table">
@@ -6376,6 +9006,99 @@
                     <a:p>
                       <a:r>
                         <a:rPr sz="1000" b="0"/>
+                        <a:t>DeBERTa-v3-large NLI fine-tuned on MedNLI</a:t>
+                      </a:r>
+                    </a:p>
+                  </a:txBody>
+                  <a:tcPr/>
+                </a:tc>
+                <a:tc>
+                  <a:txBody>
+                    <a:bodyPr/>
+                    <a:lstStyle/>
+                    <a:p>
+                      <a:r>
+                        <a:rPr sz="1000" b="0"/>
+                        <a:t>whole course, windowed</a:t>
+                      </a:r>
+                    </a:p>
+                  </a:txBody>
+                  <a:tcPr/>
+                </a:tc>
+                <a:tc>
+                  <a:txBody>
+                    <a:bodyPr/>
+                    <a:lstStyle/>
+                    <a:p>
+                      <a:r>
+                        <a:rPr sz="1000" b="0"/>
+                        <a:t>0.75</a:t>
+                      </a:r>
+                    </a:p>
+                  </a:txBody>
+                  <a:tcPr/>
+                </a:tc>
+                <a:tc>
+                  <a:txBody>
+                    <a:bodyPr/>
+                    <a:lstStyle/>
+                    <a:p>
+                      <a:r>
+                        <a:rPr sz="1000" b="0"/>
+                        <a:t>0.44</a:t>
+                      </a:r>
+                    </a:p>
+                  </a:txBody>
+                  <a:tcPr/>
+                </a:tc>
+                <a:tc>
+                  <a:txBody>
+                    <a:bodyPr/>
+                    <a:lstStyle/>
+                    <a:p>
+                      <a:r>
+                        <a:rPr sz="1000" b="0"/>
+                        <a:t>0.46</a:t>
+                      </a:r>
+                    </a:p>
+                  </a:txBody>
+                  <a:tcPr/>
+                </a:tc>
+                <a:tc>
+                  <a:txBody>
+                    <a:bodyPr/>
+                    <a:lstStyle/>
+                    <a:p>
+                      <a:r>
+                        <a:rPr sz="1000" b="0"/>
+                        <a:t>0.31</a:t>
+                      </a:r>
+                    </a:p>
+                  </a:txBody>
+                  <a:tcPr/>
+                </a:tc>
+                <a:tc>
+                  <a:txBody>
+                    <a:bodyPr/>
+                    <a:lstStyle/>
+                    <a:p>
+                      <a:r>
+                        <a:rPr sz="1000" b="0"/>
+                        <a:t>21%</a:t>
+                      </a:r>
+                    </a:p>
+                  </a:txBody>
+                  <a:tcPr/>
+                </a:tc>
+              </a:tr>
+              <a:tr h="365760">
+                <a:tc>
+                  <a:txBody>
+                    <a:bodyPr/>
+                    <a:lstStyle/>
+                    <a:p>
+                      <a:r>
+                        <a:rPr sz="1000" b="0"/>
                         <a:t>DeBERTa-v3-large NLI</a:t>
                       </a:r>
                     </a:p>
@@ -6455,6 +9178,99 @@
                       <a:r>
                         <a:rPr sz="1000" b="0"/>
                         <a:t>42%</a:t>
+                      </a:r>
+                    </a:p>
+                  </a:txBody>
+                  <a:tcPr/>
+                </a:tc>
+              </a:tr>
+              <a:tr h="365760">
+                <a:tc>
+                  <a:txBody>
+                    <a:bodyPr/>
+                    <a:lstStyle/>
+                    <a:p>
+                      <a:r>
+                        <a:rPr sz="1000" b="0"/>
+                        <a:t>DeBERTa-v3-large NLI fine-tuned on MedNLI</a:t>
+                      </a:r>
+                    </a:p>
+                  </a:txBody>
+                  <a:tcPr/>
+                </a:tc>
+                <a:tc>
+                  <a:txBody>
+                    <a:bodyPr/>
+                    <a:lstStyle/>
+                    <a:p>
+                      <a:r>
+                        <a:rPr sz="1000" b="0"/>
+                        <a:t>top-3 sentences</a:t>
+                      </a:r>
+                    </a:p>
+                  </a:txBody>
+                  <a:tcPr/>
+                </a:tc>
+                <a:tc>
+                  <a:txBody>
+                    <a:bodyPr/>
+                    <a:lstStyle/>
+                    <a:p>
+                      <a:r>
+                        <a:rPr sz="1000" b="0"/>
+                        <a:t>0.74</a:t>
+                      </a:r>
+                    </a:p>
+                  </a:txBody>
+                  <a:tcPr/>
+                </a:tc>
+                <a:tc>
+                  <a:txBody>
+                    <a:bodyPr/>
+                    <a:lstStyle/>
+                    <a:p>
+                      <a:r>
+                        <a:rPr sz="1000" b="0"/>
+                        <a:t>0.41</a:t>
+                      </a:r>
+                    </a:p>
+                  </a:txBody>
+                  <a:tcPr/>
+                </a:tc>
+                <a:tc>
+                  <a:txBody>
+                    <a:bodyPr/>
+                    <a:lstStyle/>
+                    <a:p>
+                      <a:r>
+                        <a:rPr sz="1000" b="0"/>
+                        <a:t>0.48</a:t>
+                      </a:r>
+                    </a:p>
+                  </a:txBody>
+                  <a:tcPr/>
+                </a:tc>
+                <a:tc>
+                  <a:txBody>
+                    <a:bodyPr/>
+                    <a:lstStyle/>
+                    <a:p>
+                      <a:r>
+                        <a:rPr sz="1000" b="0"/>
+                        <a:t>0.28</a:t>
+                      </a:r>
+                    </a:p>
+                  </a:txBody>
+                  <a:tcPr/>
+                </a:tc>
+                <a:tc>
+                  <a:txBody>
+                    <a:bodyPr/>
+                    <a:lstStyle/>
+                    <a:p>
+                      <a:r>
+                        <a:rPr sz="1000" b="0"/>
+                        <a:t>24%</a:t>
                       </a:r>
                     </a:p>
                   </a:txBody>
@@ -7209,7 +10025,7 @@
         <p:spPr>
           <a:xfrm>
             <a:off x="365760" y="1097280"/>
-            <a:ext cx="11430000" cy="5184098"/>
+            <a:ext cx="11430000" cy="4608212"/>
           </a:xfrm>
           <a:prstGeom prst="rect">
             <a:avLst/>

</xml_diff>

<commit_message>
Second-judge agreement results in Chapter 7, discussion and conclusion; renderer sets grid column widths so tables honor their layout
Co-Authored-By: Claude Fable 5.1 <noreply@anthropic.com>
</commit_message>
<xml_diff>
--- a/deliverables/Progress_Slides_Fall2026.pptx
+++ b/deliverables/Progress_Slides_Fall2026.pptx
@@ -4374,6 +4374,17 @@
               <a:t>• Question answering: abstention 23% (full course) versus 33% (excerpts), highest for warning signs, which the course rarely states; retrieval lowers unsupported answers partly by abstaining more</a:t>
             </a:r>
           </a:p>
+          <a:p>
+            <a:pPr>
+              <a:spcAft>
+                <a:spcPts val="800"/>
+              </a:spcAft>
+            </a:pPr>
+            <a:r>
+              <a:rPr sz="1600"/>
+              <a:t>• Second judge (Bespoke-MiniCheck-7B, a 7B LLM checker): same ordering of conditions; flags 0.2% of verbatim extracts, so the NLI judge's 0.056 floor is judge error; confirms 40% of the selected judge's flags; grounded conditions' unsupported share bounded between 0.008 and 0.185</a:t>
+            </a:r>
+          </a:p>
         </p:txBody>
       </p:sp>
     </p:spTree>
@@ -6088,7 +6099,7 @@
             </a:pPr>
             <a:r>
               <a:rPr sz="1600"/>
-              <a:t>• Complete draft generated from the result files: 136 pages in CSUN format (1-inch margins, 12-pt Times New Roman, double-spaced, roman-numbered preliminary pages, arabic body)</a:t>
+              <a:t>• Complete draft generated from the result files: 139 pages in CSUN format (1-inch margins, 12-pt Times New Roman, double-spaced, roman-numbered preliminary pages, arabic body)</a:t>
             </a:r>
           </a:p>
           <a:p>
@@ -6831,7 +6842,7 @@
                     <a:p>
                       <a:r>
                         <a:rPr sz="1000" b="0"/>
-                        <a:t>Done: pilot judge validated (kappa 0.06); five candidates compared; DeBERTa-v3-large NLI selected (kappa 0.33, AUROC 0.78); MedNLI fine-tune: dev accuracy 87.8%</a:t>
+                        <a:t>Done: pilot judge validated (kappa 0.06); six candidates compared; DeBERTa-v3-large NLI selected (kappa 0.33, AUROC 0.78); MedNLI fine-tune: dev accuracy 87.8%</a:t>
                       </a:r>
                     </a:p>
                   </a:txBody>
@@ -8702,7 +8713,7 @@
         </p:nvGraphicFramePr>
         <p:xfrm>
           <a:off x="365760" y="1097280"/>
-          <a:ext cx="11429996" cy="4754880"/>
+          <a:ext cx="11429996" cy="5486400"/>
         </p:xfrm>
         <a:graphic>
           <a:graphicData uri="http://schemas.openxmlformats.org/drawingml/2006/table">
@@ -9085,6 +9096,192 @@
                       <a:r>
                         <a:rPr sz="1000" b="0"/>
                         <a:t>21%</a:t>
+                      </a:r>
+                    </a:p>
+                  </a:txBody>
+                  <a:tcPr/>
+                </a:tc>
+              </a:tr>
+              <a:tr h="365760">
+                <a:tc>
+                  <a:txBody>
+                    <a:bodyPr/>
+                    <a:lstStyle/>
+                    <a:p>
+                      <a:r>
+                        <a:rPr sz="1000" b="0"/>
+                        <a:t>Bespoke-MiniCheck-7B (LLM checker)</a:t>
+                      </a:r>
+                    </a:p>
+                  </a:txBody>
+                  <a:tcPr/>
+                </a:tc>
+                <a:tc>
+                  <a:txBody>
+                    <a:bodyPr/>
+                    <a:lstStyle/>
+                    <a:p>
+                      <a:r>
+                        <a:rPr sz="1000" b="0"/>
+                        <a:t>top-3 sentences</a:t>
+                      </a:r>
+                    </a:p>
+                  </a:txBody>
+                  <a:tcPr/>
+                </a:tc>
+                <a:tc>
+                  <a:txBody>
+                    <a:bodyPr/>
+                    <a:lstStyle/>
+                    <a:p>
+                      <a:r>
+                        <a:rPr sz="1000" b="0"/>
+                        <a:t>0.75</a:t>
+                      </a:r>
+                    </a:p>
+                  </a:txBody>
+                  <a:tcPr/>
+                </a:tc>
+                <a:tc>
+                  <a:txBody>
+                    <a:bodyPr/>
+                    <a:lstStyle/>
+                    <a:p>
+                      <a:r>
+                        <a:rPr sz="1000" b="0"/>
+                        <a:t>0.39</a:t>
+                      </a:r>
+                    </a:p>
+                  </a:txBody>
+                  <a:tcPr/>
+                </a:tc>
+                <a:tc>
+                  <a:txBody>
+                    <a:bodyPr/>
+                    <a:lstStyle/>
+                    <a:p>
+                      <a:r>
+                        <a:rPr sz="1000" b="0"/>
+                        <a:t>0.60</a:t>
+                      </a:r>
+                    </a:p>
+                  </a:txBody>
+                  <a:tcPr/>
+                </a:tc>
+                <a:tc>
+                  <a:txBody>
+                    <a:bodyPr/>
+                    <a:lstStyle/>
+                    <a:p>
+                      <a:r>
+                        <a:rPr sz="1000" b="0"/>
+                        <a:t>0.30</a:t>
+                      </a:r>
+                    </a:p>
+                  </a:txBody>
+                  <a:tcPr/>
+                </a:tc>
+                <a:tc>
+                  <a:txBody>
+                    <a:bodyPr/>
+                    <a:lstStyle/>
+                    <a:p>
+                      <a:r>
+                        <a:rPr sz="1000" b="0"/>
+                        <a:t>31%</a:t>
+                      </a:r>
+                    </a:p>
+                  </a:txBody>
+                  <a:tcPr/>
+                </a:tc>
+              </a:tr>
+              <a:tr h="365760">
+                <a:tc>
+                  <a:txBody>
+                    <a:bodyPr/>
+                    <a:lstStyle/>
+                    <a:p>
+                      <a:r>
+                        <a:rPr sz="1000" b="0"/>
+                        <a:t>Bespoke-MiniCheck-7B (LLM checker)</a:t>
+                      </a:r>
+                    </a:p>
+                  </a:txBody>
+                  <a:tcPr/>
+                </a:tc>
+                <a:tc>
+                  <a:txBody>
+                    <a:bodyPr/>
+                    <a:lstStyle/>
+                    <a:p>
+                      <a:r>
+                        <a:rPr sz="1000" b="0"/>
+                        <a:t>whole course, windowed</a:t>
+                      </a:r>
+                    </a:p>
+                  </a:txBody>
+                  <a:tcPr/>
+                </a:tc>
+                <a:tc>
+                  <a:txBody>
+                    <a:bodyPr/>
+                    <a:lstStyle/>
+                    <a:p>
+                      <a:r>
+                        <a:rPr sz="1000" b="0"/>
+                        <a:t>0.72</a:t>
+                      </a:r>
+                    </a:p>
+                  </a:txBody>
+                  <a:tcPr/>
+                </a:tc>
+                <a:tc>
+                  <a:txBody>
+                    <a:bodyPr/>
+                    <a:lstStyle/>
+                    <a:p>
+                      <a:r>
+                        <a:rPr sz="1000" b="0"/>
+                        <a:t>0.38</a:t>
+                      </a:r>
+                    </a:p>
+                  </a:txBody>
+                  <a:tcPr/>
+                </a:tc>
+                <a:tc>
+                  <a:txBody>
+                    <a:bodyPr/>
+                    <a:lstStyle/>
+                    <a:p>
+                      <a:r>
+                        <a:rPr sz="1000" b="0"/>
+                        <a:t>0.62</a:t>
+                      </a:r>
+                    </a:p>
+                  </a:txBody>
+                  <a:tcPr/>
+                </a:tc>
+                <a:tc>
+                  <a:txBody>
+                    <a:bodyPr/>
+                    <a:lstStyle/>
+                    <a:p>
+                      <a:r>
+                        <a:rPr sz="1000" b="0"/>
+                        <a:t>0.29</a:t>
+                      </a:r>
+                    </a:p>
+                  </a:txBody>
+                  <a:tcPr/>
+                </a:tc>
+                <a:tc>
+                  <a:txBody>
+                    <a:bodyPr/>
+                    <a:lstStyle/>
+                    <a:p>
+                      <a:r>
+                        <a:rPr sz="1000" b="0"/>
+                        <a:t>33%</a:t>
                       </a:r>
                     </a:p>
                   </a:txBody>

</xml_diff>

<commit_message>
Second thesis draft: committee on the signature page, consistency pass, corrected ablation statistics
- Signature page lists the committee (Ebrahimi, McIlhenny, Wang as chair)
- Chapters 1 to 4 brought in line with the main study; Chapter 4 numbering gap fixed
- Retrieval ablations reported with Holm-adjusted p-values; pilot Holm family described correctly
- Paired tests under the second judge; hypotheses answered across both studies in Chapter 8
- Section 8.4 and Table 8.1 rewritten for both studies; literature review extended
- Table renderer sizes columns so header words are never split
- Second progress report slides
</commit_message>
<xml_diff>
--- a/deliverables/Progress_Slides_Fall2026.pptx
+++ b/deliverables/Progress_Slides_Fall2026.pptx
@@ -23,6 +23,8 @@
     <p:sldId id="271" r:id="rId22"/>
     <p:sldId id="272" r:id="rId23"/>
     <p:sldId id="273" r:id="rId24"/>
+    <p:sldId id="274" r:id="rId25"/>
+    <p:sldId id="275" r:id="rId26"/>
   </p:sldIdLst>
   <p:sldSz cx="12191695" cy="6858000" type="screen4x3"/>
   <p:notesSz cx="6858000" cy="9144000"/>
@@ -3135,7 +3137,7 @@
           <a:p>
             <a:r>
               <a:rPr sz="1800"/>
-              <a:t>Progress Report, Fall 2026 (COMP 698C)</a:t>
+              <a:t>Second Progress Report, Fall 2026 (COMP 698C)</a:t>
             </a:r>
           </a:p>
           <a:p>
@@ -3147,13 +3149,13 @@
           <a:p>
             <a:r>
               <a:rPr sz="1800"/>
-              <a:t>Advisor: Dr. Taehyung (George) Wang</a:t>
+              <a:t>Committee: Dr. Taehyung (George) Wang (chair), Dr. Mahdi Ebrahimi, Dr. Robert McIlhenny</a:t>
             </a:r>
           </a:p>
           <a:p>
             <a:r>
               <a:rPr sz="1800"/>
-              <a:t>California State University, Northridge, September 16, 2026</a:t>
+              <a:t>California State University, Northridge, October 12, 2026</a:t>
             </a:r>
           </a:p>
         </p:txBody>
@@ -4360,7 +4362,7 @@
             </a:pPr>
             <a:r>
               <a:rPr sz="1600"/>
-              <a:t>• Citations: 72% accurate for excerpt-only RAG but 38% for RAG with the whole course; requiring citations lowered UFR (dropping the requirement raised it by 0.030) and three-sentence chunks raised CR, while other retrieval settings changed only coverage; coverage followed the amount of retrieved text</a:t>
+              <a:t>• Citations: 72% accurate for excerpt-only RAG but 38% for RAG with the whole course; no retrieval setting changed faithfulness after correction for multiple comparisons (the largest effect, dropping the citation requirement, raised UFR by 0.030, p = 0.017 before correction); coverage followed the amount of retrieved text</a:t>
             </a:r>
           </a:p>
           <a:p>
@@ -4956,7 +4958,7 @@
           <a:p>
             <a:r>
               <a:rPr sz="1200"/>
-              <a:t>Negative UFR and CR differences and positive coverage and citation differences favour the variant. Base: 5-sentence chunks, top-3, dense retrieval, citations required.</a:t>
+              <a:t>Negative UFR and CR differences and positive coverage and citation differences favor the variant. Base: 5-sentence chunks, top-3, dense retrieval, citations required.</a:t>
             </a:r>
           </a:p>
         </p:txBody>
@@ -6065,21 +6067,265 @@
           <a:p>
             <a:r>
               <a:rPr sz="2800" b="1"/>
-              <a:t>Thesis writing status</a:t>
+              <a:t>Hypotheses: verdicts across both studies</a:t>
             </a:r>
           </a:p>
         </p:txBody>
       </p:sp>
+      <p:graphicFrame>
+        <p:nvGraphicFramePr>
+          <p:cNvPr id="3" name="Table 2"/>
+          <p:cNvGraphicFramePr>
+            <a:graphicFrameLocks noGrp="1"/>
+          </p:cNvGraphicFramePr>
+          <p:nvPr/>
+        </p:nvGraphicFramePr>
+        <p:xfrm>
+          <a:off x="365760" y="1097280"/>
+          <a:ext cx="11429999" cy="1463040"/>
+        </p:xfrm>
+        <a:graphic>
+          <a:graphicData uri="http://schemas.openxmlformats.org/drawingml/2006/table">
+            <a:tbl>
+              <a:tblPr firstRow="1" bandRow="1">
+                <a:tableStyleId>{5C22544A-7EE6-4342-B048-85BDC9FD1C3A}</a:tableStyleId>
+              </a:tblPr>
+              <a:tblGrid>
+                <a:gridCol w="2833884"/>
+                <a:gridCol w="2833884"/>
+                <a:gridCol w="3400661"/>
+                <a:gridCol w="2361570"/>
+              </a:tblGrid>
+              <a:tr h="365760">
+                <a:tc>
+                  <a:txBody>
+                    <a:bodyPr/>
+                    <a:lstStyle/>
+                    <a:p>
+                      <a:r>
+                        <a:rPr sz="1100" b="1"/>
+                        <a:t>Hypothesis</a:t>
+                      </a:r>
+                    </a:p>
+                  </a:txBody>
+                  <a:tcPr/>
+                </a:tc>
+                <a:tc>
+                  <a:txBody>
+                    <a:bodyPr/>
+                    <a:lstStyle/>
+                    <a:p>
+                      <a:r>
+                        <a:rPr sz="1100" b="1"/>
+                        <a:t>Pilot (MTSamples, GPT-4o-mini)</a:t>
+                      </a:r>
+                    </a:p>
+                  </a:txBody>
+                  <a:tcPr/>
+                </a:tc>
+                <a:tc>
+                  <a:txBody>
+                    <a:bodyPr/>
+                    <a:lstStyle/>
+                    <a:p>
+                      <a:r>
+                        <a:rPr sz="1100" b="1"/>
+                        <a:t>Main study (MIMIC-IV, local model)</a:t>
+                      </a:r>
+                    </a:p>
+                  </a:txBody>
+                  <a:tcPr/>
+                </a:tc>
+                <a:tc>
+                  <a:txBody>
+                    <a:bodyPr/>
+                    <a:lstStyle/>
+                    <a:p>
+                      <a:r>
+                        <a:rPr sz="1100" b="1"/>
+                        <a:t>Verdict</a:t>
+                      </a:r>
+                    </a:p>
+                  </a:txBody>
+                  <a:tcPr/>
+                </a:tc>
+              </a:tr>
+              <a:tr h="365760">
+                <a:tc>
+                  <a:txBody>
+                    <a:bodyPr/>
+                    <a:lstStyle/>
+                    <a:p>
+                      <a:r>
+                        <a:rPr sz="1000" b="0"/>
+                        <a:t>H1: unsupported content is measurable, and the judge agrees with experts better than chance</a:t>
+                      </a:r>
+                    </a:p>
+                  </a:txBody>
+                  <a:tcPr/>
+                </a:tc>
+                <a:tc>
+                  <a:txBody>
+                    <a:bodyPr/>
+                    <a:lstStyle/>
+                    <a:p>
+                      <a:r>
+                        <a:rPr sz="1000" b="0"/>
+                        <a:t>UFR 0.811 under a judge with kappa 0.06 (chance level)</a:t>
+                      </a:r>
+                    </a:p>
+                  </a:txBody>
+                  <a:tcPr/>
+                </a:tc>
+                <a:tc>
+                  <a:txBody>
+                    <a:bodyPr/>
+                    <a:lstStyle/>
+                    <a:p>
+                      <a:r>
+                        <a:rPr sz="1000" b="0"/>
+                        <a:t>UFR 0.135, 7.8 points above the judge's floor; judge kappa 0.33</a:t>
+                      </a:r>
+                    </a:p>
+                  </a:txBody>
+                  <a:tcPr/>
+                </a:tc>
+                <a:tc>
+                  <a:txBody>
+                    <a:bodyPr/>
+                    <a:lstStyle/>
+                    <a:p>
+                      <a:r>
+                        <a:rPr sz="1000" b="0"/>
+                        <a:t>First half supported; second half supported only for the selected judge, moderately</a:t>
+                      </a:r>
+                    </a:p>
+                  </a:txBody>
+                  <a:tcPr/>
+                </a:tc>
+              </a:tr>
+              <a:tr h="365760">
+                <a:tc>
+                  <a:txBody>
+                    <a:bodyPr/>
+                    <a:lstStyle/>
+                    <a:p>
+                      <a:r>
+                        <a:rPr sz="1000" b="0"/>
+                        <a:t>H2: RAG reduces unsupported and contradicted statements</a:t>
+                      </a:r>
+                    </a:p>
+                  </a:txBody>
+                  <a:tcPr/>
+                </a:tc>
+                <a:tc>
+                  <a:txBody>
+                    <a:bodyPr/>
+                    <a:lstStyle/>
+                    <a:p>
+                      <a:r>
+                        <a:rPr sz="1000" b="0"/>
+                        <a:t>CR down 24% (p = 0.011, Holm p = 0.135); UFR unchanged</a:t>
+                      </a:r>
+                    </a:p>
+                  </a:txBody>
+                  <a:tcPr/>
+                </a:tc>
+                <a:tc>
+                  <a:txBody>
+                    <a:bodyPr/>
+                    <a:lstStyle/>
+                    <a:p>
+                      <a:r>
+                        <a:rPr sz="1000" b="0"/>
+                        <a:t>UFR down 51 percent (p &lt; 0.001); CR unchanged (p = 0.791)</a:t>
+                      </a:r>
+                    </a:p>
+                  </a:txBody>
+                  <a:tcPr/>
+                </a:tc>
+                <a:tc>
+                  <a:txBody>
+                    <a:bodyPr/>
+                    <a:lstStyle/>
+                    <a:p>
+                      <a:r>
+                        <a:rPr sz="1000" b="0"/>
+                        <a:t>Supported for unsupported facts on hospital courses; not for contradictions</a:t>
+                      </a:r>
+                    </a:p>
+                  </a:txBody>
+                  <a:tcPr/>
+                </a:tc>
+              </a:tr>
+              <a:tr h="365760">
+                <a:tc>
+                  <a:txBody>
+                    <a:bodyPr/>
+                    <a:lstStyle/>
+                    <a:p>
+                      <a:r>
+                        <a:rPr sz="1000" b="0"/>
+                        <a:t>H3: verification adds to RAG</a:t>
+                      </a:r>
+                    </a:p>
+                  </a:txBody>
+                  <a:tcPr/>
+                </a:tc>
+                <a:tc>
+                  <a:txBody>
+                    <a:bodyPr/>
+                    <a:lstStyle/>
+                    <a:p>
+                      <a:r>
+                        <a:rPr sz="1000" b="0"/>
+                        <a:t>E3 vs E1 UFR p &lt; 0.001</a:t>
+                      </a:r>
+                    </a:p>
+                  </a:txBody>
+                  <a:tcPr/>
+                </a:tc>
+                <a:tc>
+                  <a:txBody>
+                    <a:bodyPr/>
+                    <a:lstStyle/>
+                    <a:p>
+                      <a:r>
+                        <a:rPr sz="1000" b="0"/>
+                        <a:t>Selected judge: E3 = E1 (p = 0.651); second judge: 0.069 vs 0.134 (p &lt; 0.001)</a:t>
+                      </a:r>
+                    </a:p>
+                  </a:txBody>
+                  <a:tcPr/>
+                </a:tc>
+                <a:tc>
+                  <a:txBody>
+                    <a:bodyPr/>
+                    <a:lstStyle/>
+                    <a:p>
+                      <a:r>
+                        <a:rPr sz="1000" b="0"/>
+                        <a:t>Supported in the pilot; judge-dependent in the main study</a:t>
+                      </a:r>
+                    </a:p>
+                  </a:txBody>
+                  <a:tcPr/>
+                </a:tc>
+              </a:tr>
+            </a:tbl>
+          </a:graphicData>
+        </a:graphic>
+      </p:graphicFrame>
       <p:sp>
         <p:nvSpPr>
-          <p:cNvPr id="3" name="TextBox 2"/>
+          <p:cNvPr id="4" name="TextBox 3"/>
           <p:cNvSpPr txBox="1"/>
           <p:nvPr/>
         </p:nvSpPr>
         <p:spPr>
           <a:xfrm>
-            <a:off x="457200" y="1097280"/>
-            <a:ext cx="11247120" cy="5303520"/>
+            <a:off x="365760" y="5943600"/>
+            <a:ext cx="11430000" cy="731520"/>
           </a:xfrm>
           <a:prstGeom prst="rect">
             <a:avLst/>
@@ -6092,58 +6338,9 @@
           </a:bodyPr>
           <a:lstStyle/>
           <a:p>
-            <a:pPr>
-              <a:spcAft>
-                <a:spcPts val="800"/>
-              </a:spcAft>
-            </a:pPr>
-            <a:r>
-              <a:rPr sz="1600"/>
-              <a:t>• Complete draft generated from the result files: 139 pages in CSUN format (1-inch margins, 12-pt Times New Roman, double-spaced, roman-numbered preliminary pages, arabic body)</a:t>
-            </a:r>
-          </a:p>
-          <a:p>
-            <a:pPr>
-              <a:spcAft>
-                <a:spcPts val="800"/>
-              </a:spcAft>
-            </a:pPr>
-            <a:r>
-              <a:rPr sz="1600"/>
-              <a:t>• Nine chapters: 1 Introduction, 2 Literature Review, 3 Data, 4 Methodology, 5 Pilot Study on MTSamples, 6 Selecting a Valid Judge, 7 Main Study on MIMIC-IV, 8 Discussion, 9 Conclusion; IEEE references with DOIs; Appendices A to E (prompts, per-document results, worked examples, repository, threshold sweep)</a:t>
-            </a:r>
-          </a:p>
-          <a:p>
-            <a:pPr>
-              <a:spcAft>
-                <a:spcPts val="800"/>
-              </a:spcAft>
-            </a:pPr>
-            <a:r>
-              <a:rPr sz="1600"/>
-              <a:t>• Since the September 4 draft: judge selection study, MedNLI adaptation, main study on MIMIC-IV with a local model (citations, coverage against the clinician's instructions, citation accuracy, ablations), question-answering pilot</a:t>
-            </a:r>
-          </a:p>
-          <a:p>
-            <a:pPr>
-              <a:spcAft>
-                <a:spcPts val="800"/>
-              </a:spcAft>
-            </a:pPr>
-            <a:r>
-              <a:rPr sz="1600"/>
-              <a:t>• Open items: committee composition to be confirmed with the advisor; advisor review of the draft; final title on the ETD planning form (with or without 'and Question Answering')</a:t>
-            </a:r>
-          </a:p>
-          <a:p>
-            <a:pPr>
-              <a:spcAft>
-                <a:spcPts val="800"/>
-              </a:spcAft>
-            </a:pPr>
-            <a:r>
-              <a:rPr sz="1600"/>
-              <a:t>• Every table and figure is regenerated by one command from the result files</a:t>
+            <a:r>
+              <a:rPr sz="1200"/>
+              <a:t>Paired two-sided Wilcoxon tests on the same documents. The main-study judge is DeBERTa-v3-large NLI selected against 1,781 expert-annotated sentences; the second judge is Bespoke-MiniCheck-7B.</a:t>
             </a:r>
           </a:p>
         </p:txBody>
@@ -6190,271 +6387,21 @@
           <a:p>
             <a:r>
               <a:rPr sz="2800" b="1"/>
-              <a:t>Plan to the defense (aligned with CSUN ETD deadlines)</a:t>
+              <a:t>Thesis writing status</a:t>
             </a:r>
           </a:p>
         </p:txBody>
       </p:sp>
-      <p:graphicFrame>
-        <p:nvGraphicFramePr>
-          <p:cNvPr id="3" name="Table 2"/>
-          <p:cNvGraphicFramePr>
-            <a:graphicFrameLocks noGrp="1"/>
-          </p:cNvGraphicFramePr>
-          <p:nvPr/>
-        </p:nvGraphicFramePr>
-        <p:xfrm>
-          <a:off x="365760" y="1097280"/>
-          <a:ext cx="11429999" cy="2926080"/>
-        </p:xfrm>
-        <a:graphic>
-          <a:graphicData uri="http://schemas.openxmlformats.org/drawingml/2006/table">
-            <a:tbl>
-              <a:tblPr firstRow="1" bandRow="1">
-                <a:tableStyleId>{5C22544A-7EE6-4342-B048-85BDC9FD1C3A}</a:tableStyleId>
-              </a:tblPr>
-              <a:tblGrid>
-                <a:gridCol w="2267107"/>
-                <a:gridCol w="9162892"/>
-              </a:tblGrid>
-              <a:tr h="365760">
-                <a:tc>
-                  <a:txBody>
-                    <a:bodyPr/>
-                    <a:lstStyle/>
-                    <a:p>
-                      <a:r>
-                        <a:rPr sz="1100" b="1"/>
-                        <a:t>By</a:t>
-                      </a:r>
-                    </a:p>
-                  </a:txBody>
-                  <a:tcPr/>
-                </a:tc>
-                <a:tc>
-                  <a:txBody>
-                    <a:bodyPr/>
-                    <a:lstStyle/>
-                    <a:p>
-                      <a:r>
-                        <a:rPr sz="1100" b="1"/>
-                        <a:t>Milestone</a:t>
-                      </a:r>
-                    </a:p>
-                  </a:txBody>
-                  <a:tcPr/>
-                </a:tc>
-              </a:tr>
-              <a:tr h="365760">
-                <a:tc>
-                  <a:txBody>
-                    <a:bodyPr/>
-                    <a:lstStyle/>
-                    <a:p>
-                      <a:r>
-                        <a:rPr sz="1000" b="0"/>
-                        <a:t>Sep 22, 2026</a:t>
-                      </a:r>
-                    </a:p>
-                  </a:txBody>
-                  <a:tcPr/>
-                </a:tc>
-                <a:tc>
-                  <a:txBody>
-                    <a:bodyPr/>
-                    <a:lstStyle/>
-                    <a:p>
-                      <a:r>
-                        <a:rPr sz="1000" b="0"/>
-                        <a:t>Advisor review of the complete draft; committee composition discussed</a:t>
-                      </a:r>
-                    </a:p>
-                  </a:txBody>
-                  <a:tcPr/>
-                </a:tc>
-              </a:tr>
-              <a:tr h="365760">
-                <a:tc>
-                  <a:txBody>
-                    <a:bodyPr/>
-                    <a:lstStyle/>
-                    <a:p>
-                      <a:r>
-                        <a:rPr sz="1000" b="0"/>
-                        <a:t>Oct 9, 2026</a:t>
-                      </a:r>
-                    </a:p>
-                  </a:txBody>
-                  <a:tcPr/>
-                </a:tc>
-                <a:tc>
-                  <a:txBody>
-                    <a:bodyPr/>
-                    <a:lstStyle/>
-                    <a:p>
-                      <a:r>
-                        <a:rPr sz="1000" b="0"/>
-                        <a:t>ETD Planning Form filed (title and committee)</a:t>
-                      </a:r>
-                    </a:p>
-                  </a:txBody>
-                  <a:tcPr/>
-                </a:tc>
-              </a:tr>
-              <a:tr h="365760">
-                <a:tc>
-                  <a:txBody>
-                    <a:bodyPr/>
-                    <a:lstStyle/>
-                    <a:p>
-                      <a:r>
-                        <a:rPr sz="1000" b="0"/>
-                        <a:t>Oct 16, 2026</a:t>
-                      </a:r>
-                    </a:p>
-                  </a:txBody>
-                  <a:tcPr/>
-                </a:tc>
-                <a:tc>
-                  <a:txBody>
-                    <a:bodyPr/>
-                    <a:lstStyle/>
-                    <a:p>
-                      <a:r>
-                        <a:rPr sz="1000" b="0"/>
-                        <a:t>Revised draft to advisor for approval; Canvas upload and Turnitin check after approval</a:t>
-                      </a:r>
-                    </a:p>
-                  </a:txBody>
-                  <a:tcPr/>
-                </a:tc>
-              </a:tr>
-              <a:tr h="365760">
-                <a:tc>
-                  <a:txBody>
-                    <a:bodyPr/>
-                    <a:lstStyle/>
-                    <a:p>
-                      <a:r>
-                        <a:rPr sz="1000" b="0"/>
-                        <a:t>Oct 23, 2026</a:t>
-                      </a:r>
-                    </a:p>
-                  </a:txBody>
-                  <a:tcPr/>
-                </a:tc>
-                <a:tc>
-                  <a:txBody>
-                    <a:bodyPr/>
-                    <a:lstStyle/>
-                    <a:p>
-                      <a:r>
-                        <a:rPr sz="1000" b="0"/>
-                        <a:t>Draft to committee (two-week review); Doodle poll with 1-hour slots over 3 to 4 weeks</a:t>
-                      </a:r>
-                    </a:p>
-                  </a:txBody>
-                  <a:tcPr/>
-                </a:tc>
-              </a:tr>
-              <a:tr h="365760">
-                <a:tc>
-                  <a:txBody>
-                    <a:bodyPr/>
-                    <a:lstStyle/>
-                    <a:p>
-                      <a:r>
-                        <a:rPr sz="1000" b="0"/>
-                        <a:t>Nov 6, 2026</a:t>
-                      </a:r>
-                    </a:p>
-                  </a:txBody>
-                  <a:tcPr/>
-                </a:tc>
-                <a:tc>
-                  <a:txBody>
-                    <a:bodyPr/>
-                    <a:lstStyle/>
-                    <a:p>
-                      <a:r>
-                        <a:rPr sz="1000" b="0"/>
-                        <a:t>ETD preliminary format review</a:t>
-                      </a:r>
-                    </a:p>
-                  </a:txBody>
-                  <a:tcPr/>
-                </a:tc>
-              </a:tr>
-              <a:tr h="365760">
-                <a:tc>
-                  <a:txBody>
-                    <a:bodyPr/>
-                    <a:lstStyle/>
-                    <a:p>
-                      <a:r>
-                        <a:rPr sz="1000" b="0"/>
-                        <a:t>Nov 16 to 24, 2026</a:t>
-                      </a:r>
-                    </a:p>
-                  </a:txBody>
-                  <a:tcPr/>
-                </a:tc>
-                <a:tc>
-                  <a:txBody>
-                    <a:bodyPr/>
-                    <a:lstStyle/>
-                    <a:p>
-                      <a:r>
-                        <a:rPr sz="1000" b="0"/>
-                        <a:t>Defense (40 min presentation, 10 min Q&amp;A); slides to advisor one week before</a:t>
-                      </a:r>
-                    </a:p>
-                  </a:txBody>
-                  <a:tcPr/>
-                </a:tc>
-              </a:tr>
-              <a:tr h="365760">
-                <a:tc>
-                  <a:txBody>
-                    <a:bodyPr/>
-                    <a:lstStyle/>
-                    <a:p>
-                      <a:r>
-                        <a:rPr sz="1000" b="0"/>
-                        <a:t>Dec 4, 2026</a:t>
-                      </a:r>
-                    </a:p>
-                  </a:txBody>
-                  <a:tcPr/>
-                </a:tc>
-                <a:tc>
-                  <a:txBody>
-                    <a:bodyPr/>
-                    <a:lstStyle/>
-                    <a:p>
-                      <a:r>
-                        <a:rPr sz="1000" b="0"/>
-                        <a:t>Final ETD upload after revisions</a:t>
-                      </a:r>
-                    </a:p>
-                  </a:txBody>
-                  <a:tcPr/>
-                </a:tc>
-              </a:tr>
-            </a:tbl>
-          </a:graphicData>
-        </a:graphic>
-      </p:graphicFrame>
       <p:sp>
         <p:nvSpPr>
-          <p:cNvPr id="4" name="TextBox 3"/>
+          <p:cNvPr id="3" name="TextBox 2"/>
           <p:cNvSpPr txBox="1"/>
           <p:nvPr/>
         </p:nvSpPr>
         <p:spPr>
           <a:xfrm>
-            <a:off x="365760" y="5943600"/>
-            <a:ext cx="11430000" cy="731520"/>
+            <a:off x="457200" y="1097280"/>
+            <a:ext cx="11247120" cy="5303520"/>
           </a:xfrm>
           <a:prstGeom prst="rect">
             <a:avLst/>
@@ -6467,9 +6414,58 @@
           </a:bodyPr>
           <a:lstStyle/>
           <a:p>
-            <a:r>
-              <a:rPr sz="1200"/>
-              <a:t>The December 12 defense date in the May report is after the December 4 ETD deadline and has been moved.</a:t>
+            <a:pPr>
+              <a:spcAft>
+                <a:spcPts val="800"/>
+              </a:spcAft>
+            </a:pPr>
+            <a:r>
+              <a:rPr sz="1600"/>
+              <a:t>• Complete second draft generated from the result files: 136 pages in CSUN format (1-inch margins, 12-pt Times New Roman, double-spaced, roman-numbered preliminary pages, arabic body); signature page with the full committee</a:t>
+            </a:r>
+          </a:p>
+          <a:p>
+            <a:pPr>
+              <a:spcAft>
+                <a:spcPts val="800"/>
+              </a:spcAft>
+            </a:pPr>
+            <a:r>
+              <a:rPr sz="1600"/>
+              <a:t>• Nine chapters: 1 Introduction, 2 Literature Review, 3 Data, 4 Methodology, 5 Pilot Study on MTSamples, 6 Selecting a Valid Judge, 7 Main Study on MIMIC-IV, 8 Discussion, 9 Conclusion; IEEE references with DOIs; Appendices A to E (prompts, per-document results, worked examples, repository, threshold sweep)</a:t>
+            </a:r>
+          </a:p>
+          <a:p>
+            <a:pPr>
+              <a:spcAft>
+                <a:spcPts val="800"/>
+              </a:spcAft>
+            </a:pPr>
+            <a:r>
+              <a:rPr sz="1600"/>
+              <a:t>• Project status: all experiments promised in the proposal are complete (judge validation and selection, five conditions on MTSamples and on 110 MIMIC-IV hospital courses, coverage against the clinician's instructions, citation accuracy, six retrieval ablations, question-answering pilot), plus a second-judge robustness check on all 6,588 main-study claims</a:t>
+            </a:r>
+          </a:p>
+          <a:p>
+            <a:pPr>
+              <a:spcAft>
+                <a:spcPts val="800"/>
+              </a:spcAft>
+            </a:pPr>
+            <a:r>
+              <a:rPr sz="1600"/>
+              <a:t>• Administrative status: committee confirmed (Dr. Wang, chair; Dr. Ebrahimi; Dr. McIlhenny); ETD planning form submitted</a:t>
+            </a:r>
+          </a:p>
+          <a:p>
+            <a:pPr>
+              <a:spcAft>
+                <a:spcPts val="800"/>
+              </a:spcAft>
+            </a:pPr>
+            <a:r>
+              <a:rPr sz="1600"/>
+              <a:t>• Every table and figure is regenerated by one command from the result files</a:t>
             </a:r>
           </a:p>
         </p:txBody>
@@ -6516,7 +6512,7 @@
           <a:p>
             <a:r>
               <a:rPr sz="2800" b="1"/>
-              <a:t>Risks and requests</a:t>
+              <a:t>Revisions in the second draft</a:t>
             </a:r>
           </a:p>
         </p:txBody>
@@ -6550,7 +6546,7 @@
             </a:pPr>
             <a:r>
               <a:rPr sz="1600"/>
-              <a:t>• Judge validity: the selected judge agrees with experts moderately (kappa 0.33); main-study rates are reported with this error profile, and conclusions rest on paired comparisons</a:t>
+              <a:t>• Committee members added to the signature page; acknowledgments rewritten</a:t>
             </a:r>
           </a:p>
           <a:p>
@@ -6561,7 +6557,7 @@
             </a:pPr>
             <a:r>
               <a:rPr sz="1600"/>
-              <a:t>• Generator difference: the pilot used GPT-4o-mini on public notes and the main study a 7-billion-parameter local model on MIMIC-IV, so the two studies are compared qualitatively</a:t>
+              <a:t>• Statistics corrected: the retrieval-ablation effects on faithfulness are now reported with Holm-adjusted p-values and do not survive the correction (coverage effects do); the pilot's Holm family is described correctly as all twenty pairwise tests</a:t>
             </a:r>
           </a:p>
           <a:p>
@@ -6572,7 +6568,7 @@
             </a:pPr>
             <a:r>
               <a:rPr sz="1600"/>
-              <a:t>• Schedule: advisor approval, Turnitin and two weeks of committee review must all precede the November 6 format review</a:t>
+              <a:t>• Hypotheses H1 to H3 answered across both studies in Chapter 8; paired tests added under the second judge (verification best under that judge, p &lt; 0.001)</a:t>
             </a:r>
           </a:p>
           <a:p>
@@ -6583,7 +6579,344 @@
             </a:pPr>
             <a:r>
               <a:rPr sz="1600"/>
-              <a:t>• Requests to the advisor: review the complete draft, confirm the committee, and decide the final title for the ETD planning form</a:t>
+              <a:t>• Literature review extended with grounding-specific checkers (MiniCheck), evidence on unreliable factuality metrics (Godbole and Jia 2025; FaithBench 2025) and clinical fact verification at scale (VeriFact 2026)</a:t>
+            </a:r>
+          </a:p>
+          <a:p>
+            <a:pPr>
+              <a:spcAft>
+                <a:spcPts val="800"/>
+              </a:spcAft>
+            </a:pPr>
+            <a:r>
+              <a:rPr sz="1600"/>
+              <a:t>• Consistency pass: Chapters 1 to 4 brought in line with the main study (scope, data sources, methodology overview, section numbering), the comparison of approaches in Section 8.4 rewritten for both studies, spelling and figure captions corrected</a:t>
+            </a:r>
+          </a:p>
+        </p:txBody>
+      </p:sp>
+    </p:spTree>
+  </p:cSld>
+  <p:clrMapOvr>
+    <a:masterClrMapping/>
+  </p:clrMapOvr>
+</p:sld>
+</file>
+
+<file path=ppt/slides/slide19.xml><?xml version="1.0" encoding="utf-8"?>
+<p:sld xmlns:a="http://schemas.openxmlformats.org/drawingml/2006/main" xmlns:p="http://schemas.openxmlformats.org/presentationml/2006/main" xmlns:r="http://schemas.openxmlformats.org/officeDocument/2006/relationships">
+  <p:cSld>
+    <p:spTree>
+      <p:nvGrpSpPr>
+        <p:cNvPr id="1" name=""/>
+        <p:cNvGrpSpPr/>
+        <p:nvPr/>
+      </p:nvGrpSpPr>
+      <p:grpSpPr/>
+      <p:sp>
+        <p:nvSpPr>
+          <p:cNvPr id="2" name="TextBox 1"/>
+          <p:cNvSpPr txBox="1"/>
+          <p:nvPr/>
+        </p:nvSpPr>
+        <p:spPr>
+          <a:xfrm>
+            <a:off x="365760" y="182880"/>
+            <a:ext cx="11430000" cy="822960"/>
+          </a:xfrm>
+          <a:prstGeom prst="rect">
+            <a:avLst/>
+          </a:prstGeom>
+          <a:noFill/>
+        </p:spPr>
+        <p:txBody>
+          <a:bodyPr wrap="square">
+            <a:spAutoFit/>
+          </a:bodyPr>
+          <a:lstStyle/>
+          <a:p>
+            <a:r>
+              <a:rPr sz="2800" b="1"/>
+              <a:t>Plan to the defense (aligned with CSUN ETD deadlines)</a:t>
+            </a:r>
+          </a:p>
+        </p:txBody>
+      </p:sp>
+      <p:graphicFrame>
+        <p:nvGraphicFramePr>
+          <p:cNvPr id="3" name="Table 2"/>
+          <p:cNvGraphicFramePr>
+            <a:graphicFrameLocks noGrp="1"/>
+          </p:cNvGraphicFramePr>
+          <p:nvPr/>
+        </p:nvGraphicFramePr>
+        <p:xfrm>
+          <a:off x="365760" y="1097280"/>
+          <a:ext cx="11429999" cy="2926080"/>
+        </p:xfrm>
+        <a:graphic>
+          <a:graphicData uri="http://schemas.openxmlformats.org/drawingml/2006/table">
+            <a:tbl>
+              <a:tblPr firstRow="1" bandRow="1">
+                <a:tableStyleId>{5C22544A-7EE6-4342-B048-85BDC9FD1C3A}</a:tableStyleId>
+              </a:tblPr>
+              <a:tblGrid>
+                <a:gridCol w="2456033"/>
+                <a:gridCol w="8973966"/>
+              </a:tblGrid>
+              <a:tr h="365760">
+                <a:tc>
+                  <a:txBody>
+                    <a:bodyPr/>
+                    <a:lstStyle/>
+                    <a:p>
+                      <a:r>
+                        <a:rPr sz="1100" b="1"/>
+                        <a:t>By</a:t>
+                      </a:r>
+                    </a:p>
+                  </a:txBody>
+                  <a:tcPr/>
+                </a:tc>
+                <a:tc>
+                  <a:txBody>
+                    <a:bodyPr/>
+                    <a:lstStyle/>
+                    <a:p>
+                      <a:r>
+                        <a:rPr sz="1100" b="1"/>
+                        <a:t>Milestone</a:t>
+                      </a:r>
+                    </a:p>
+                  </a:txBody>
+                  <a:tcPr/>
+                </a:tc>
+              </a:tr>
+              <a:tr h="365760">
+                <a:tc>
+                  <a:txBody>
+                    <a:bodyPr/>
+                    <a:lstStyle/>
+                    <a:p>
+                      <a:r>
+                        <a:rPr sz="1000" b="0"/>
+                        <a:t>Oct 9, 2026</a:t>
+                      </a:r>
+                    </a:p>
+                  </a:txBody>
+                  <a:tcPr/>
+                </a:tc>
+                <a:tc>
+                  <a:txBody>
+                    <a:bodyPr/>
+                    <a:lstStyle/>
+                    <a:p>
+                      <a:r>
+                        <a:rPr sz="1000" b="0"/>
+                        <a:t>ETD Planning Form submitted; committee confirmed (done)</a:t>
+                      </a:r>
+                    </a:p>
+                  </a:txBody>
+                  <a:tcPr/>
+                </a:tc>
+              </a:tr>
+              <a:tr h="365760">
+                <a:tc>
+                  <a:txBody>
+                    <a:bodyPr/>
+                    <a:lstStyle/>
+                    <a:p>
+                      <a:r>
+                        <a:rPr sz="1000" b="0"/>
+                        <a:t>Mid-October</a:t>
+                      </a:r>
+                    </a:p>
+                  </a:txBody>
+                  <a:tcPr/>
+                </a:tc>
+                <a:tc>
+                  <a:txBody>
+                    <a:bodyPr/>
+                    <a:lstStyle/>
+                    <a:p>
+                      <a:r>
+                        <a:rPr sz="1000" b="0"/>
+                        <a:t>Second draft and progress report submitted; advisor review of the second draft</a:t>
+                      </a:r>
+                    </a:p>
+                  </a:txBody>
+                  <a:tcPr/>
+                </a:tc>
+              </a:tr>
+              <a:tr h="365760">
+                <a:tc>
+                  <a:txBody>
+                    <a:bodyPr/>
+                    <a:lstStyle/>
+                    <a:p>
+                      <a:r>
+                        <a:rPr sz="1000" b="0"/>
+                        <a:t>Oct 23, 2026</a:t>
+                      </a:r>
+                    </a:p>
+                  </a:txBody>
+                  <a:tcPr/>
+                </a:tc>
+                <a:tc>
+                  <a:txBody>
+                    <a:bodyPr/>
+                    <a:lstStyle/>
+                    <a:p>
+                      <a:r>
+                        <a:rPr sz="1000" b="0"/>
+                        <a:t>Advisor approval; Canvas upload and Turnitin similarity check (20% or lower)</a:t>
+                      </a:r>
+                    </a:p>
+                  </a:txBody>
+                  <a:tcPr/>
+                </a:tc>
+              </a:tr>
+              <a:tr h="365760">
+                <a:tc>
+                  <a:txBody>
+                    <a:bodyPr/>
+                    <a:lstStyle/>
+                    <a:p>
+                      <a:r>
+                        <a:rPr sz="1000" b="0"/>
+                        <a:t>Oct 23 to Nov 6, 2026</a:t>
+                      </a:r>
+                    </a:p>
+                  </a:txBody>
+                  <a:tcPr/>
+                </a:tc>
+                <a:tc>
+                  <a:txBody>
+                    <a:bodyPr/>
+                    <a:lstStyle/>
+                    <a:p>
+                      <a:r>
+                        <a:rPr sz="1000" b="0"/>
+                        <a:t>Draft to committee (at least two weeks of review); Doodle poll with 1-hour slots over 3 to 4 weeks</a:t>
+                      </a:r>
+                    </a:p>
+                  </a:txBody>
+                  <a:tcPr/>
+                </a:tc>
+              </a:tr>
+              <a:tr h="365760">
+                <a:tc>
+                  <a:txBody>
+                    <a:bodyPr/>
+                    <a:lstStyle/>
+                    <a:p>
+                      <a:r>
+                        <a:rPr sz="1000" b="0"/>
+                        <a:t>Nov 6, 2026</a:t>
+                      </a:r>
+                    </a:p>
+                  </a:txBody>
+                  <a:tcPr/>
+                </a:tc>
+                <a:tc>
+                  <a:txBody>
+                    <a:bodyPr/>
+                    <a:lstStyle/>
+                    <a:p>
+                      <a:r>
+                        <a:rPr sz="1000" b="0"/>
+                        <a:t>ETD preliminary format review</a:t>
+                      </a:r>
+                    </a:p>
+                  </a:txBody>
+                  <a:tcPr/>
+                </a:tc>
+              </a:tr>
+              <a:tr h="365760">
+                <a:tc>
+                  <a:txBody>
+                    <a:bodyPr/>
+                    <a:lstStyle/>
+                    <a:p>
+                      <a:r>
+                        <a:rPr sz="1000" b="0"/>
+                        <a:t>Nov 16 to 24, 2026</a:t>
+                      </a:r>
+                    </a:p>
+                  </a:txBody>
+                  <a:tcPr/>
+                </a:tc>
+                <a:tc>
+                  <a:txBody>
+                    <a:bodyPr/>
+                    <a:lstStyle/>
+                    <a:p>
+                      <a:r>
+                        <a:rPr sz="1000" b="0"/>
+                        <a:t>Defense on CSUN Zoom (40 min presentation, 10 min Q&amp;A, 10 min deliberation); slides to advisor one week before</a:t>
+                      </a:r>
+                    </a:p>
+                  </a:txBody>
+                  <a:tcPr/>
+                </a:tc>
+              </a:tr>
+              <a:tr h="365760">
+                <a:tc>
+                  <a:txBody>
+                    <a:bodyPr/>
+                    <a:lstStyle/>
+                    <a:p>
+                      <a:r>
+                        <a:rPr sz="1000" b="0"/>
+                        <a:t>Dec 4, 2026</a:t>
+                      </a:r>
+                    </a:p>
+                  </a:txBody>
+                  <a:tcPr/>
+                </a:tc>
+                <a:tc>
+                  <a:txBody>
+                    <a:bodyPr/>
+                    <a:lstStyle/>
+                    <a:p>
+                      <a:r>
+                        <a:rPr sz="1000" b="0"/>
+                        <a:t>Final ETD upload after revisions; committee approval in the ETD system</a:t>
+                      </a:r>
+                    </a:p>
+                  </a:txBody>
+                  <a:tcPr/>
+                </a:tc>
+              </a:tr>
+            </a:tbl>
+          </a:graphicData>
+        </a:graphic>
+      </p:graphicFrame>
+      <p:sp>
+        <p:nvSpPr>
+          <p:cNvPr id="4" name="TextBox 3"/>
+          <p:cNvSpPr txBox="1"/>
+          <p:nvPr/>
+        </p:nvSpPr>
+        <p:spPr>
+          <a:xfrm>
+            <a:off x="365760" y="5943600"/>
+            <a:ext cx="11430000" cy="731520"/>
+          </a:xfrm>
+          <a:prstGeom prst="rect">
+            <a:avLst/>
+          </a:prstGeom>
+          <a:noFill/>
+        </p:spPr>
+        <p:txBody>
+          <a:bodyPr wrap="square">
+            <a:spAutoFit/>
+          </a:bodyPr>
+          <a:lstStyle/>
+          <a:p>
+            <a:r>
+              <a:rPr sz="1200"/>
+              <a:t>The defense is planned before the December 4 ETD deadline, as the committee approves the thesis inside the ETD system.</a:t>
             </a:r>
           </a:p>
         </p:txBody>
@@ -6720,6 +7053,120 @@
             <a:r>
               <a:rPr sz="1600"/>
               <a:t>• Three studies: pilot on public MTSamples notes with GPT-4o-mini; judge selection against expert labels; main study on MIMIC-IV hospital courses with a locally run open-weight model</a:t>
+            </a:r>
+          </a:p>
+        </p:txBody>
+      </p:sp>
+    </p:spTree>
+  </p:cSld>
+  <p:clrMapOvr>
+    <a:masterClrMapping/>
+  </p:clrMapOvr>
+</p:sld>
+</file>
+
+<file path=ppt/slides/slide20.xml><?xml version="1.0" encoding="utf-8"?>
+<p:sld xmlns:a="http://schemas.openxmlformats.org/drawingml/2006/main" xmlns:p="http://schemas.openxmlformats.org/presentationml/2006/main" xmlns:r="http://schemas.openxmlformats.org/officeDocument/2006/relationships">
+  <p:cSld>
+    <p:spTree>
+      <p:nvGrpSpPr>
+        <p:cNvPr id="1" name=""/>
+        <p:cNvGrpSpPr/>
+        <p:nvPr/>
+      </p:nvGrpSpPr>
+      <p:grpSpPr/>
+      <p:sp>
+        <p:nvSpPr>
+          <p:cNvPr id="2" name="TextBox 1"/>
+          <p:cNvSpPr txBox="1"/>
+          <p:nvPr/>
+        </p:nvSpPr>
+        <p:spPr>
+          <a:xfrm>
+            <a:off x="365760" y="182880"/>
+            <a:ext cx="11430000" cy="822960"/>
+          </a:xfrm>
+          <a:prstGeom prst="rect">
+            <a:avLst/>
+          </a:prstGeom>
+          <a:noFill/>
+        </p:spPr>
+        <p:txBody>
+          <a:bodyPr wrap="square">
+            <a:spAutoFit/>
+          </a:bodyPr>
+          <a:lstStyle/>
+          <a:p>
+            <a:r>
+              <a:rPr sz="2800" b="1"/>
+              <a:t>Risks and requests</a:t>
+            </a:r>
+          </a:p>
+        </p:txBody>
+      </p:sp>
+      <p:sp>
+        <p:nvSpPr>
+          <p:cNvPr id="3" name="TextBox 2"/>
+          <p:cNvSpPr txBox="1"/>
+          <p:nvPr/>
+        </p:nvSpPr>
+        <p:spPr>
+          <a:xfrm>
+            <a:off x="457200" y="1097280"/>
+            <a:ext cx="11247120" cy="5303520"/>
+          </a:xfrm>
+          <a:prstGeom prst="rect">
+            <a:avLst/>
+          </a:prstGeom>
+          <a:noFill/>
+        </p:spPr>
+        <p:txBody>
+          <a:bodyPr wrap="square">
+            <a:spAutoFit/>
+          </a:bodyPr>
+          <a:lstStyle/>
+          <a:p>
+            <a:pPr>
+              <a:spcAft>
+                <a:spcPts val="800"/>
+              </a:spcAft>
+            </a:pPr>
+            <a:r>
+              <a:rPr sz="1600"/>
+              <a:t>• Judge validity: the selected judge agrees with experts moderately (kappa 0.33); main-study rates are reported with this error profile and bounded by a second judge, and conclusions rest on paired comparisons</a:t>
+            </a:r>
+          </a:p>
+          <a:p>
+            <a:pPr>
+              <a:spcAft>
+                <a:spcPts val="800"/>
+              </a:spcAft>
+            </a:pPr>
+            <a:r>
+              <a:rPr sz="1600"/>
+              <a:t>• Generator difference: the pilot used GPT-4o-mini on public notes and the main study a 7-billion-parameter local model on MIMIC-IV, so the two studies are compared qualitatively</a:t>
+            </a:r>
+          </a:p>
+          <a:p>
+            <a:pPr>
+              <a:spcAft>
+                <a:spcPts val="800"/>
+              </a:spcAft>
+            </a:pPr>
+            <a:r>
+              <a:rPr sz="1600"/>
+              <a:t>• Schedule: advisor approval, the Turnitin check and two weeks of committee review must all precede the November 6 format review</a:t>
+            </a:r>
+          </a:p>
+          <a:p>
+            <a:pPr>
+              <a:spcAft>
+                <a:spcPts val="800"/>
+              </a:spcAft>
+            </a:pPr>
+            <a:r>
+              <a:rPr sz="1600"/>
+              <a:t>• Requests to the advisor: review the second draft and approve it for distribution to the committee; advise on the defense window</a:t>
             </a:r>
           </a:p>
         </p:txBody>
@@ -9110,7 +9557,7 @@
                     <a:p>
                       <a:r>
                         <a:rPr sz="1000" b="0"/>
-                        <a:t>Bespoke-MiniCheck-7B (LLM checker)</a:t>
+                        <a:t>Bespoke-MiniCheck-7B</a:t>
                       </a:r>
                     </a:p>
                   </a:txBody>
@@ -9203,7 +9650,7 @@
                     <a:p>
                       <a:r>
                         <a:rPr sz="1000" b="0"/>
-                        <a:t>Bespoke-MiniCheck-7B (LLM checker)</a:t>
+                        <a:t>Bespoke-MiniCheck-7B</a:t>
                       </a:r>
                     </a:p>
                   </a:txBody>

</xml_diff>

<commit_message>
List McIlhenny first among the committee members
</commit_message>
<xml_diff>
--- a/deliverables/Progress_Slides_Fall2026.pptx
+++ b/deliverables/Progress_Slides_Fall2026.pptx
@@ -3149,7 +3149,7 @@
           <a:p>
             <a:r>
               <a:rPr sz="1800"/>
-              <a:t>Committee: Dr. Taehyung (George) Wang (chair), Dr. Mahdi Ebrahimi, Dr. Robert McIlhenny</a:t>
+              <a:t>Committee: Dr. Taehyung (George) Wang (chair), Dr. Robert McIlhenny, Dr. Mahdi Ebrahimi</a:t>
             </a:r>
           </a:p>
           <a:p>
@@ -6454,7 +6454,7 @@
             </a:pPr>
             <a:r>
               <a:rPr sz="1600"/>
-              <a:t>• Administrative status: committee confirmed (Dr. Wang, chair; Dr. Ebrahimi; Dr. McIlhenny); ETD planning form submitted</a:t>
+              <a:t>• Administrative status: committee confirmed (Dr. Wang, chair; Dr. McIlhenny; Dr. Ebrahimi); ETD planning form submitted</a:t>
             </a:r>
           </a:p>
           <a:p>

</xml_diff>

<commit_message>
Rebuild the progress slides and the source code and data description from the corrected results
</commit_message>
<xml_diff>
--- a/deliverables/Progress_Slides_Fall2026.pptx
+++ b/deliverables/Progress_Slides_Fall2026.pptx
@@ -3155,7 +3155,7 @@
           <a:p>
             <a:r>
               <a:rPr sz="1800"/>
-              <a:t>California State University, Northridge, October 12, 2026</a:t>
+              <a:t>California State University, Northridge, October 16, 2026</a:t>
             </a:r>
           </a:p>
         </p:txBody>
@@ -3391,7 +3391,7 @@
                     <a:p>
                       <a:r>
                         <a:rPr sz="1100" b="1"/>
-                        <a:t>E0 zero-context</a:t>
+                        <a:t>E0 full-note</a:t>
                       </a:r>
                     </a:p>
                   </a:txBody>
@@ -3484,59 +3484,59 @@
                     <a:p>
                       <a:r>
                         <a:rPr sz="1000" b="0"/>
-                        <a:t>0.135</a:t>
-                      </a:r>
-                    </a:p>
-                  </a:txBody>
-                  <a:tcPr/>
-                </a:tc>
-                <a:tc>
-                  <a:txBody>
-                    <a:bodyPr/>
-                    <a:lstStyle/>
-                    <a:p>
-                      <a:r>
-                        <a:rPr sz="1000" b="0"/>
-                        <a:t>0.066</a:t>
-                      </a:r>
-                    </a:p>
-                  </a:txBody>
-                  <a:tcPr/>
-                </a:tc>
-                <a:tc>
-                  <a:txBody>
-                    <a:bodyPr/>
-                    <a:lstStyle/>
-                    <a:p>
-                      <a:r>
-                        <a:rPr sz="1000" b="0"/>
-                        <a:t>0.072</a:t>
-                      </a:r>
-                    </a:p>
-                  </a:txBody>
-                  <a:tcPr/>
-                </a:tc>
-                <a:tc>
-                  <a:txBody>
-                    <a:bodyPr/>
-                    <a:lstStyle/>
-                    <a:p>
-                      <a:r>
-                        <a:rPr sz="1000" b="0"/>
-                        <a:t>0.070</a:t>
-                      </a:r>
-                    </a:p>
-                  </a:txBody>
-                  <a:tcPr/>
-                </a:tc>
-                <a:tc>
-                  <a:txBody>
-                    <a:bodyPr/>
-                    <a:lstStyle/>
-                    <a:p>
-                      <a:r>
-                        <a:rPr sz="1000" b="0"/>
-                        <a:t>0.056</a:t>
+                        <a:t>0.137</a:t>
+                      </a:r>
+                    </a:p>
+                  </a:txBody>
+                  <a:tcPr/>
+                </a:tc>
+                <a:tc>
+                  <a:txBody>
+                    <a:bodyPr/>
+                    <a:lstStyle/>
+                    <a:p>
+                      <a:r>
+                        <a:rPr sz="1000" b="0"/>
+                        <a:t>0.075</a:t>
+                      </a:r>
+                    </a:p>
+                  </a:txBody>
+                  <a:tcPr/>
+                </a:tc>
+                <a:tc>
+                  <a:txBody>
+                    <a:bodyPr/>
+                    <a:lstStyle/>
+                    <a:p>
+                      <a:r>
+                        <a:rPr sz="1000" b="0"/>
+                        <a:t>0.073</a:t>
+                      </a:r>
+                    </a:p>
+                  </a:txBody>
+                  <a:tcPr/>
+                </a:tc>
+                <a:tc>
+                  <a:txBody>
+                    <a:bodyPr/>
+                    <a:lstStyle/>
+                    <a:p>
+                      <a:r>
+                        <a:rPr sz="1000" b="0"/>
+                        <a:t>0.068</a:t>
+                      </a:r>
+                    </a:p>
+                  </a:txBody>
+                  <a:tcPr/>
+                </a:tc>
+                <a:tc>
+                  <a:txBody>
+                    <a:bodyPr/>
+                    <a:lstStyle/>
+                    <a:p>
+                      <a:r>
+                        <a:rPr sz="1000" b="0"/>
+                        <a:t>0.058</a:t>
                       </a:r>
                     </a:p>
                   </a:txBody>
@@ -3577,32 +3577,6 @@
                     <a:p>
                       <a:r>
                         <a:rPr sz="1000" b="0"/>
-                        <a:t>0.029</a:t>
-                      </a:r>
-                    </a:p>
-                  </a:txBody>
-                  <a:tcPr/>
-                </a:tc>
-                <a:tc>
-                  <a:txBody>
-                    <a:bodyPr/>
-                    <a:lstStyle/>
-                    <a:p>
-                      <a:r>
-                        <a:rPr sz="1000" b="0"/>
-                        <a:t>0.027</a:t>
-                      </a:r>
-                    </a:p>
-                  </a:txBody>
-                  <a:tcPr/>
-                </a:tc>
-                <a:tc>
-                  <a:txBody>
-                    <a:bodyPr/>
-                    <a:lstStyle/>
-                    <a:p>
-                      <a:r>
-                        <a:rPr sz="1000" b="0"/>
                         <a:t>0.031</a:t>
                       </a:r>
                     </a:p>
@@ -3616,6 +3590,19 @@
                     <a:p>
                       <a:r>
                         <a:rPr sz="1000" b="0"/>
+                        <a:t>0.030</a:t>
+                      </a:r>
+                    </a:p>
+                  </a:txBody>
+                  <a:tcPr/>
+                </a:tc>
+                <a:tc>
+                  <a:txBody>
+                    <a:bodyPr/>
+                    <a:lstStyle/>
+                    <a:p>
+                      <a:r>
+                        <a:rPr sz="1000" b="0"/>
                         <a:t>0.032</a:t>
                       </a:r>
                     </a:p>
@@ -3629,7 +3616,20 @@
                     <a:p>
                       <a:r>
                         <a:rPr sz="1000" b="0"/>
-                        <a:t>0.051</a:t>
+                        <a:t>0.031</a:t>
+                      </a:r>
+                    </a:p>
+                  </a:txBody>
+                  <a:tcPr/>
+                </a:tc>
+                <a:tc>
+                  <a:txBody>
+                    <a:bodyPr/>
+                    <a:lstStyle/>
+                    <a:p>
+                      <a:r>
+                        <a:rPr sz="1000" b="0"/>
+                        <a:t>0.053</a:t>
                       </a:r>
                     </a:p>
                   </a:txBody>
@@ -3776,20 +3776,20 @@
                     <a:p>
                       <a:r>
                         <a:rPr sz="1000" b="0"/>
-                        <a:t>71.8%</a:t>
-                      </a:r>
-                    </a:p>
-                  </a:txBody>
-                  <a:tcPr/>
-                </a:tc>
-                <a:tc>
-                  <a:txBody>
-                    <a:bodyPr/>
-                    <a:lstStyle/>
-                    <a:p>
-                      <a:r>
-                        <a:rPr sz="1000" b="0"/>
-                        <a:t>38.1%</a:t>
+                        <a:t>84.9%</a:t>
+                      </a:r>
+                    </a:p>
+                  </a:txBody>
+                  <a:tcPr/>
+                </a:tc>
+                <a:tc>
+                  <a:txBody>
+                    <a:bodyPr/>
+                    <a:lstStyle/>
+                    <a:p>
+                      <a:r>
+                        <a:rPr sz="1000" b="0"/>
+                        <a:t>54.8%</a:t>
                       </a:r>
                     </a:p>
                   </a:txBody>
@@ -4142,7 +4142,7 @@
           <a:p>
             <a:r>
               <a:rPr sz="1200"/>
-              <a:t>E1 vs E0: UFR p &lt; 0.001, CR p = 0.791, coverage p &lt; 0.001. E1b vs E0: UFR p &lt; 0.001, CR p = 0.305, coverage p = 0.449. E3 vs E0: UFR p &lt; 0.001, CR p = 0.358, coverage p &lt; 0.001. E2 vs E0: UFR p &lt; 0.001, CR p = 0.125, coverage p &lt; 0.001. Paired two-sided Wilcoxon tests on the same documents.</a:t>
+              <a:t>E1 vs E0: UFR p &lt; 0.001, CR p = 0.985, coverage p &lt; 0.001. E1b vs E0: UFR p &lt; 0.001, CR p = 0.462, coverage p = 0.449. E3 vs E0: UFR p &lt; 0.001, CR p = 0.878, coverage p &lt; 0.001. E2 vs E0: UFR p &lt; 0.001, CR p = 0.169, coverage p &lt; 0.001. Paired two-sided Wilcoxon tests on the same documents.</a:t>
             </a:r>
           </a:p>
         </p:txBody>
@@ -4211,7 +4211,7 @@
         <p:spPr>
           <a:xfrm>
             <a:off x="365760" y="1097280"/>
-            <a:ext cx="5577840" cy="2601014"/>
+            <a:ext cx="5577840" cy="2684646"/>
           </a:xfrm>
           <a:prstGeom prst="rect">
             <a:avLst/>
@@ -4318,7 +4318,7 @@
             </a:pPr>
             <a:r>
               <a:rPr sz="1600"/>
-              <a:t>• Every grounded condition cut the unsupported fact rate by about 46 percent versus zero-context (E1 0.066, E1b 0.072, E3 0.070 versus E0 0.135; all p &lt; 0.001); the three do not differ from one another; CR did not change</a:t>
+              <a:t>• Every grounded condition cut the unsupported fact rate by about 47 percent versus full-note (E1 0.075, E1b 0.073, E3 0.068 versus E0 0.137; all p &lt; 0.001); the three do not differ from one another; CR did not change</a:t>
             </a:r>
           </a:p>
           <a:p>
@@ -4340,7 +4340,7 @@
             </a:pPr>
             <a:r>
               <a:rPr sz="1600"/>
-              <a:t>• Verbatim extraction scores UFR 0.056: the judge's error floor; the grounded LLM conditions sit within a few hundredths of it</a:t>
+              <a:t>• Verbatim extraction scores UFR 0.058: judge error on text supported by construction, a reference rather than a floor; the grounded LLM conditions sit within a few hundredths of it</a:t>
             </a:r>
           </a:p>
           <a:p>
@@ -4362,7 +4362,7 @@
             </a:pPr>
             <a:r>
               <a:rPr sz="1600"/>
-              <a:t>• Citations: 72% accurate for excerpt-only RAG but 38% for RAG with the whole course; no retrieval setting changed faithfulness after correction for multiple comparisons (the largest effect, dropping the citation requirement, raised UFR by 0.030, p = 0.017 before correction); coverage followed the amount of retrieved text</a:t>
+              <a:t>• Citations: 85% accurate for excerpt-only RAG but 55% for RAG with the whole course; no retrieval setting changed faithfulness; coverage followed the amount of retrieved text</a:t>
             </a:r>
           </a:p>
           <a:p>
@@ -4384,7 +4384,7 @@
             </a:pPr>
             <a:r>
               <a:rPr sz="1600"/>
-              <a:t>• Second judge (Bespoke-MiniCheck-7B, a 7B LLM checker): same ordering of conditions; flags 0.2% of verbatim extracts, so the NLI judge's 0.056 floor is judge error; confirms 40% of the selected judge's flags; grounded conditions' unsupported share bounded between 0.008 and 0.185</a:t>
+              <a:t>• Second judge (Bespoke-MiniCheck-7B, a 7B LLM checker): same ordering of conditions; flags 0.4% of verbatim extracts, so the NLI judge's 0.058 on verbatim text is its own error; confirms 40% of the selected judge's flags; conservative (both judges) and inclusive (either judge) flagging rules give 0.008 to 0.194 for the grounded conditions, alternative estimates rather than bounds</a:t>
             </a:r>
           </a:p>
         </p:txBody>
@@ -4549,20 +4549,20 @@
                     <a:p>
                       <a:r>
                         <a:rPr sz="1000" b="0"/>
-                        <a:t>+0.009 (p = 0.485)</a:t>
-                      </a:r>
-                    </a:p>
-                  </a:txBody>
-                  <a:tcPr/>
-                </a:tc>
-                <a:tc>
-                  <a:txBody>
-                    <a:bodyPr/>
-                    <a:lstStyle/>
-                    <a:p>
-                      <a:r>
-                        <a:rPr sz="1000" b="0"/>
-                        <a:t>+0.020 (p = 0.045)</a:t>
+                        <a:t>+0.000 (p = 0.902)</a:t>
+                      </a:r>
+                    </a:p>
+                  </a:txBody>
+                  <a:tcPr/>
+                </a:tc>
+                <a:tc>
+                  <a:txBody>
+                    <a:bodyPr/>
+                    <a:lstStyle/>
+                    <a:p>
+                      <a:r>
+                        <a:rPr sz="1000" b="0"/>
+                        <a:t>+0.013 (p = 0.146)</a:t>
                       </a:r>
                     </a:p>
                   </a:txBody>
@@ -4588,7 +4588,7 @@
                     <a:p>
                       <a:r>
                         <a:rPr sz="1000" b="0"/>
-                        <a:t>+0.050 (p = 0.172)</a:t>
+                        <a:t>-0.020 (p = 0.880)</a:t>
                       </a:r>
                     </a:p>
                   </a:txBody>
@@ -4616,20 +4616,20 @@
                     <a:p>
                       <a:r>
                         <a:rPr sz="1000" b="0"/>
-                        <a:t>-0.003 (p = 0.834)</a:t>
-                      </a:r>
-                    </a:p>
-                  </a:txBody>
-                  <a:tcPr/>
-                </a:tc>
-                <a:tc>
-                  <a:txBody>
-                    <a:bodyPr/>
-                    <a:lstStyle/>
-                    <a:p>
-                      <a:r>
-                        <a:rPr sz="1000" b="0"/>
-                        <a:t>-0.005 (p = 0.308)</a:t>
+                        <a:t>-0.007 (p = 0.572)</a:t>
+                      </a:r>
+                    </a:p>
+                  </a:txBody>
+                  <a:tcPr/>
+                </a:tc>
+                <a:tc>
+                  <a:txBody>
+                    <a:bodyPr/>
+                    <a:lstStyle/>
+                    <a:p>
+                      <a:r>
+                        <a:rPr sz="1000" b="0"/>
+                        <a:t>-0.005 (p = 0.265)</a:t>
                       </a:r>
                     </a:p>
                   </a:txBody>
@@ -4655,7 +4655,7 @@
                     <a:p>
                       <a:r>
                         <a:rPr sz="1000" b="0"/>
-                        <a:t>+0.012 (p = 0.492)</a:t>
+                        <a:t>-0.009 (p = 0.936)</a:t>
                       </a:r>
                     </a:p>
                   </a:txBody>
@@ -4683,20 +4683,20 @@
                     <a:p>
                       <a:r>
                         <a:rPr sz="1000" b="0"/>
-                        <a:t>+0.018 (p = 0.427)</a:t>
-                      </a:r>
-                    </a:p>
-                  </a:txBody>
-                  <a:tcPr/>
-                </a:tc>
-                <a:tc>
-                  <a:txBody>
-                    <a:bodyPr/>
-                    <a:lstStyle/>
-                    <a:p>
-                      <a:r>
-                        <a:rPr sz="1000" b="0"/>
-                        <a:t>+0.017 (p = 0.094)</a:t>
+                        <a:t>+0.013 (p = 0.471)</a:t>
+                      </a:r>
+                    </a:p>
+                  </a:txBody>
+                  <a:tcPr/>
+                </a:tc>
+                <a:tc>
+                  <a:txBody>
+                    <a:bodyPr/>
+                    <a:lstStyle/>
+                    <a:p>
+                      <a:r>
+                        <a:rPr sz="1000" b="0"/>
+                        <a:t>+0.013 (p = 0.108)</a:t>
                       </a:r>
                     </a:p>
                   </a:txBody>
@@ -4722,7 +4722,7 @@
                     <a:p>
                       <a:r>
                         <a:rPr sz="1000" b="0"/>
-                        <a:t>+0.059 (p = 0.060)</a:t>
+                        <a:t>-0.004 (p = 0.699)</a:t>
                       </a:r>
                     </a:p>
                   </a:txBody>
@@ -4750,20 +4750,20 @@
                     <a:p>
                       <a:r>
                         <a:rPr sz="1000" b="0"/>
-                        <a:t>+0.009 (p = 0.493)</a:t>
-                      </a:r>
-                    </a:p>
-                  </a:txBody>
-                  <a:tcPr/>
-                </a:tc>
-                <a:tc>
-                  <a:txBody>
-                    <a:bodyPr/>
-                    <a:lstStyle/>
-                    <a:p>
-                      <a:r>
-                        <a:rPr sz="1000" b="0"/>
-                        <a:t>+0.000 (p = 0.838)</a:t>
+                        <a:t>+0.005 (p = 0.584)</a:t>
+                      </a:r>
+                    </a:p>
+                  </a:txBody>
+                  <a:tcPr/>
+                </a:tc>
+                <a:tc>
+                  <a:txBody>
+                    <a:bodyPr/>
+                    <a:lstStyle/>
+                    <a:p>
+                      <a:r>
+                        <a:rPr sz="1000" b="0"/>
+                        <a:t>-0.001 (p = 0.656)</a:t>
                       </a:r>
                     </a:p>
                   </a:txBody>
@@ -4789,7 +4789,7 @@
                     <a:p>
                       <a:r>
                         <a:rPr sz="1000" b="0"/>
-                        <a:t>-0.084 (p = 0.020)</a:t>
+                        <a:t>-0.032 (p = 0.184)</a:t>
                       </a:r>
                     </a:p>
                   </a:txBody>
@@ -4817,20 +4817,20 @@
                     <a:p>
                       <a:r>
                         <a:rPr sz="1000" b="0"/>
-                        <a:t>+0.007 (p = 0.596)</a:t>
-                      </a:r>
-                    </a:p>
-                  </a:txBody>
-                  <a:tcPr/>
-                </a:tc>
-                <a:tc>
-                  <a:txBody>
-                    <a:bodyPr/>
-                    <a:lstStyle/>
-                    <a:p>
-                      <a:r>
-                        <a:rPr sz="1000" b="0"/>
-                        <a:t>+0.007 (p = 0.687)</a:t>
+                        <a:t>-0.001 (p = 0.917)</a:t>
+                      </a:r>
+                    </a:p>
+                  </a:txBody>
+                  <a:tcPr/>
+                </a:tc>
+                <a:tc>
+                  <a:txBody>
+                    <a:bodyPr/>
+                    <a:lstStyle/>
+                    <a:p>
+                      <a:r>
+                        <a:rPr sz="1000" b="0"/>
+                        <a:t>+0.003 (p = 0.933)</a:t>
                       </a:r>
                     </a:p>
                   </a:txBody>
@@ -4856,7 +4856,7 @@
                     <a:p>
                       <a:r>
                         <a:rPr sz="1000" b="0"/>
-                        <a:t>+0.035 (p = 0.393)</a:t>
+                        <a:t>-0.002 (p = 0.767)</a:t>
                       </a:r>
                     </a:p>
                   </a:txBody>
@@ -4884,20 +4884,20 @@
                     <a:p>
                       <a:r>
                         <a:rPr sz="1000" b="0"/>
-                        <a:t>+0.030 (p = 0.017)</a:t>
-                      </a:r>
-                    </a:p>
-                  </a:txBody>
-                  <a:tcPr/>
-                </a:tc>
-                <a:tc>
-                  <a:txBody>
-                    <a:bodyPr/>
-                    <a:lstStyle/>
-                    <a:p>
-                      <a:r>
-                        <a:rPr sz="1000" b="0"/>
-                        <a:t>-0.007 (p = 0.178)</a:t>
+                        <a:t>+0.021 (p = 0.117)</a:t>
+                      </a:r>
+                    </a:p>
+                  </a:txBody>
+                  <a:tcPr/>
+                </a:tc>
+                <a:tc>
+                  <a:txBody>
+                    <a:bodyPr/>
+                    <a:lstStyle/>
+                    <a:p>
+                      <a:r>
+                        <a:rPr sz="1000" b="0"/>
+                        <a:t>-0.010 (p = 0.091)</a:t>
                       </a:r>
                     </a:p>
                   </a:txBody>
@@ -6184,7 +6184,7 @@
                     <a:p>
                       <a:r>
                         <a:rPr sz="1000" b="0"/>
-                        <a:t>UFR 0.135, 7.8 points above the judge's floor; judge kappa 0.33</a:t>
+                        <a:t>UFR 0.137 (judge-estimated; verbatim-extraction reference 0.058); judge kappa 0.33</a:t>
                       </a:r>
                     </a:p>
                   </a:txBody>
@@ -6238,7 +6238,7 @@
                     <a:p>
                       <a:r>
                         <a:rPr sz="1000" b="0"/>
-                        <a:t>UFR down 51 percent (p &lt; 0.001); CR unchanged (p = 0.791)</a:t>
+                        <a:t>UFR down 45 percent (p &lt; 0.001); CR unchanged (p = 0.985)</a:t>
                       </a:r>
                     </a:p>
                   </a:txBody>
@@ -6292,7 +6292,7 @@
                     <a:p>
                       <a:r>
                         <a:rPr sz="1000" b="0"/>
-                        <a:t>Selected judge: E3 = E1 (p = 0.651); second judge: 0.069 vs 0.134 (p &lt; 0.001)</a:t>
+                        <a:t>Selected judge: E3 = E1 (p = 0.212); second judge: 0.079 vs 0.135 (p &lt; 0.001)</a:t>
                       </a:r>
                     </a:p>
                   </a:txBody>
@@ -6421,7 +6421,7 @@
             </a:pPr>
             <a:r>
               <a:rPr sz="1600"/>
-              <a:t>• Complete second draft generated from the result files: 136 pages in CSUN format (1-inch margins, 12-pt Times New Roman, double-spaced, roman-numbered preliminary pages, arabic body); signature page with the full committee</a:t>
+              <a:t>• Complete second draft generated from the result files: 156 pages in CSUN format (1-inch margins, 12-pt Times New Roman, double-spaced, roman-numbered preliminary pages, arabic body); signature page with the full committee</a:t>
             </a:r>
           </a:p>
           <a:p>
@@ -7030,7 +7030,7 @@
             </a:pPr>
             <a:r>
               <a:rPr sz="1600"/>
-              <a:t>• RQ3: do retrieval-augmented generation and verification reduce unsupported and contradicted statements, compared with an extractive bound, and at what cost in coverage?</a:t>
+              <a:t>• RQ3: do retrieval-augmented generation and verification reduce unsupported and contradicted statements, compared with an extractive reference, and at what cost in coverage?</a:t>
             </a:r>
           </a:p>
           <a:p>
@@ -7133,7 +7133,7 @@
             </a:pPr>
             <a:r>
               <a:rPr sz="1600"/>
-              <a:t>• Judge validity: the selected judge agrees with experts moderately (kappa 0.33); main-study rates are reported with this error profile and bounded by a second judge, and conclusions rest on paired comparisons</a:t>
+              <a:t>• Judge validity: the selected judge agrees with experts moderately (kappa 0.33); main-study rates are judge-estimated and reported with this error profile, checked by a second judge and a manual audit, and conclusions rest on paired comparisons</a:t>
             </a:r>
           </a:p>
           <a:p>
@@ -7345,7 +7345,7 @@
                     <a:p>
                       <a:r>
                         <a:rPr sz="1000" b="0"/>
-                        <a:t>Done in both studies: E0 zero-context, E1 RAG (excerpts), E1b RAG (note + excerpts), E3 RAG + Chain-of-Verification, E2 extractive</a:t>
+                        <a:t>Done in both studies: E0 full-note, E1 RAG (excerpts), E1b RAG (note + excerpts), E3 RAG + Chain-of-Verification, E2 extractive</a:t>
                       </a:r>
                     </a:p>
                   </a:txBody>
@@ -7787,7 +7787,7 @@
                     <a:p>
                       <a:r>
                         <a:rPr sz="1100" b="1"/>
-                        <a:t>E0 zero-context</a:t>
+                        <a:t>E0 full-note</a:t>
                       </a:r>
                     </a:p>
                   </a:txBody>
@@ -8354,7 +8354,7 @@
           <a:p>
             <a:r>
               <a:rPr sz="1200"/>
-              <a:t>Paired Wilcoxon versus E0: E1 CR p = 0.011 (−24%), E1 UFR p = 0.977; E1b UFR p = 0.020; E3 UFR p &lt; 0.001 (−15%; versus E1 p &lt; 0.001), E3 CR p = 0.913; E2 UFR p &lt; 0.001. Verification lowers unsupported facts the most; retrieval alone lowers contradictions modestly; the extractive bound exposes a non-zero judge error floor. Header lines and abstentions excluded.</a:t>
+              <a:t>Paired Wilcoxon versus E0: E1 CR p = 0.011 (−24%), E1 UFR p = 0.977; E1b UFR p = 0.020; E3 UFR p &lt; 0.001 (−15%; versus E1 p &lt; 0.001), E3 CR p = 0.913; E2 UFR p &lt; 0.001. Verification lowers unsupported facts the most; retrieval alone lowers contradictions modestly; the extractive reference shows the judge errs even on verbatim text. Header lines and abstentions excluded.</a:t>
             </a:r>
           </a:p>
         </p:txBody>

</xml_diff>